<commit_message>
Fix slide layouts: add SFT/DM definitions, fix overlapping containers, improve writing flow
</commit_message>
<xml_diff>
--- a/paper/iclr2026/iclr2026_spotlight.pptx
+++ b/paper/iclr2026/iclr2026_spotlight.pptx
@@ -511,7 +511,7 @@
           <a:lstStyle/>
           <a:p>
             <a:r>
-              <a:t>[30 sec] Welcome. Today I'll present our work on how SFT transfers not just vocabulary but deep epistemic priors in language models.</a:t>
+              <a:t>[30 sec] Welcome. Today I will present our work on how supervised fine-tuning transfers not just vocabulary but deep epistemic priors.</a:t>
             </a:r>
           </a:p>
         </p:txBody>
@@ -581,7 +581,7 @@
           <a:lstStyle/>
           <a:p>
             <a:r>
-              <a:t>Leave up during Q&amp;A. Backup slides: full MMLU subtask breakdown, Corr2Cause template-level analysis, EconCausal regression patterns, training hyperparameters, dataset quality metrics.</a:t>
+              <a:t>Leave up during Q&amp;A. Backup slides: full MMLU breakdown, Corr2Cause template analysis, EconCausal patterns, training config.</a:t>
             </a:r>
           </a:p>
         </p:txBody>
@@ -651,7 +651,7 @@
           <a:lstStyle/>
           <a:p>
             <a:r>
-              <a:t>[45 sec] SFT is how we align models, but we don't understand what it transfers beyond the training domain. Prior work showed LLMs carry ideological priors from pretraining, but treated it as static. We asked: if we fine-tune on a specific analytical framework, does it shift reasoning in unseen domains? Transition: To answer this, we fine-tuned Qwen3.5-9B on Dialectical Materialist analysis.</a:t>
+              <a:t>[45 sec] LLMs are aligned in two stages. First, supervised fine-tuning -- we train on curated instruction-answer pairs. Then preference optimization -- DPO or RLHF -- further shapes responses. SFT is the most impactful step because it sets the reasoning baseline. But we do not understand what it transfers beyond the training domain. Transition: That is the question we investigate.</a:t>
             </a:r>
           </a:p>
         </p:txBody>
@@ -721,7 +721,7 @@
           <a:lstStyle/>
           <a:p>
             <a:r>
-              <a:t>[45 sec] We fine-tuned Qwen3.5-9B via QLoRA on 1,460 question-answer pairs generated by a 27B teacher using DM analysis prompts. We evaluated across three domains: general capability, formal causal logic, and applied economic causal reasoning. All in bf16 with 0-shot greedy decoding. Transition: Here is what we found, and it is surprising.</a:t>
+              <a:t>[45 sec] Prior work showed LLMs carry ideological priors from pretraining, but treated ideology as static. We asked a dynamic question: can targeted SFT shift a model's reasoning? We fine-tuned on Dialectical Materialism -- a Marxist analytical framework emphasizing structural conditions and skepticism of simple causal claims. Transition: Here is how we set up the experiment.</a:t>
             </a:r>
           </a:p>
         </p:txBody>
@@ -791,7 +791,7 @@
           <a:lstStyle/>
           <a:p>
             <a:r>
-              <a:t>[60 sec] Three outcomes. General capability preserved. Formal causal reasoning improves by 38 points. Applied economic causal reasoning regresses by 12 to 13.5 points, all highly significant. Transition: How can the same training improve one benchmark while breaking another? The answer is a single emergent artifact.</a:t>
+              <a:t>[45 sec] We fine-tuned Qwen3.5-9B using quantized LoRA on 1,460 question-answer pairs generated by a 27B teacher with DM analysis prompts. Evaluated across three domains: general capability, formal causal logic, and applied economic causal reasoning. All in bfloat16 with 0-shot greedy decoding.</a:t>
             </a:r>
           </a:p>
         </p:txBody>
@@ -861,7 +861,7 @@
           <a:lstStyle/>
           <a:p>
             <a:r>
-              <a:t>[60 sec] The dominant regression pattern is positive-to-mixed hedging. The model takes correct positive causal predictions and converts them to ambiguous mixed answers. On Task1 Econ, 52.7% of all regressions. This hedging is ABSENT from the training data. The teacher hedges only 4% of the time. It is an emergent artifact. The model learned DM skepticism and applies it universally. Transition: This explains why Corr2Cause improves while EconCausal regresses.</a:t>
+              <a:t>[60 sec] Three outcomes. General capability preserved. Formal causal reasoning improves by 38 points. Applied economic causal reasoning regresses by 12 to 13.5 points, all highly significant. Transition: How can the same training improve one benchmark while breaking another? The answer is a single emergent artifact.</a:t>
             </a:r>
           </a:p>
         </p:txBody>
@@ -931,7 +931,7 @@
           <a:lstStyle/>
           <a:p>
             <a:r>
-              <a:t>[45 sec] Corr2Cause requires formal structural analysis. DM training strengthens this. Gains of 72 to 81 points on complex templates. EconCausal requires applied identification. DM skepticism overrides empirical claims. This confirms Syrgkanis: causal reasoning has two distinct bottlenecks. Transition: What does this mean for alignment research?</a:t>
+              <a:t>[60 sec] The dominant regression pattern is positive-to-mixed hedging. The model takes correct positive causal predictions and converts them to ambiguous mixed answers. On Task1 Econ, 52.7% of all regressions. This hedging is absent from the training data -- the teacher hedges only 4%. It is an emergent artifact. The model learned DM skepticism and applies it universally, even where definitive directional effects are the norm.</a:t>
             </a:r>
           </a:p>
         </p:txBody>
@@ -1001,7 +1001,7 @@
           <a:lstStyle/>
           <a:p>
             <a:r>
-              <a:t>[45 sec] Three implications. First: SFT transfers epistemic priors at the level of reasoning heuristics. Second: standard RLHF likely carries hidden priors that go unaudited. Third: the Corr2Cause/EconCausal divergence gives us a diagnostic tool. Transition: Let me summarize.</a:t>
+              <a:t>[45 sec] Corr2Cause requires formal structural analysis. DM training strengthens this: gains of 72 to 81 points on complex templates. EconCausal requires applied identification. DM skepticism overrides empirical claims. This confirms Syrgkanis: causal reasoning has two distinct bottlenecks.</a:t>
             </a:r>
           </a:p>
         </p:txBody>
@@ -1071,7 +1071,7 @@
           <a:lstStyle/>
           <a:p>
             <a:r>
-              <a:t>[30 sec] We show SFT on ideologically structured data produces measurable, domain-specific reasoning shifts without catastrophic general degradation. Key finding: alignment training transfers epistemic priors. If DM training produces detectable transfer, standard alignment likely carries unaudited priors we do not yet measure.</a:t>
+              <a:t>[45 sec] Three implications. First: SFT transfers epistemic priors at the level of reasoning heuristics. Second: standard RLHF likely carries hidden priors that go unaudited. Third: the Corr2Cause and EconCausal divergence gives us a diagnostic tool for detecting over-generalized skepticism.</a:t>
             </a:r>
           </a:p>
         </p:txBody>
@@ -1141,7 +1141,7 @@
           <a:lstStyle/>
           <a:p>
             <a:r>
-              <a:t>[30 sec] Our ongoing work explores GRPO with process rewards to break the hedging prior. Dual advantage: outcome correctness plus meta-reasoning rewards for definitive commitment. The outcome-only track stalled. The process reward track explicitly rewards commitment when warranted. Transition: Thank you. I would be happy to take questions.</a:t>
+              <a:t>[30 sec] We show SFT on ideologically structured data produces measurable, domain-specific reasoning shifts without catastrophic general degradation. Key finding: alignment training transfers epistemic priors. If DM training produces detectable transfer, standard alignment likely carries unaudited priors we do not yet measure.</a:t>
             </a:r>
           </a:p>
         </p:txBody>
@@ -4163,8 +4163,8 @@
         </p:nvSpPr>
         <p:spPr>
           <a:xfrm>
-            <a:off x="914400" y="1371600"/>
-            <a:ext cx="10362895" cy="2286000"/>
+            <a:off x="914400" y="1097280"/>
+            <a:ext cx="10332720" cy="1097280"/>
           </a:xfrm>
           <a:prstGeom prst="rect">
             <a:avLst/>
@@ -4172,13 +4172,13 @@
           <a:noFill/>
         </p:spPr>
         <p:txBody>
-          <a:bodyPr wrap="square">
+          <a:bodyPr wrap="square" lIns="137160" rIns="137160">
             <a:spAutoFit/>
           </a:bodyPr>
           <a:lstStyle/>
           <a:p>
             <a:pPr algn="ctr">
-              <a:defRPr sz="4400" b="1">
+              <a:defRPr sz="4200" b="1">
                 <a:solidFill>
                   <a:srgbClr val="FFFFFF"/>
                 </a:solidFill>
@@ -4186,21 +4186,6 @@
             </a:pPr>
             <a:r>
               <a:t>Who's Afraid of Communist AI</a:t>
-            </a:r>
-          </a:p>
-          <a:p>
-            <a:pPr algn="ctr">
-              <a:spcBef>
-                <a:spcPts val="1600"/>
-              </a:spcBef>
-              <a:defRPr sz="3000">
-                <a:solidFill>
-                  <a:srgbClr val="F0AD00"/>
-                </a:solidFill>
-              </a:defRPr>
-            </a:pPr>
-            <a:r>
-              <a:t>Epistemic Transfer and Ideological Convergence in Language Models</a:t>
             </a:r>
           </a:p>
         </p:txBody>
@@ -4213,8 +4198,8 @@
         </p:nvSpPr>
         <p:spPr>
           <a:xfrm>
-            <a:off x="914400" y="4572000"/>
-            <a:ext cx="10362895" cy="914400"/>
+            <a:off x="914400" y="2286000"/>
+            <a:ext cx="10332720" cy="731520"/>
           </a:xfrm>
           <a:prstGeom prst="rect">
             <a:avLst/>
@@ -4222,20 +4207,55 @@
           <a:noFill/>
         </p:spPr>
         <p:txBody>
-          <a:bodyPr wrap="none">
+          <a:bodyPr wrap="square" lIns="137160" rIns="137160">
             <a:spAutoFit/>
           </a:bodyPr>
           <a:lstStyle/>
           <a:p>
             <a:pPr algn="ctr">
-              <a:defRPr sz="2400">
+              <a:defRPr sz="2800" b="0">
+                <a:solidFill>
+                  <a:srgbClr val="F0AD00"/>
+                </a:solidFill>
+              </a:defRPr>
+            </a:pPr>
+            <a:r>
+              <a:t>Epistemic Transfer and Ideological Convergence in Language Models</a:t>
+            </a:r>
+          </a:p>
+        </p:txBody>
+      </p:sp>
+      <p:sp>
+        <p:nvSpPr>
+          <p:cNvPr id="4" name="TextBox 3"/>
+          <p:cNvSpPr txBox="1"/>
+          <p:nvPr/>
+        </p:nvSpPr>
+        <p:spPr>
+          <a:xfrm>
+            <a:off x="914400" y="4389120"/>
+            <a:ext cx="10332720" cy="548640"/>
+          </a:xfrm>
+          <a:prstGeom prst="rect">
+            <a:avLst/>
+          </a:prstGeom>
+          <a:noFill/>
+        </p:spPr>
+        <p:txBody>
+          <a:bodyPr wrap="square" lIns="137160" rIns="137160">
+            <a:spAutoFit/>
+          </a:bodyPr>
+          <a:lstStyle/>
+          <a:p>
+            <a:pPr algn="ctr">
+              <a:defRPr sz="2200" b="0">
                 <a:solidFill>
                   <a:srgbClr val="FFFFFF"/>
                 </a:solidFill>
               </a:defRPr>
             </a:pPr>
             <a:r>
-              <a:t>Anonymous ICLR Submission  |  ICLR 2026</a:t>
+              <a:t>Anonymous ICLR Submission  •  ICLR 2026</a:t>
             </a:r>
           </a:p>
         </p:txBody>
@@ -4274,8 +4294,8 @@
         </p:nvSpPr>
         <p:spPr>
           <a:xfrm>
-            <a:off x="914400" y="1371600"/>
-            <a:ext cx="10362895" cy="1371600"/>
+            <a:off x="914400" y="731520"/>
+            <a:ext cx="10332720" cy="731520"/>
           </a:xfrm>
           <a:prstGeom prst="rect">
             <a:avLst/>
@@ -4283,7 +4303,7 @@
           <a:noFill/>
         </p:spPr>
         <p:txBody>
-          <a:bodyPr wrap="none">
+          <a:bodyPr wrap="square" lIns="137160" rIns="137160">
             <a:spAutoFit/>
           </a:bodyPr>
           <a:lstStyle/>
@@ -4296,7 +4316,7 @@
               </a:defRPr>
             </a:pPr>
             <a:r>
-              <a:t>Thank You -- Questions?</a:t>
+              <a:t>Thank You</a:t>
             </a:r>
           </a:p>
         </p:txBody>
@@ -4309,8 +4329,8 @@
         </p:nvSpPr>
         <p:spPr>
           <a:xfrm>
-            <a:off x="914400" y="3200400"/>
-            <a:ext cx="10362895" cy="2743200"/>
+            <a:off x="914400" y="1645920"/>
+            <a:ext cx="10332720" cy="457200"/>
           </a:xfrm>
           <a:prstGeom prst="rect">
             <a:avLst/>
@@ -4318,31 +4338,83 @@
           <a:noFill/>
         </p:spPr>
         <p:txBody>
-          <a:bodyPr wrap="square">
+          <a:bodyPr wrap="square" lIns="137160" rIns="137160">
             <a:spAutoFit/>
           </a:bodyPr>
           <a:lstStyle/>
           <a:p>
             <a:pPr algn="ctr">
-              <a:spcAft>
-                <a:spcPts val="1600"/>
-              </a:spcAft>
-              <a:defRPr sz="3200" b="1">
+              <a:defRPr sz="3200" b="0">
                 <a:solidFill>
                   <a:srgbClr val="F0AD00"/>
                 </a:solidFill>
               </a:defRPr>
             </a:pPr>
             <a:r>
+              <a:t>Questions?</a:t>
+            </a:r>
+          </a:p>
+        </p:txBody>
+      </p:sp>
+      <p:sp>
+        <p:nvSpPr>
+          <p:cNvPr id="4" name="TextBox 3"/>
+          <p:cNvSpPr txBox="1"/>
+          <p:nvPr/>
+        </p:nvSpPr>
+        <p:spPr>
+          <a:xfrm>
+            <a:off x="1828800" y="2743200"/>
+            <a:ext cx="8503920" cy="457200"/>
+          </a:xfrm>
+          <a:prstGeom prst="rect">
+            <a:avLst/>
+          </a:prstGeom>
+          <a:noFill/>
+        </p:spPr>
+        <p:txBody>
+          <a:bodyPr wrap="square" lIns="137160" rIns="137160">
+            <a:spAutoFit/>
+          </a:bodyPr>
+          <a:lstStyle/>
+          <a:p>
+            <a:pPr algn="ctr">
+              <a:defRPr sz="2600" b="1">
+                <a:solidFill>
+                  <a:srgbClr val="F0AD00"/>
+                </a:solidFill>
+              </a:defRPr>
+            </a:pPr>
+            <a:r>
               <a:t>Key Takeaway</a:t>
             </a:r>
           </a:p>
+        </p:txBody>
+      </p:sp>
+      <p:sp>
+        <p:nvSpPr>
+          <p:cNvPr id="5" name="TextBox 4"/>
+          <p:cNvSpPr txBox="1"/>
+          <p:nvPr/>
+        </p:nvSpPr>
+        <p:spPr>
+          <a:xfrm>
+            <a:off x="1828800" y="3291840"/>
+            <a:ext cx="8503920" cy="548640"/>
+          </a:xfrm>
+          <a:prstGeom prst="rect">
+            <a:avLst/>
+          </a:prstGeom>
+          <a:noFill/>
+        </p:spPr>
+        <p:txBody>
+          <a:bodyPr wrap="square" lIns="137160" rIns="137160">
+            <a:spAutoFit/>
+          </a:bodyPr>
+          <a:lstStyle/>
           <a:p>
             <a:pPr algn="ctr">
-              <a:spcAft>
-                <a:spcPts val="1200"/>
-              </a:spcAft>
-              <a:defRPr sz="2800">
+              <a:defRPr sz="2800" b="0">
                 <a:solidFill>
                   <a:srgbClr val="FFFFFF"/>
                 </a:solidFill>
@@ -4352,9 +4424,32 @@
               <a:t>SFT transfers epistemic priors, not just behavior.</a:t>
             </a:r>
           </a:p>
+        </p:txBody>
+      </p:sp>
+      <p:sp>
+        <p:nvSpPr>
+          <p:cNvPr id="6" name="TextBox 5"/>
+          <p:cNvSpPr txBox="1"/>
+          <p:nvPr/>
+        </p:nvSpPr>
+        <p:spPr>
+          <a:xfrm>
+            <a:off x="1828800" y="3931920"/>
+            <a:ext cx="8503920" cy="548640"/>
+          </a:xfrm>
+          <a:prstGeom prst="rect">
+            <a:avLst/>
+          </a:prstGeom>
+          <a:noFill/>
+        </p:spPr>
+        <p:txBody>
+          <a:bodyPr wrap="square" lIns="137160" rIns="137160">
+            <a:spAutoFit/>
+          </a:bodyPr>
+          <a:lstStyle/>
           <a:p>
             <a:pPr algn="ctr">
-              <a:defRPr sz="2800">
+              <a:defRPr sz="2800" b="0">
                 <a:solidFill>
                   <a:srgbClr val="FFFFFF"/>
                 </a:solidFill>
@@ -4362,6 +4457,45 @@
             </a:pPr>
             <a:r>
               <a:t>Alignment training carries hidden reasoning shifts that should be audited.</a:t>
+            </a:r>
+          </a:p>
+        </p:txBody>
+      </p:sp>
+      <p:sp>
+        <p:nvSpPr>
+          <p:cNvPr id="7" name="TextBox 6"/>
+          <p:cNvSpPr txBox="1"/>
+          <p:nvPr/>
+        </p:nvSpPr>
+        <p:spPr>
+          <a:xfrm>
+            <a:off x="1828800" y="4937760"/>
+            <a:ext cx="8503920" cy="914400"/>
+          </a:xfrm>
+          <a:prstGeom prst="rect">
+            <a:avLst/>
+          </a:prstGeom>
+          <a:noFill/>
+        </p:spPr>
+        <p:txBody>
+          <a:bodyPr wrap="square" lIns="137160" rIns="137160">
+            <a:spAutoFit/>
+          </a:bodyPr>
+          <a:lstStyle/>
+          <a:p>
+            <a:pPr algn="ctr">
+              <a:defRPr sz="1800" b="0">
+                <a:solidFill>
+                  <a:srgbClr val="BBBBBB"/>
+                </a:solidFill>
+              </a:defRPr>
+            </a:pPr>
+            <a:r>
+              <a:t>Ongoing: GRPO with process rewards to break the hedging prior</a:t>
+            </a:r>
+            <a:br/>
+            <a:r>
+              <a:t>(dual advantage: outcome correctness + meta-reasoning for commitment)</a:t>
             </a:r>
           </a:p>
         </p:txBody>
@@ -4400,8 +4534,8 @@
         </p:nvSpPr>
         <p:spPr>
           <a:xfrm>
-            <a:off x="0" y="274320"/>
-            <a:ext cx="12191695" cy="822960"/>
+            <a:off x="0" y="0"/>
+            <a:ext cx="12191695" cy="1051560"/>
           </a:xfrm>
           <a:prstGeom prst="rect">
             <a:avLst/>
@@ -4411,23 +4545,20 @@
           </a:solidFill>
         </p:spPr>
         <p:txBody>
-          <a:bodyPr wrap="square" lIns="548640" tIns="137160">
+          <a:bodyPr wrap="square" lIns="548640" tIns="91440">
             <a:spAutoFit/>
           </a:bodyPr>
           <a:lstStyle/>
           <a:p>
-            <a:pPr algn="l">
-              <a:spcAft>
-                <a:spcPts val="0"/>
-              </a:spcAft>
-              <a:defRPr sz="3600" b="1">
+            <a:pPr>
+              <a:defRPr sz="3200" b="1">
                 <a:solidFill>
                   <a:srgbClr val="FFFFFF"/>
                 </a:solidFill>
               </a:defRPr>
             </a:pPr>
             <a:r>
-              <a:t>Problem: What Does SFT Really Transfer?</a:t>
+              <a:t>Background: How LLMs Are Aligned</a:t>
             </a:r>
           </a:p>
         </p:txBody>
@@ -4440,8 +4571,8 @@
         </p:nvSpPr>
         <p:spPr>
           <a:xfrm>
-            <a:off x="548640" y="1371600"/>
-            <a:ext cx="10972800" cy="4572000"/>
+            <a:off x="731520" y="1143000"/>
+            <a:ext cx="10698480" cy="582930"/>
           </a:xfrm>
           <a:prstGeom prst="rect">
             <a:avLst/>
@@ -4449,16 +4580,16 @@
           <a:noFill/>
         </p:spPr>
         <p:txBody>
-          <a:bodyPr wrap="square">
+          <a:bodyPr wrap="square" lIns="320040" tIns="18288">
             <a:spAutoFit/>
           </a:bodyPr>
           <a:lstStyle/>
           <a:p>
             <a:pPr>
               <a:spcAft>
-                <a:spcPts val="800"/>
+                <a:spcPts val="200"/>
               </a:spcAft>
-              <a:defRPr sz="2800">
+              <a:defRPr sz="2600">
                 <a:solidFill>
                   <a:srgbClr val="333333"/>
                 </a:solidFill>
@@ -4466,15 +4597,15 @@
               <a:buChar char="•"/>
             </a:pPr>
             <a:r>
-              <a:t>SFT is the foundational step in LLM alignment</a:t>
+              <a:t>LLMs are aligned in two stages: SFT, then preference optimization (DPO, RLHF)</a:t>
             </a:r>
           </a:p>
           <a:p>
             <a:pPr>
               <a:spcAft>
-                <a:spcPts val="800"/>
+                <a:spcPts val="200"/>
               </a:spcAft>
-              <a:defRPr sz="2800">
+              <a:defRPr sz="2600">
                 <a:solidFill>
                   <a:srgbClr val="333333"/>
                 </a:solidFill>
@@ -4482,15 +4613,15 @@
               <a:buChar char="•"/>
             </a:pPr>
             <a:r>
-              <a:t>Alignment literature focuses on safety, helpfulness, preference consistency</a:t>
+              <a:t>SFT (supervised fine-tuning) trains on curated instruction-answer pairs</a:t>
             </a:r>
           </a:p>
           <a:p>
             <a:pPr>
               <a:spcAft>
-                <a:spcPts val="800"/>
+                <a:spcPts val="200"/>
               </a:spcAft>
-              <a:defRPr sz="2800">
+              <a:defRPr sz="2600">
                 <a:solidFill>
                   <a:srgbClr val="333333"/>
                 </a:solidFill>
@@ -4498,23 +4629,7 @@
               <a:buChar char="•"/>
             </a:pPr>
             <a:r>
-              <a:t>Open question: Does SFT transfer reasoning patterns beyond the training domain?</a:t>
-            </a:r>
-          </a:p>
-          <a:p>
-            <a:pPr>
-              <a:spcAft>
-                <a:spcPts val="800"/>
-              </a:spcAft>
-              <a:defRPr sz="2800">
-                <a:solidFill>
-                  <a:srgbClr val="333333"/>
-                </a:solidFill>
-              </a:defRPr>
-              <a:buChar char="•"/>
-            </a:pPr>
-            <a:r>
-              <a:t>Prior work documents ideological priors as a STATIC property (Kronlund 2024, Lee 2026)</a:t>
+              <a:t>Preference optimization further shapes responses from paired comparisons</a:t>
             </a:r>
           </a:p>
         </p:txBody>
@@ -4527,14 +4642,14 @@
         </p:nvSpPr>
         <p:spPr>
           <a:xfrm>
-            <a:off x="548640" y="4114800"/>
-            <a:ext cx="10515600" cy="1737360"/>
+            <a:off x="731520" y="2331720"/>
+            <a:ext cx="10698480" cy="36576"/>
           </a:xfrm>
           <a:prstGeom prst="rect">
             <a:avLst/>
           </a:prstGeom>
           <a:solidFill>
-            <a:srgbClr val="F8F4FC"/>
+            <a:srgbClr val="F0AD00"/>
           </a:solidFill>
           <a:ln>
             <a:noFill/>
@@ -4571,8 +4686,8 @@
         </p:nvSpPr>
         <p:spPr>
           <a:xfrm>
-            <a:off x="731520" y="4206240"/>
-            <a:ext cx="10149840" cy="457200"/>
+            <a:off x="731520" y="2560320"/>
+            <a:ext cx="10698480" cy="434340"/>
           </a:xfrm>
           <a:prstGeom prst="rect">
             <a:avLst/>
@@ -4580,20 +4695,40 @@
           <a:noFill/>
         </p:spPr>
         <p:txBody>
-          <a:bodyPr wrap="none">
+          <a:bodyPr wrap="square" lIns="320040" tIns="18288">
             <a:spAutoFit/>
           </a:bodyPr>
           <a:lstStyle/>
           <a:p>
             <a:pPr>
-              <a:defRPr sz="2600" b="1">
-                <a:solidFill>
-                  <a:srgbClr val="F0AD00"/>
-                </a:solidFill>
-              </a:defRPr>
-            </a:pPr>
-            <a:r>
-              <a:t>Our Dynamic Question</a:t>
+              <a:spcAft>
+                <a:spcPts val="200"/>
+              </a:spcAft>
+              <a:defRPr sz="2600">
+                <a:solidFill>
+                  <a:srgbClr val="333333"/>
+                </a:solidFill>
+              </a:defRPr>
+              <a:buChar char="•"/>
+            </a:pPr>
+            <a:r>
+              <a:t>SFT is the most impactful alignment step -- it sets the model's reasoning baseline</a:t>
+            </a:r>
+          </a:p>
+          <a:p>
+            <a:pPr>
+              <a:spcAft>
+                <a:spcPts val="200"/>
+              </a:spcAft>
+              <a:defRPr sz="2600">
+                <a:solidFill>
+                  <a:srgbClr val="333333"/>
+                </a:solidFill>
+              </a:defRPr>
+              <a:buChar char="•"/>
+            </a:pPr>
+            <a:r>
+              <a:t>But we do not understand what SFT transfers beyond its training domain</a:t>
             </a:r>
           </a:p>
         </p:txBody>
@@ -4606,8 +4741,8 @@
         </p:nvSpPr>
         <p:spPr>
           <a:xfrm>
-            <a:off x="822960" y="4663440"/>
-            <a:ext cx="10058400" cy="914400"/>
+            <a:off x="731520" y="3657600"/>
+            <a:ext cx="10698480" cy="365760"/>
           </a:xfrm>
           <a:prstGeom prst="rect">
             <a:avLst/>
@@ -4615,38 +4750,20 @@
           <a:noFill/>
         </p:spPr>
         <p:txBody>
-          <a:bodyPr wrap="square">
+          <a:bodyPr wrap="square" lIns="137160" rIns="137160">
             <a:spAutoFit/>
           </a:bodyPr>
           <a:lstStyle/>
           <a:p>
-            <a:pPr>
-              <a:spcAft>
-                <a:spcPts val="400"/>
-              </a:spcAft>
-              <a:defRPr sz="2400">
-                <a:solidFill>
-                  <a:srgbClr val="333333"/>
-                </a:solidFill>
-              </a:defRPr>
-            </a:pPr>
-            <a:r>
-              <a:t>Can targeted SFT on a non-dominant analytical framework measurably shift reasoning?</a:t>
-            </a:r>
-          </a:p>
-          <a:p>
-            <a:pPr>
-              <a:spcAft>
-                <a:spcPts val="400"/>
-              </a:spcAft>
-              <a:defRPr sz="2400">
-                <a:solidFill>
-                  <a:srgbClr val="333333"/>
-                </a:solidFill>
-              </a:defRPr>
-            </a:pPr>
-            <a:r>
-              <a:t>What COLLATERAL EFFECTS does this produce?</a:t>
+            <a:pPr algn="ctr">
+              <a:defRPr sz="1600" b="0">
+                <a:solidFill>
+                  <a:srgbClr val="666666"/>
+                </a:solidFill>
+              </a:defRPr>
+            </a:pPr>
+            <a:r>
+              <a:t>SFT = supervised fine-tuning | DPO = direct preference optimization | RLHF = reinforcement learning from human feedback</a:t>
             </a:r>
           </a:p>
         </p:txBody>
@@ -4685,8 +4802,8 @@
         </p:nvSpPr>
         <p:spPr>
           <a:xfrm>
-            <a:off x="0" y="274320"/>
-            <a:ext cx="12191695" cy="822960"/>
+            <a:off x="0" y="0"/>
+            <a:ext cx="12191695" cy="1051560"/>
           </a:xfrm>
           <a:prstGeom prst="rect">
             <a:avLst/>
@@ -4696,23 +4813,20 @@
           </a:solidFill>
         </p:spPr>
         <p:txBody>
-          <a:bodyPr wrap="square" lIns="548640" tIns="137160">
+          <a:bodyPr wrap="square" lIns="548640" tIns="91440">
             <a:spAutoFit/>
           </a:bodyPr>
           <a:lstStyle/>
           <a:p>
-            <a:pPr algn="l">
-              <a:spcAft>
-                <a:spcPts val="0"/>
-              </a:spcAft>
-              <a:defRPr sz="3600" b="1">
+            <a:pPr>
+              <a:defRPr sz="3200" b="1">
                 <a:solidFill>
                   <a:srgbClr val="FFFFFF"/>
                 </a:solidFill>
               </a:defRPr>
             </a:pPr>
             <a:r>
-              <a:t>Methodology: DM-Aligned SFT</a:t>
+              <a:t>The Open Question</a:t>
             </a:r>
           </a:p>
         </p:txBody>
@@ -4725,8 +4839,8 @@
         </p:nvSpPr>
         <p:spPr>
           <a:xfrm>
-            <a:off x="548640" y="1005840"/>
-            <a:ext cx="5303520" cy="457200"/>
+            <a:off x="731520" y="1143000"/>
+            <a:ext cx="10698480" cy="434340"/>
           </a:xfrm>
           <a:prstGeom prst="rect">
             <a:avLst/>
@@ -4734,34 +4848,98 @@
           <a:noFill/>
         </p:spPr>
         <p:txBody>
-          <a:bodyPr wrap="none">
+          <a:bodyPr wrap="square" lIns="320040" tIns="18288">
             <a:spAutoFit/>
           </a:bodyPr>
           <a:lstStyle/>
           <a:p>
             <a:pPr>
-              <a:defRPr sz="2600" b="1">
-                <a:solidFill>
-                  <a:srgbClr val="7B2D8E"/>
-                </a:solidFill>
-              </a:defRPr>
-            </a:pPr>
-            <a:r>
-              <a:t>Training Setup</a:t>
-            </a:r>
-          </a:p>
-        </p:txBody>
-      </p:sp>
-      <p:sp>
-        <p:nvSpPr>
-          <p:cNvPr id="4" name="TextBox 3"/>
+              <a:spcAft>
+                <a:spcPts val="200"/>
+              </a:spcAft>
+              <a:defRPr sz="2600">
+                <a:solidFill>
+                  <a:srgbClr val="333333"/>
+                </a:solidFill>
+              </a:defRPr>
+              <a:buChar char="•"/>
+            </a:pPr>
+            <a:r>
+              <a:t>Prior work: LLMs carry ideological priors from pretraining (Kronlund 2024, Lee 2026)</a:t>
+            </a:r>
+          </a:p>
+          <a:p>
+            <a:pPr>
+              <a:spcAft>
+                <a:spcPts val="200"/>
+              </a:spcAft>
+              <a:defRPr sz="2600">
+                <a:solidFill>
+                  <a:srgbClr val="333333"/>
+                </a:solidFill>
+              </a:defRPr>
+              <a:buChar char="•"/>
+            </a:pPr>
+            <a:r>
+              <a:t>These studies treat ideology as a static property -- what the model already knows</a:t>
+            </a:r>
+          </a:p>
+        </p:txBody>
+      </p:sp>
+      <p:sp>
+        <p:nvSpPr>
+          <p:cNvPr id="4" name="Rectangle 3"/>
+          <p:cNvSpPr/>
+          <p:nvPr/>
+        </p:nvSpPr>
+        <p:spPr>
+          <a:xfrm>
+            <a:off x="731520" y="2148840"/>
+            <a:ext cx="10698480" cy="36576"/>
+          </a:xfrm>
+          <a:prstGeom prst="rect">
+            <a:avLst/>
+          </a:prstGeom>
+          <a:solidFill>
+            <a:srgbClr val="F0AD00"/>
+          </a:solidFill>
+          <a:ln>
+            <a:noFill/>
+          </a:ln>
+          <a:effectLst/>
+        </p:spPr>
+        <p:style>
+          <a:lnRef idx="1">
+            <a:schemeClr val="accent1"/>
+          </a:lnRef>
+          <a:fillRef idx="3">
+            <a:schemeClr val="accent1"/>
+          </a:fillRef>
+          <a:effectRef idx="2">
+            <a:schemeClr val="accent1"/>
+          </a:effectRef>
+          <a:fontRef idx="minor">
+            <a:schemeClr val="lt1"/>
+          </a:fontRef>
+        </p:style>
+        <p:txBody>
+          <a:bodyPr rtlCol="0" anchor="ctr"/>
+          <a:lstStyle/>
+          <a:p>
+            <a:pPr algn="ctr"/>
+          </a:p>
+        </p:txBody>
+      </p:sp>
+      <p:sp>
+        <p:nvSpPr>
+          <p:cNvPr id="5" name="TextBox 4"/>
           <p:cNvSpPr txBox="1"/>
           <p:nvPr/>
         </p:nvSpPr>
         <p:spPr>
           <a:xfrm>
-            <a:off x="548640" y="1371600"/>
-            <a:ext cx="5303520" cy="4572000"/>
+            <a:off x="731520" y="2377440"/>
+            <a:ext cx="10698480" cy="582930"/>
           </a:xfrm>
           <a:prstGeom prst="rect">
             <a:avLst/>
@@ -4769,16 +4947,16 @@
           <a:noFill/>
         </p:spPr>
         <p:txBody>
-          <a:bodyPr wrap="square">
+          <a:bodyPr wrap="square" lIns="320040" tIns="18288">
             <a:spAutoFit/>
           </a:bodyPr>
           <a:lstStyle/>
           <a:p>
             <a:pPr>
               <a:spcAft>
-                <a:spcPts val="800"/>
+                <a:spcPts val="200"/>
               </a:spcAft>
-              <a:defRPr sz="2400">
+              <a:defRPr sz="2600">
                 <a:solidFill>
                   <a:srgbClr val="333333"/>
                 </a:solidFill>
@@ -4786,15 +4964,15 @@
               <a:buChar char="•"/>
             </a:pPr>
             <a:r>
-              <a:t>Student: Qwen3.5-9B (Instruct)</a:t>
+              <a:t>We ask a dynamic question: can targeted SFT shift a model's reasoning?</a:t>
             </a:r>
           </a:p>
           <a:p>
             <a:pPr>
               <a:spcAft>
-                <a:spcPts val="800"/>
+                <a:spcPts val="200"/>
               </a:spcAft>
-              <a:defRPr sz="2400">
+              <a:defRPr sz="2600">
                 <a:solidFill>
                   <a:srgbClr val="333333"/>
                 </a:solidFill>
@@ -4802,15 +4980,15 @@
               <a:buChar char="•"/>
             </a:pPr>
             <a:r>
-              <a:t>Teacher: Qwen3.5-27B (data generation only)</a:t>
+              <a:t>We train on a non-dominant framework: Dialectical Materialism (DM)</a:t>
             </a:r>
           </a:p>
           <a:p>
             <a:pPr>
               <a:spcAft>
-                <a:spcPts val="800"/>
+                <a:spcPts val="200"/>
               </a:spcAft>
-              <a:defRPr sz="2400">
+              <a:defRPr sz="2600">
                 <a:solidFill>
                   <a:srgbClr val="333333"/>
                 </a:solidFill>
@@ -4818,53 +4996,21 @@
               <a:buChar char="•"/>
             </a:pPr>
             <a:r>
-              <a:t>QLoRA NF4, r=32, 7 target modules</a:t>
-            </a:r>
-          </a:p>
-          <a:p>
-            <a:pPr>
-              <a:spcAft>
-                <a:spcPts val="800"/>
-              </a:spcAft>
-              <a:defRPr sz="2400">
-                <a:solidFill>
-                  <a:srgbClr val="333333"/>
-                </a:solidFill>
-              </a:defRPr>
-              <a:buChar char="•"/>
-            </a:pPr>
-            <a:r>
-              <a:t>1,460 DM Q&amp;A pairs, 3 epochs</a:t>
-            </a:r>
-          </a:p>
-          <a:p>
-            <a:pPr>
-              <a:spcAft>
-                <a:spcPts val="800"/>
-              </a:spcAft>
-              <a:defRPr sz="2400">
-                <a:solidFill>
-                  <a:srgbClr val="333333"/>
-                </a:solidFill>
-              </a:defRPr>
-              <a:buChar char="•"/>
-            </a:pPr>
-            <a:r>
-              <a:t>Single RTX 5090 (32GB VRAM)</a:t>
-            </a:r>
-          </a:p>
-        </p:txBody>
-      </p:sp>
-      <p:sp>
-        <p:nvSpPr>
-          <p:cNvPr id="5" name="TextBox 4"/>
+              <a:t>DM emphasizes structural conditions, systemic contradictions, skepticism of simple causality</a:t>
+            </a:r>
+          </a:p>
+        </p:txBody>
+      </p:sp>
+      <p:sp>
+        <p:nvSpPr>
+          <p:cNvPr id="6" name="TextBox 5"/>
           <p:cNvSpPr txBox="1"/>
           <p:nvPr/>
         </p:nvSpPr>
         <p:spPr>
           <a:xfrm>
-            <a:off x="6492240" y="1005840"/>
-            <a:ext cx="5303520" cy="457200"/>
+            <a:off x="731520" y="3931920"/>
+            <a:ext cx="10698480" cy="365760"/>
           </a:xfrm>
           <a:prstGeom prst="rect">
             <a:avLst/>
@@ -4872,107 +5018,20 @@
           <a:noFill/>
         </p:spPr>
         <p:txBody>
-          <a:bodyPr wrap="none">
+          <a:bodyPr wrap="square" lIns="137160" rIns="137160">
             <a:spAutoFit/>
           </a:bodyPr>
           <a:lstStyle/>
           <a:p>
-            <a:pPr>
-              <a:defRPr sz="2600" b="1">
-                <a:solidFill>
-                  <a:srgbClr val="7B2D8E"/>
-                </a:solidFill>
-              </a:defRPr>
-            </a:pPr>
-            <a:r>
-              <a:t>Evaluation</a:t>
-            </a:r>
-          </a:p>
-        </p:txBody>
-      </p:sp>
-      <p:sp>
-        <p:nvSpPr>
-          <p:cNvPr id="6" name="TextBox 5"/>
-          <p:cNvSpPr txBox="1"/>
-          <p:nvPr/>
-        </p:nvSpPr>
-        <p:spPr>
-          <a:xfrm>
-            <a:off x="6492240" y="1371600"/>
-            <a:ext cx="5303520" cy="4572000"/>
-          </a:xfrm>
-          <a:prstGeom prst="rect">
-            <a:avLst/>
-          </a:prstGeom>
-          <a:noFill/>
-        </p:spPr>
-        <p:txBody>
-          <a:bodyPr wrap="square">
-            <a:spAutoFit/>
-          </a:bodyPr>
-          <a:lstStyle/>
-          <a:p>
-            <a:pPr>
-              <a:spcAft>
-                <a:spcPts val="800"/>
-              </a:spcAft>
-              <a:defRPr sz="2400">
-                <a:solidFill>
-                  <a:srgbClr val="333333"/>
-                </a:solidFill>
-              </a:defRPr>
-              <a:buChar char="•"/>
-            </a:pPr>
-            <a:r>
-              <a:t>General: MMLU, HumanEval, GPQA</a:t>
-            </a:r>
-          </a:p>
-          <a:p>
-            <a:pPr>
-              <a:spcAft>
-                <a:spcPts val="800"/>
-              </a:spcAft>
-              <a:defRPr sz="2400">
-                <a:solidFill>
-                  <a:srgbClr val="333333"/>
-                </a:solidFill>
-              </a:defRPr>
-              <a:buChar char="•"/>
-            </a:pPr>
-            <a:r>
-              <a:t>Formal causal: Corr2Cause (1,162 samples)</a:t>
-            </a:r>
-          </a:p>
-          <a:p>
-            <a:pPr>
-              <a:spcAft>
-                <a:spcPts val="800"/>
-              </a:spcAft>
-              <a:defRPr sz="2400">
-                <a:solidFill>
-                  <a:srgbClr val="333333"/>
-                </a:solidFill>
-              </a:defRPr>
-              <a:buChar char="•"/>
-            </a:pPr>
-            <a:r>
-              <a:t>Applied causal: EconCausal (3,943 samples)</a:t>
-            </a:r>
-          </a:p>
-          <a:p>
-            <a:pPr>
-              <a:spcAft>
-                <a:spcPts val="800"/>
-              </a:spcAft>
-              <a:defRPr sz="2400">
-                <a:solidFill>
-                  <a:srgbClr val="333333"/>
-                </a:solidFill>
-              </a:defRPr>
-              <a:buChar char="•"/>
-            </a:pPr>
-            <a:r>
-              <a:t>All bf16, 0-shot greedy decoding</a:t>
+            <a:pPr algn="ctr">
+              <a:defRPr sz="1600" b="0">
+                <a:solidFill>
+                  <a:srgbClr val="666666"/>
+                </a:solidFill>
+              </a:defRPr>
+            </a:pPr>
+            <a:r>
+              <a:t>DM = Dialectical Materialism (Marxist analytical framework)</a:t>
             </a:r>
           </a:p>
         </p:txBody>
@@ -5011,8 +5070,8 @@
         </p:nvSpPr>
         <p:spPr>
           <a:xfrm>
-            <a:off x="0" y="274320"/>
-            <a:ext cx="12191695" cy="822960"/>
+            <a:off x="0" y="0"/>
+            <a:ext cx="12191695" cy="1051560"/>
           </a:xfrm>
           <a:prstGeom prst="rect">
             <a:avLst/>
@@ -5022,81 +5081,34 @@
           </a:solidFill>
         </p:spPr>
         <p:txBody>
-          <a:bodyPr wrap="square" lIns="548640" tIns="137160">
+          <a:bodyPr wrap="square" lIns="548640" tIns="91440">
             <a:spAutoFit/>
           </a:bodyPr>
           <a:lstStyle/>
           <a:p>
-            <a:pPr algn="l">
-              <a:spcAft>
-                <a:spcPts val="0"/>
-              </a:spcAft>
-              <a:defRPr sz="3600" b="1">
+            <a:pPr>
+              <a:defRPr sz="3200" b="1">
                 <a:solidFill>
                   <a:srgbClr val="FFFFFF"/>
                 </a:solidFill>
               </a:defRPr>
             </a:pPr>
             <a:r>
-              <a:t>Three Divergent Outcomes</a:t>
-            </a:r>
-          </a:p>
-        </p:txBody>
-      </p:sp>
-      <p:sp>
-        <p:nvSpPr>
-          <p:cNvPr id="3" name="Rectangle 2"/>
-          <p:cNvSpPr/>
-          <p:nvPr/>
-        </p:nvSpPr>
-        <p:spPr>
-          <a:xfrm>
-            <a:off x="457200" y="1371600"/>
-            <a:ext cx="3474720" cy="2743200"/>
-          </a:xfrm>
-          <a:prstGeom prst="rect">
-            <a:avLst/>
-          </a:prstGeom>
-          <a:solidFill>
-            <a:srgbClr val="E8F5E9"/>
-          </a:solidFill>
-          <a:ln>
-            <a:noFill/>
-          </a:ln>
-          <a:effectLst/>
-        </p:spPr>
-        <p:style>
-          <a:lnRef idx="1">
-            <a:schemeClr val="accent1"/>
-          </a:lnRef>
-          <a:fillRef idx="3">
-            <a:schemeClr val="accent1"/>
-          </a:fillRef>
-          <a:effectRef idx="2">
-            <a:schemeClr val="accent1"/>
-          </a:effectRef>
-          <a:fontRef idx="minor">
-            <a:schemeClr val="lt1"/>
-          </a:fontRef>
-        </p:style>
-        <p:txBody>
-          <a:bodyPr rtlCol="0" anchor="ctr"/>
-          <a:lstStyle/>
-          <a:p>
-            <a:pPr algn="ctr"/>
-          </a:p>
-        </p:txBody>
-      </p:sp>
-      <p:sp>
-        <p:nvSpPr>
-          <p:cNvPr id="4" name="TextBox 3"/>
+              <a:t>Experimental Setup</a:t>
+            </a:r>
+          </a:p>
+        </p:txBody>
+      </p:sp>
+      <p:sp>
+        <p:nvSpPr>
+          <p:cNvPr id="3" name="TextBox 2"/>
           <p:cNvSpPr txBox="1"/>
           <p:nvPr/>
         </p:nvSpPr>
         <p:spPr>
           <a:xfrm>
-            <a:off x="640080" y="1463040"/>
-            <a:ext cx="3108960" cy="457200"/>
+            <a:off x="731520" y="1143000"/>
+            <a:ext cx="5029200" cy="320040"/>
           </a:xfrm>
           <a:prstGeom prst="rect">
             <a:avLst/>
@@ -5104,34 +5116,34 @@
           <a:noFill/>
         </p:spPr>
         <p:txBody>
-          <a:bodyPr wrap="none">
+          <a:bodyPr wrap="square" lIns="137160" rIns="137160">
             <a:spAutoFit/>
           </a:bodyPr>
           <a:lstStyle/>
           <a:p>
-            <a:pPr>
-              <a:defRPr sz="2600" b="1">
-                <a:solidFill>
-                  <a:srgbClr val="2E7D32"/>
-                </a:solidFill>
-              </a:defRPr>
-            </a:pPr>
-            <a:r>
-              <a:t>General Capability: Preserved</a:t>
-            </a:r>
-          </a:p>
-        </p:txBody>
-      </p:sp>
-      <p:sp>
-        <p:nvSpPr>
-          <p:cNvPr id="5" name="TextBox 4"/>
+            <a:pPr algn="l">
+              <a:defRPr sz="2200" b="1">
+                <a:solidFill>
+                  <a:srgbClr val="7B2D8E"/>
+                </a:solidFill>
+              </a:defRPr>
+            </a:pPr>
+            <a:r>
+              <a:t>Training</a:t>
+            </a:r>
+          </a:p>
+        </p:txBody>
+      </p:sp>
+      <p:sp>
+        <p:nvSpPr>
+          <p:cNvPr id="4" name="TextBox 3"/>
           <p:cNvSpPr txBox="1"/>
           <p:nvPr/>
         </p:nvSpPr>
         <p:spPr>
           <a:xfrm>
-            <a:off x="731520" y="1920240"/>
-            <a:ext cx="3017520" cy="1828800"/>
+            <a:off x="731520" y="1508760"/>
+            <a:ext cx="5029200" cy="765810"/>
           </a:xfrm>
           <a:prstGeom prst="rect">
             <a:avLst/>
@@ -5139,126 +5151,102 @@
           <a:noFill/>
         </p:spPr>
         <p:txBody>
-          <a:bodyPr wrap="square">
+          <a:bodyPr wrap="square" lIns="320040" tIns="18288">
             <a:spAutoFit/>
           </a:bodyPr>
           <a:lstStyle/>
           <a:p>
             <a:pPr>
               <a:spcAft>
-                <a:spcPts val="400"/>
+                <a:spcPts val="200"/>
               </a:spcAft>
-              <a:defRPr sz="2400">
+              <a:defRPr sz="2200">
                 <a:solidFill>
                   <a:srgbClr val="333333"/>
                 </a:solidFill>
               </a:defRPr>
-            </a:pPr>
-            <a:r>
-              <a:t>MMLU: -0.8pp</a:t>
+              <a:buChar char="•"/>
+            </a:pPr>
+            <a:r>
+              <a:t>Student: Qwen3.5-9B (Instruct variant)</a:t>
             </a:r>
           </a:p>
           <a:p>
             <a:pPr>
               <a:spcAft>
-                <a:spcPts val="400"/>
+                <a:spcPts val="200"/>
               </a:spcAft>
-              <a:defRPr sz="2400">
+              <a:defRPr sz="2200">
                 <a:solidFill>
                   <a:srgbClr val="333333"/>
                 </a:solidFill>
               </a:defRPr>
-            </a:pPr>
-            <a:r>
-              <a:t>HumanEval: 0.0pp</a:t>
+              <a:buChar char="•"/>
+            </a:pPr>
+            <a:r>
+              <a:t>Teacher: Qwen3.5-27B (generates DM answers only)</a:t>
             </a:r>
           </a:p>
           <a:p>
             <a:pPr>
               <a:spcAft>
-                <a:spcPts val="400"/>
+                <a:spcPts val="200"/>
               </a:spcAft>
-              <a:defRPr sz="2400">
+              <a:defRPr sz="2200">
                 <a:solidFill>
                   <a:srgbClr val="333333"/>
                 </a:solidFill>
               </a:defRPr>
-            </a:pPr>
-            <a:r>
-              <a:t>GPQA: -1.5pp</a:t>
+              <a:buChar char="•"/>
+            </a:pPr>
+            <a:r>
+              <a:t>QLoRA with NF4 quantization, rank 32, 7 target modules</a:t>
             </a:r>
           </a:p>
           <a:p>
             <a:pPr>
               <a:spcAft>
-                <a:spcPts val="400"/>
+                <a:spcPts val="200"/>
               </a:spcAft>
-              <a:defRPr sz="2400">
+              <a:defRPr sz="2200">
                 <a:solidFill>
                   <a:srgbClr val="333333"/>
                 </a:solidFill>
               </a:defRPr>
-            </a:pPr>
-            <a:r>
-              <a:t>All within binomial variance</a:t>
-            </a:r>
-          </a:p>
-        </p:txBody>
-      </p:sp>
-      <p:sp>
-        <p:nvSpPr>
-          <p:cNvPr id="6" name="Rectangle 5"/>
-          <p:cNvSpPr/>
-          <p:nvPr/>
-        </p:nvSpPr>
-        <p:spPr>
-          <a:xfrm>
-            <a:off x="4206240" y="1371600"/>
-            <a:ext cx="3474720" cy="2743200"/>
-          </a:xfrm>
-          <a:prstGeom prst="rect">
-            <a:avLst/>
-          </a:prstGeom>
-          <a:solidFill>
-            <a:srgbClr val="E3F2FD"/>
-          </a:solidFill>
-          <a:ln>
-            <a:noFill/>
-          </a:ln>
-          <a:effectLst/>
-        </p:spPr>
-        <p:style>
-          <a:lnRef idx="1">
-            <a:schemeClr val="accent1"/>
-          </a:lnRef>
-          <a:fillRef idx="3">
-            <a:schemeClr val="accent1"/>
-          </a:fillRef>
-          <a:effectRef idx="2">
-            <a:schemeClr val="accent1"/>
-          </a:effectRef>
-          <a:fontRef idx="minor">
-            <a:schemeClr val="lt1"/>
-          </a:fontRef>
-        </p:style>
-        <p:txBody>
-          <a:bodyPr rtlCol="0" anchor="ctr"/>
-          <a:lstStyle/>
-          <a:p>
-            <a:pPr algn="ctr"/>
-          </a:p>
-        </p:txBody>
-      </p:sp>
-      <p:sp>
-        <p:nvSpPr>
-          <p:cNvPr id="7" name="TextBox 6"/>
+              <a:buChar char="•"/>
+            </a:pPr>
+            <a:r>
+              <a:t>1,460 DM question-answer pairs, trained 3 epochs</a:t>
+            </a:r>
+          </a:p>
+          <a:p>
+            <a:pPr>
+              <a:spcAft>
+                <a:spcPts val="200"/>
+              </a:spcAft>
+              <a:defRPr sz="2200">
+                <a:solidFill>
+                  <a:srgbClr val="333333"/>
+                </a:solidFill>
+              </a:defRPr>
+              <a:buChar char="•"/>
+            </a:pPr>
+            <a:r>
+              <a:t>Single NVIDIA RTX 5090 (32 GB VRAM)</a:t>
+            </a:r>
+          </a:p>
+        </p:txBody>
+      </p:sp>
+      <p:sp>
+        <p:nvSpPr>
+          <p:cNvPr id="5" name="TextBox 4"/>
           <p:cNvSpPr txBox="1"/>
           <p:nvPr/>
         </p:nvSpPr>
         <p:spPr>
           <a:xfrm>
-            <a:off x="4389120" y="1463040"/>
-            <a:ext cx="3108960" cy="457200"/>
+            <a:off x="6400800" y="1143000"/>
+            <a:ext cx="5029200" cy="320040"/>
           </a:xfrm>
           <a:prstGeom prst="rect">
             <a:avLst/>
@@ -5266,34 +5254,34 @@
           <a:noFill/>
         </p:spPr>
         <p:txBody>
-          <a:bodyPr wrap="none">
+          <a:bodyPr wrap="square" lIns="137160" rIns="137160">
             <a:spAutoFit/>
           </a:bodyPr>
           <a:lstStyle/>
           <a:p>
-            <a:pPr>
-              <a:defRPr sz="2600" b="1">
-                <a:solidFill>
-                  <a:srgbClr val="1565C0"/>
-                </a:solidFill>
-              </a:defRPr>
-            </a:pPr>
-            <a:r>
-              <a:t>Formal Causal: +38.3pp</a:t>
-            </a:r>
-          </a:p>
-        </p:txBody>
-      </p:sp>
-      <p:sp>
-        <p:nvSpPr>
-          <p:cNvPr id="8" name="TextBox 7"/>
+            <a:pPr algn="l">
+              <a:defRPr sz="2200" b="1">
+                <a:solidFill>
+                  <a:srgbClr val="7B2D8E"/>
+                </a:solidFill>
+              </a:defRPr>
+            </a:pPr>
+            <a:r>
+              <a:t>Evaluation</a:t>
+            </a:r>
+          </a:p>
+        </p:txBody>
+      </p:sp>
+      <p:sp>
+        <p:nvSpPr>
+          <p:cNvPr id="6" name="TextBox 5"/>
           <p:cNvSpPr txBox="1"/>
           <p:nvPr/>
         </p:nvSpPr>
         <p:spPr>
           <a:xfrm>
-            <a:off x="4480560" y="1920240"/>
-            <a:ext cx="3017520" cy="1828800"/>
+            <a:off x="6400800" y="1508760"/>
+            <a:ext cx="5029200" cy="640080"/>
           </a:xfrm>
           <a:prstGeom prst="rect">
             <a:avLst/>
@@ -5301,126 +5289,86 @@
           <a:noFill/>
         </p:spPr>
         <p:txBody>
-          <a:bodyPr wrap="square">
+          <a:bodyPr wrap="square" lIns="320040" tIns="18288">
             <a:spAutoFit/>
           </a:bodyPr>
           <a:lstStyle/>
           <a:p>
             <a:pPr>
               <a:spcAft>
-                <a:spcPts val="400"/>
+                <a:spcPts val="200"/>
               </a:spcAft>
-              <a:defRPr sz="2400">
+              <a:defRPr sz="2200">
                 <a:solidFill>
                   <a:srgbClr val="333333"/>
                 </a:solidFill>
               </a:defRPr>
-            </a:pPr>
-            <a:r>
-              <a:t>Corr2Cause</a:t>
+              <a:buChar char="•"/>
+            </a:pPr>
+            <a:r>
+              <a:t>All benchmarks: bf16 precision, 0-shot greedy decoding</a:t>
             </a:r>
           </a:p>
           <a:p>
             <a:pPr>
               <a:spcAft>
-                <a:spcPts val="400"/>
+                <a:spcPts val="200"/>
               </a:spcAft>
-              <a:defRPr sz="2400">
+              <a:defRPr sz="2200">
                 <a:solidFill>
                   <a:srgbClr val="333333"/>
                 </a:solidFill>
               </a:defRPr>
-            </a:pPr>
-            <a:r>
-              <a:t>Corrects 520 baseline errors</a:t>
+              <a:buChar char="•"/>
+            </a:pPr>
+            <a:r>
+              <a:t>General capability: MMLU, HumanEval, GPQA Diamond</a:t>
             </a:r>
           </a:p>
           <a:p>
             <a:pPr>
               <a:spcAft>
-                <a:spcPts val="400"/>
+                <a:spcPts val="200"/>
               </a:spcAft>
-              <a:defRPr sz="2400">
+              <a:defRPr sz="2200">
                 <a:solidFill>
                   <a:srgbClr val="333333"/>
                 </a:solidFill>
               </a:defRPr>
-            </a:pPr>
-            <a:r>
-              <a:t>Introduces only 75 new errors</a:t>
+              <a:buChar char="•"/>
+            </a:pPr>
+            <a:r>
+              <a:t>Formal causal logic: Corr2Cause (1,162 samples)</a:t>
             </a:r>
           </a:p>
           <a:p>
             <a:pPr>
               <a:spcAft>
-                <a:spcPts val="400"/>
+                <a:spcPts val="200"/>
               </a:spcAft>
-              <a:defRPr sz="2400">
+              <a:defRPr sz="2200">
                 <a:solidFill>
                   <a:srgbClr val="333333"/>
                 </a:solidFill>
               </a:defRPr>
-            </a:pPr>
-            <a:r>
-              <a:t>Net gain: +445</a:t>
-            </a:r>
-          </a:p>
-        </p:txBody>
-      </p:sp>
-      <p:sp>
-        <p:nvSpPr>
-          <p:cNvPr id="9" name="Rectangle 8"/>
-          <p:cNvSpPr/>
-          <p:nvPr/>
-        </p:nvSpPr>
-        <p:spPr>
-          <a:xfrm>
-            <a:off x="7955280" y="1371600"/>
-            <a:ext cx="3474720" cy="2743200"/>
-          </a:xfrm>
-          <a:prstGeom prst="rect">
-            <a:avLst/>
-          </a:prstGeom>
-          <a:solidFill>
-            <a:srgbClr val="FCE4EC"/>
-          </a:solidFill>
-          <a:ln>
-            <a:noFill/>
-          </a:ln>
-          <a:effectLst/>
-        </p:spPr>
-        <p:style>
-          <a:lnRef idx="1">
-            <a:schemeClr val="accent1"/>
-          </a:lnRef>
-          <a:fillRef idx="3">
-            <a:schemeClr val="accent1"/>
-          </a:fillRef>
-          <a:effectRef idx="2">
-            <a:schemeClr val="accent1"/>
-          </a:effectRef>
-          <a:fontRef idx="minor">
-            <a:schemeClr val="lt1"/>
-          </a:fontRef>
-        </p:style>
-        <p:txBody>
-          <a:bodyPr rtlCol="0" anchor="ctr"/>
-          <a:lstStyle/>
-          <a:p>
-            <a:pPr algn="ctr"/>
-          </a:p>
-        </p:txBody>
-      </p:sp>
-      <p:sp>
-        <p:nvSpPr>
-          <p:cNvPr id="10" name="TextBox 9"/>
+              <a:buChar char="•"/>
+            </a:pPr>
+            <a:r>
+              <a:t>Applied causal reasoning: EconCausal (3,943 samples)</a:t>
+            </a:r>
+          </a:p>
+        </p:txBody>
+      </p:sp>
+      <p:sp>
+        <p:nvSpPr>
+          <p:cNvPr id="7" name="TextBox 6"/>
           <p:cNvSpPr txBox="1"/>
           <p:nvPr/>
         </p:nvSpPr>
         <p:spPr>
           <a:xfrm>
-            <a:off x="8138160" y="1463040"/>
-            <a:ext cx="3108960" cy="457200"/>
+            <a:off x="731520" y="5486400"/>
+            <a:ext cx="10698480" cy="365760"/>
           </a:xfrm>
           <a:prstGeom prst="rect">
             <a:avLst/>
@@ -5428,103 +5376,20 @@
           <a:noFill/>
         </p:spPr>
         <p:txBody>
-          <a:bodyPr wrap="none">
+          <a:bodyPr wrap="square" lIns="137160" rIns="137160">
             <a:spAutoFit/>
           </a:bodyPr>
           <a:lstStyle/>
           <a:p>
-            <a:pPr>
-              <a:defRPr sz="2600" b="1">
-                <a:solidFill>
-                  <a:srgbClr val="C62828"/>
-                </a:solidFill>
-              </a:defRPr>
-            </a:pPr>
-            <a:r>
-              <a:t>Applied Causal: -12.4pp</a:t>
-            </a:r>
-          </a:p>
-        </p:txBody>
-      </p:sp>
-      <p:sp>
-        <p:nvSpPr>
-          <p:cNvPr id="11" name="TextBox 10"/>
-          <p:cNvSpPr txBox="1"/>
-          <p:nvPr/>
-        </p:nvSpPr>
-        <p:spPr>
-          <a:xfrm>
-            <a:off x="8229600" y="1920240"/>
-            <a:ext cx="3017520" cy="1828800"/>
-          </a:xfrm>
-          <a:prstGeom prst="rect">
-            <a:avLst/>
-          </a:prstGeom>
-          <a:noFill/>
-        </p:spPr>
-        <p:txBody>
-          <a:bodyPr wrap="square">
-            <a:spAutoFit/>
-          </a:bodyPr>
-          <a:lstStyle/>
-          <a:p>
-            <a:pPr>
-              <a:spcAft>
-                <a:spcPts val="400"/>
-              </a:spcAft>
-              <a:defRPr sz="2400">
-                <a:solidFill>
-                  <a:srgbClr val="333333"/>
-                </a:solidFill>
-              </a:defRPr>
-            </a:pPr>
-            <a:r>
-              <a:t>EconCausal Task1: -12.4pp</a:t>
-            </a:r>
-          </a:p>
-          <a:p>
-            <a:pPr>
-              <a:spcAft>
-                <a:spcPts val="400"/>
-              </a:spcAft>
-              <a:defRPr sz="2400">
-                <a:solidFill>
-                  <a:srgbClr val="333333"/>
-                </a:solidFill>
-              </a:defRPr>
-            </a:pPr>
-            <a:r>
-              <a:t>Task1 Finance: -13.5pp</a:t>
-            </a:r>
-          </a:p>
-          <a:p>
-            <a:pPr>
-              <a:spcAft>
-                <a:spcPts val="400"/>
-              </a:spcAft>
-              <a:defRPr sz="2400">
-                <a:solidFill>
-                  <a:srgbClr val="333333"/>
-                </a:solidFill>
-              </a:defRPr>
-            </a:pPr>
-            <a:r>
-              <a:t>Task3: -10.8pp</a:t>
-            </a:r>
-          </a:p>
-          <a:p>
-            <a:pPr>
-              <a:spcAft>
-                <a:spcPts val="400"/>
-              </a:spcAft>
-              <a:defRPr sz="2400">
-                <a:solidFill>
-                  <a:srgbClr val="333333"/>
-                </a:solidFill>
-              </a:defRPr>
-            </a:pPr>
-            <a:r>
-              <a:t>All highly significant</a:t>
+            <a:pPr algn="ctr">
+              <a:defRPr sz="1600" b="0">
+                <a:solidFill>
+                  <a:srgbClr val="666666"/>
+                </a:solidFill>
+              </a:defRPr>
+            </a:pPr>
+            <a:r>
+              <a:t>QLoRA = quantized LoRA (parameter-efficient fine-tuning) | NF4 = 4-bit normalfloat quantization</a:t>
             </a:r>
           </a:p>
         </p:txBody>
@@ -5563,8 +5428,8 @@
         </p:nvSpPr>
         <p:spPr>
           <a:xfrm>
-            <a:off x="0" y="274320"/>
-            <a:ext cx="12191695" cy="822960"/>
+            <a:off x="0" y="0"/>
+            <a:ext cx="12191695" cy="1051560"/>
           </a:xfrm>
           <a:prstGeom prst="rect">
             <a:avLst/>
@@ -5574,23 +5439,20 @@
           </a:solidFill>
         </p:spPr>
         <p:txBody>
-          <a:bodyPr wrap="square" lIns="548640" tIns="137160">
+          <a:bodyPr wrap="square" lIns="548640" tIns="91440">
             <a:spAutoFit/>
           </a:bodyPr>
           <a:lstStyle/>
           <a:p>
-            <a:pPr algn="l">
-              <a:spcAft>
-                <a:spcPts val="0"/>
-              </a:spcAft>
-              <a:defRPr sz="3600" b="1">
+            <a:pPr>
+              <a:defRPr sz="3200" b="1">
                 <a:solidFill>
                   <a:srgbClr val="FFFFFF"/>
                 </a:solidFill>
               </a:defRPr>
             </a:pPr>
             <a:r>
-              <a:t>The Hedging Artifact</a:t>
+              <a:t>Three Divergent Outcomes</a:t>
             </a:r>
           </a:p>
         </p:txBody>
@@ -5603,14 +5465,14 @@
         </p:nvSpPr>
         <p:spPr>
           <a:xfrm>
-            <a:off x="548640" y="1371600"/>
-            <a:ext cx="10515600" cy="3246120"/>
+            <a:off x="457200" y="1143000"/>
+            <a:ext cx="3291840" cy="4114800"/>
           </a:xfrm>
           <a:prstGeom prst="rect">
             <a:avLst/>
           </a:prstGeom>
           <a:solidFill>
-            <a:srgbClr val="FCE4EC"/>
+            <a:srgbClr val="E8F5E9"/>
           </a:solidFill>
           <a:ln>
             <a:noFill/>
@@ -5647,8 +5509,8 @@
         </p:nvSpPr>
         <p:spPr>
           <a:xfrm>
-            <a:off x="731520" y="1463040"/>
-            <a:ext cx="10149840" cy="457200"/>
+            <a:off x="640080" y="1280160"/>
+            <a:ext cx="2926080" cy="365760"/>
           </a:xfrm>
           <a:prstGeom prst="rect">
             <a:avLst/>
@@ -5656,20 +5518,20 @@
           <a:noFill/>
         </p:spPr>
         <p:txBody>
-          <a:bodyPr wrap="none">
+          <a:bodyPr wrap="square" lIns="137160" rIns="137160">
             <a:spAutoFit/>
           </a:bodyPr>
           <a:lstStyle/>
           <a:p>
-            <a:pPr>
-              <a:defRPr sz="2600" b="1">
-                <a:solidFill>
-                  <a:srgbClr val="C62828"/>
-                </a:solidFill>
-              </a:defRPr>
-            </a:pPr>
-            <a:r>
-              <a:t>Dominant Failure Mode: Positive-to-Mixed Hedging</a:t>
+            <a:pPr algn="l">
+              <a:defRPr sz="2100" b="1">
+                <a:solidFill>
+                  <a:srgbClr val="2E7D32"/>
+                </a:solidFill>
+              </a:defRPr>
+            </a:pPr>
+            <a:r>
+              <a:t>General: Preserved</a:t>
             </a:r>
           </a:p>
         </p:txBody>
@@ -5682,8 +5544,8 @@
         </p:nvSpPr>
         <p:spPr>
           <a:xfrm>
-            <a:off x="822960" y="1920240"/>
-            <a:ext cx="10058400" cy="2286000"/>
+            <a:off x="640080" y="1691640"/>
+            <a:ext cx="2926080" cy="594360"/>
           </a:xfrm>
           <a:prstGeom prst="rect">
             <a:avLst/>
@@ -5691,83 +5553,72 @@
           <a:noFill/>
         </p:spPr>
         <p:txBody>
-          <a:bodyPr wrap="square">
+          <a:bodyPr wrap="square" lIns="320040" tIns="18288">
             <a:spAutoFit/>
           </a:bodyPr>
           <a:lstStyle/>
           <a:p>
             <a:pPr>
               <a:spcAft>
-                <a:spcPts val="400"/>
+                <a:spcPts val="200"/>
               </a:spcAft>
-              <a:defRPr sz="2400">
+              <a:defRPr sz="2000">
                 <a:solidFill>
                   <a:srgbClr val="333333"/>
                 </a:solidFill>
               </a:defRPr>
-            </a:pPr>
-            <a:r>
-              <a:t>Finetuned model converts correct '+' predictions to ambiguous 'mixed'</a:t>
+              <a:buChar char="•"/>
+            </a:pPr>
+            <a:r>
+              <a:t>MMLU: -0.8pp (within noise)</a:t>
             </a:r>
           </a:p>
           <a:p>
             <a:pPr>
               <a:spcAft>
-                <a:spcPts val="400"/>
+                <a:spcPts val="200"/>
               </a:spcAft>
-              <a:defRPr sz="2400">
+              <a:defRPr sz="2000">
                 <a:solidFill>
                   <a:srgbClr val="333333"/>
                 </a:solidFill>
               </a:defRPr>
-            </a:pPr>
-            <a:r>
-              <a:t>Task1 Econ: + to mixed = 96 of 182 regressions (52.7%)</a:t>
+              <a:buChar char="•"/>
+            </a:pPr>
+            <a:r>
+              <a:t>HumanEval: 0.0pp (identical)</a:t>
             </a:r>
           </a:p>
           <a:p>
             <a:pPr>
               <a:spcAft>
-                <a:spcPts val="400"/>
+                <a:spcPts val="200"/>
               </a:spcAft>
-              <a:defRPr sz="2400">
+              <a:defRPr sz="2000">
                 <a:solidFill>
                   <a:srgbClr val="333333"/>
                 </a:solidFill>
               </a:defRPr>
-            </a:pPr>
-            <a:r>
-              <a:t>Task1 Finance: 95 of 174 (54.6%)</a:t>
+              <a:buChar char="•"/>
+            </a:pPr>
+            <a:r>
+              <a:t>GPQA: -1.5pp (within noise)</a:t>
             </a:r>
           </a:p>
           <a:p>
             <a:pPr>
               <a:spcAft>
-                <a:spcPts val="400"/>
+                <a:spcPts val="200"/>
               </a:spcAft>
-              <a:defRPr sz="2400">
+              <a:defRPr sz="2000">
                 <a:solidFill>
                   <a:srgbClr val="333333"/>
                 </a:solidFill>
               </a:defRPr>
-            </a:pPr>
-            <a:r>
-              <a:t>Positive-effect conversion: 77-85% of all Task1 regressions</a:t>
-            </a:r>
-          </a:p>
-          <a:p>
-            <a:pPr>
-              <a:spcAft>
-                <a:spcPts val="400"/>
-              </a:spcAft>
-              <a:defRPr sz="2400">
-                <a:solidFill>
-                  <a:srgbClr val="333333"/>
-                </a:solidFill>
-              </a:defRPr>
-            </a:pPr>
-            <a:r>
-              <a:t>Hedging ABSENT from training data (teacher rate: 4.0%)</a:t>
+              <a:buChar char="•"/>
+            </a:pPr>
+            <a:r>
+              <a:t>No catastrophic forgetting</a:t>
             </a:r>
           </a:p>
         </p:txBody>
@@ -5780,14 +5631,14 @@
         </p:nvSpPr>
         <p:spPr>
           <a:xfrm>
-            <a:off x="548640" y="4389120"/>
-            <a:ext cx="10515600" cy="2743200"/>
+            <a:off x="4069079" y="1143000"/>
+            <a:ext cx="3291840" cy="4114800"/>
           </a:xfrm>
           <a:prstGeom prst="rect">
             <a:avLst/>
           </a:prstGeom>
           <a:solidFill>
-            <a:srgbClr val="F8F4FC"/>
+            <a:srgbClr val="E3F2FD"/>
           </a:solidFill>
           <a:ln>
             <a:noFill/>
@@ -5824,8 +5675,8 @@
         </p:nvSpPr>
         <p:spPr>
           <a:xfrm>
-            <a:off x="731520" y="4480560"/>
-            <a:ext cx="10149840" cy="457200"/>
+            <a:off x="4251959" y="1280160"/>
+            <a:ext cx="2926080" cy="365760"/>
           </a:xfrm>
           <a:prstGeom prst="rect">
             <a:avLst/>
@@ -5833,20 +5684,20 @@
           <a:noFill/>
         </p:spPr>
         <p:txBody>
-          <a:bodyPr wrap="none">
+          <a:bodyPr wrap="square" lIns="137160" rIns="137160">
             <a:spAutoFit/>
           </a:bodyPr>
           <a:lstStyle/>
           <a:p>
-            <a:pPr>
-              <a:defRPr sz="2600" b="1">
-                <a:solidFill>
-                  <a:srgbClr val="7B2D8E"/>
-                </a:solidFill>
-              </a:defRPr>
-            </a:pPr>
-            <a:r>
-              <a:t>Mechanism: Transferred Epistemic Prior</a:t>
+            <a:pPr algn="l">
+              <a:defRPr sz="2100" b="1">
+                <a:solidFill>
+                  <a:srgbClr val="1565C0"/>
+                </a:solidFill>
+              </a:defRPr>
+            </a:pPr>
+            <a:r>
+              <a:t>Formal Causal: +38.3pp</a:t>
             </a:r>
           </a:p>
         </p:txBody>
@@ -5859,8 +5710,8 @@
         </p:nvSpPr>
         <p:spPr>
           <a:xfrm>
-            <a:off x="822960" y="4937760"/>
-            <a:ext cx="10058400" cy="1828800"/>
+            <a:off x="4251959" y="1691640"/>
+            <a:ext cx="2926080" cy="594360"/>
           </a:xfrm>
           <a:prstGeom prst="rect">
             <a:avLst/>
@@ -5868,68 +5719,238 @@
           <a:noFill/>
         </p:spPr>
         <p:txBody>
-          <a:bodyPr wrap="square">
+          <a:bodyPr wrap="square" lIns="320040" tIns="18288">
             <a:spAutoFit/>
           </a:bodyPr>
           <a:lstStyle/>
           <a:p>
             <a:pPr>
               <a:spcAft>
-                <a:spcPts val="400"/>
+                <a:spcPts val="200"/>
               </a:spcAft>
-              <a:defRPr sz="2400">
+              <a:defRPr sz="2000">
                 <a:solidFill>
                   <a:srgbClr val="333333"/>
                 </a:solidFill>
               </a:defRPr>
-            </a:pPr>
-            <a:r>
-              <a:t>Model learns DM principles: 'outcomes depend on material conditions',</a:t>
+              <a:buChar char="•"/>
+            </a:pPr>
+            <a:r>
+              <a:t>Corr2Cause: 36.3% -&gt; 74.6%</a:t>
             </a:r>
           </a:p>
           <a:p>
             <a:pPr>
               <a:spcAft>
-                <a:spcPts val="400"/>
+                <a:spcPts val="200"/>
               </a:spcAft>
-              <a:defRPr sz="2400">
+              <a:defRPr sz="2000">
                 <a:solidFill>
                   <a:srgbClr val="333333"/>
                 </a:solidFill>
               </a:defRPr>
-            </a:pPr>
-            <a:r>
-              <a:t>'effects mediated by power relations', 'cannot reduce to single direction'</a:t>
+              <a:buChar char="•"/>
+            </a:pPr>
+            <a:r>
+              <a:t>Corrects 520 baseline errors</a:t>
             </a:r>
           </a:p>
           <a:p>
             <a:pPr>
               <a:spcAft>
-                <a:spcPts val="400"/>
+                <a:spcPts val="200"/>
               </a:spcAft>
-              <a:defRPr sz="2400">
+              <a:defRPr sz="2000">
                 <a:solidFill>
                   <a:srgbClr val="333333"/>
                 </a:solidFill>
               </a:defRPr>
-            </a:pPr>
-            <a:r>
-              <a:t>Applies skepticism INDISCRIMINATELY to empirical economics questions</a:t>
+              <a:buChar char="•"/>
+            </a:pPr>
+            <a:r>
+              <a:t>Only 75 new errors introduced</a:t>
             </a:r>
           </a:p>
           <a:p>
             <a:pPr>
               <a:spcAft>
-                <a:spcPts val="400"/>
+                <a:spcPts val="200"/>
               </a:spcAft>
-              <a:defRPr sz="2400">
+              <a:defRPr sz="2000">
                 <a:solidFill>
                   <a:srgbClr val="333333"/>
                 </a:solidFill>
               </a:defRPr>
-            </a:pPr>
-            <a:r>
-              <a:t>Not a reasoning error -- a transferred epistemic prior</a:t>
+              <a:buChar char="•"/>
+            </a:pPr>
+            <a:r>
+              <a:t>Net gain: +445 correct answers</a:t>
+            </a:r>
+          </a:p>
+        </p:txBody>
+      </p:sp>
+      <p:sp>
+        <p:nvSpPr>
+          <p:cNvPr id="9" name="Rectangle 8"/>
+          <p:cNvSpPr/>
+          <p:nvPr/>
+        </p:nvSpPr>
+        <p:spPr>
+          <a:xfrm>
+            <a:off x="7680960" y="1143000"/>
+            <a:ext cx="3291840" cy="4114800"/>
+          </a:xfrm>
+          <a:prstGeom prst="rect">
+            <a:avLst/>
+          </a:prstGeom>
+          <a:solidFill>
+            <a:srgbClr val="FCE4EC"/>
+          </a:solidFill>
+          <a:ln>
+            <a:noFill/>
+          </a:ln>
+          <a:effectLst/>
+        </p:spPr>
+        <p:style>
+          <a:lnRef idx="1">
+            <a:schemeClr val="accent1"/>
+          </a:lnRef>
+          <a:fillRef idx="3">
+            <a:schemeClr val="accent1"/>
+          </a:fillRef>
+          <a:effectRef idx="2">
+            <a:schemeClr val="accent1"/>
+          </a:effectRef>
+          <a:fontRef idx="minor">
+            <a:schemeClr val="lt1"/>
+          </a:fontRef>
+        </p:style>
+        <p:txBody>
+          <a:bodyPr rtlCol="0" anchor="ctr"/>
+          <a:lstStyle/>
+          <a:p>
+            <a:pPr algn="ctr"/>
+          </a:p>
+        </p:txBody>
+      </p:sp>
+      <p:sp>
+        <p:nvSpPr>
+          <p:cNvPr id="10" name="TextBox 9"/>
+          <p:cNvSpPr txBox="1"/>
+          <p:nvPr/>
+        </p:nvSpPr>
+        <p:spPr>
+          <a:xfrm>
+            <a:off x="7863840" y="1280160"/>
+            <a:ext cx="2926080" cy="365760"/>
+          </a:xfrm>
+          <a:prstGeom prst="rect">
+            <a:avLst/>
+          </a:prstGeom>
+          <a:noFill/>
+        </p:spPr>
+        <p:txBody>
+          <a:bodyPr wrap="square" lIns="137160" rIns="137160">
+            <a:spAutoFit/>
+          </a:bodyPr>
+          <a:lstStyle/>
+          <a:p>
+            <a:pPr algn="l">
+              <a:defRPr sz="2100" b="1">
+                <a:solidFill>
+                  <a:srgbClr val="C62828"/>
+                </a:solidFill>
+              </a:defRPr>
+            </a:pPr>
+            <a:r>
+              <a:t>Applied Causal: -12.4pp</a:t>
+            </a:r>
+          </a:p>
+        </p:txBody>
+      </p:sp>
+      <p:sp>
+        <p:nvSpPr>
+          <p:cNvPr id="11" name="TextBox 10"/>
+          <p:cNvSpPr txBox="1"/>
+          <p:nvPr/>
+        </p:nvSpPr>
+        <p:spPr>
+          <a:xfrm>
+            <a:off x="7863840" y="1691640"/>
+            <a:ext cx="2926080" cy="594360"/>
+          </a:xfrm>
+          <a:prstGeom prst="rect">
+            <a:avLst/>
+          </a:prstGeom>
+          <a:noFill/>
+        </p:spPr>
+        <p:txBody>
+          <a:bodyPr wrap="square" lIns="320040" tIns="18288">
+            <a:spAutoFit/>
+          </a:bodyPr>
+          <a:lstStyle/>
+          <a:p>
+            <a:pPr>
+              <a:spcAft>
+                <a:spcPts val="200"/>
+              </a:spcAft>
+              <a:defRPr sz="2000">
+                <a:solidFill>
+                  <a:srgbClr val="333333"/>
+                </a:solidFill>
+              </a:defRPr>
+              <a:buChar char="•"/>
+            </a:pPr>
+            <a:r>
+              <a:t>Task1 Econ: 60.3% -&gt; 47.9%</a:t>
+            </a:r>
+          </a:p>
+          <a:p>
+            <a:pPr>
+              <a:spcAft>
+                <a:spcPts val="200"/>
+              </a:spcAft>
+              <a:defRPr sz="2000">
+                <a:solidFill>
+                  <a:srgbClr val="333333"/>
+                </a:solidFill>
+              </a:defRPr>
+              <a:buChar char="•"/>
+            </a:pPr>
+            <a:r>
+              <a:t>Task1 Finance: 56.5% -&gt; 43.0%</a:t>
+            </a:r>
+          </a:p>
+          <a:p>
+            <a:pPr>
+              <a:spcAft>
+                <a:spcPts val="200"/>
+              </a:spcAft>
+              <a:defRPr sz="2000">
+                <a:solidFill>
+                  <a:srgbClr val="333333"/>
+                </a:solidFill>
+              </a:defRPr>
+              <a:buChar char="•"/>
+            </a:pPr>
+            <a:r>
+              <a:t>Task3: 22.2% -&gt; 11.4%</a:t>
+            </a:r>
+          </a:p>
+          <a:p>
+            <a:pPr>
+              <a:spcAft>
+                <a:spcPts val="200"/>
+              </a:spcAft>
+              <a:defRPr sz="2000">
+                <a:solidFill>
+                  <a:srgbClr val="333333"/>
+                </a:solidFill>
+              </a:defRPr>
+              <a:buChar char="•"/>
+            </a:pPr>
+            <a:r>
+              <a:t>All regressions highly significant</a:t>
             </a:r>
           </a:p>
         </p:txBody>
@@ -5968,8 +5989,8 @@
         </p:nvSpPr>
         <p:spPr>
           <a:xfrm>
-            <a:off x="0" y="274320"/>
-            <a:ext cx="12191695" cy="822960"/>
+            <a:off x="0" y="0"/>
+            <a:ext cx="12191695" cy="1051560"/>
           </a:xfrm>
           <a:prstGeom prst="rect">
             <a:avLst/>
@@ -5979,319 +6000,40 @@
           </a:solidFill>
         </p:spPr>
         <p:txBody>
-          <a:bodyPr wrap="square" lIns="548640" tIns="137160">
+          <a:bodyPr wrap="square" lIns="548640" tIns="91440">
             <a:spAutoFit/>
           </a:bodyPr>
           <a:lstStyle/>
           <a:p>
-            <a:pPr algn="l">
-              <a:spcAft>
-                <a:spcPts val="0"/>
-              </a:spcAft>
-              <a:defRPr sz="3600" b="1">
+            <a:pPr>
+              <a:defRPr sz="3200" b="1">
                 <a:solidFill>
                   <a:srgbClr val="FFFFFF"/>
                 </a:solidFill>
               </a:defRPr>
             </a:pPr>
             <a:r>
-              <a:t>Why Corr2Cause Improves While EconCausal Regresses</a:t>
-            </a:r>
-          </a:p>
-        </p:txBody>
-      </p:sp>
-      <p:sp>
-        <p:nvSpPr>
-          <p:cNvPr id="3" name="TextBox 2"/>
-          <p:cNvSpPr txBox="1"/>
-          <p:nvPr/>
-        </p:nvSpPr>
-        <p:spPr>
-          <a:xfrm>
-            <a:off x="548640" y="1005840"/>
-            <a:ext cx="5303520" cy="457200"/>
-          </a:xfrm>
-          <a:prstGeom prst="rect">
-            <a:avLst/>
-          </a:prstGeom>
-          <a:noFill/>
-        </p:spPr>
-        <p:txBody>
-          <a:bodyPr wrap="none">
-            <a:spAutoFit/>
-          </a:bodyPr>
-          <a:lstStyle/>
-          <a:p>
-            <a:pPr>
-              <a:defRPr sz="2600" b="1">
-                <a:solidFill>
-                  <a:srgbClr val="7B2D8E"/>
-                </a:solidFill>
-              </a:defRPr>
-            </a:pPr>
-            <a:r>
-              <a:t>Corr2Cause: +38.3pp</a:t>
-            </a:r>
-          </a:p>
-        </p:txBody>
-      </p:sp>
-      <p:sp>
-        <p:nvSpPr>
-          <p:cNvPr id="4" name="TextBox 3"/>
-          <p:cNvSpPr txBox="1"/>
-          <p:nvPr/>
-        </p:nvSpPr>
-        <p:spPr>
-          <a:xfrm>
-            <a:off x="548640" y="1371600"/>
-            <a:ext cx="5303520" cy="4572000"/>
-          </a:xfrm>
-          <a:prstGeom prst="rect">
-            <a:avLst/>
-          </a:prstGeom>
-          <a:noFill/>
-        </p:spPr>
-        <p:txBody>
-          <a:bodyPr wrap="square">
-            <a:spAutoFit/>
-          </a:bodyPr>
-          <a:lstStyle/>
-          <a:p>
-            <a:pPr>
-              <a:spcAft>
-                <a:spcPts val="800"/>
-              </a:spcAft>
-              <a:defRPr sz="2400">
-                <a:solidFill>
-                  <a:srgbClr val="333333"/>
-                </a:solidFill>
-              </a:defRPr>
-              <a:buChar char="•"/>
-            </a:pPr>
-            <a:r>
-              <a:t>Formal structural analysis</a:t>
-            </a:r>
-          </a:p>
-          <a:p>
-            <a:pPr>
-              <a:spcAft>
-                <a:spcPts val="800"/>
-              </a:spcAft>
-              <a:defRPr sz="2400">
-                <a:solidFill>
-                  <a:srgbClr val="333333"/>
-                </a:solidFill>
-              </a:defRPr>
-              <a:buChar char="•"/>
-            </a:pPr>
-            <a:r>
-              <a:t>Conditional independence reasoning</a:t>
-            </a:r>
-          </a:p>
-          <a:p>
-            <a:pPr>
-              <a:spcAft>
-                <a:spcPts val="800"/>
-              </a:spcAft>
-              <a:defRPr sz="2400">
-                <a:solidFill>
-                  <a:srgbClr val="333333"/>
-                </a:solidFill>
-              </a:defRPr>
-              <a:buChar char="•"/>
-            </a:pPr>
-            <a:r>
-              <a:t>DM training STRENGTHENS: trace dependencies, identify confounders</a:t>
-            </a:r>
-          </a:p>
-          <a:p>
-            <a:pPr>
-              <a:spcAft>
-                <a:spcPts val="800"/>
-              </a:spcAft>
-              <a:defRPr sz="2400">
-                <a:solidFill>
-                  <a:srgbClr val="333333"/>
-                </a:solidFill>
-              </a:defRPr>
-              <a:buChar char="•"/>
-            </a:pPr>
-            <a:r>
-              <a:t>Non-child descendant: 13.0% -&gt; 94.3% (+81.3pp)</a:t>
-            </a:r>
-          </a:p>
-          <a:p>
-            <a:pPr>
-              <a:spcAft>
-                <a:spcPts val="800"/>
-              </a:spcAft>
-              <a:defRPr sz="2400">
-                <a:solidFill>
-                  <a:srgbClr val="333333"/>
-                </a:solidFill>
-              </a:defRPr>
-              <a:buChar char="•"/>
-            </a:pPr>
-            <a:r>
-              <a:t>Non-parent ancestor: 14.4% -&gt; 87.2% (+72.8pp)</a:t>
-            </a:r>
-          </a:p>
-        </p:txBody>
-      </p:sp>
-      <p:sp>
-        <p:nvSpPr>
-          <p:cNvPr id="5" name="TextBox 4"/>
-          <p:cNvSpPr txBox="1"/>
-          <p:nvPr/>
-        </p:nvSpPr>
-        <p:spPr>
-          <a:xfrm>
-            <a:off x="6492240" y="1005840"/>
-            <a:ext cx="5303520" cy="457200"/>
-          </a:xfrm>
-          <a:prstGeom prst="rect">
-            <a:avLst/>
-          </a:prstGeom>
-          <a:noFill/>
-        </p:spPr>
-        <p:txBody>
-          <a:bodyPr wrap="none">
-            <a:spAutoFit/>
-          </a:bodyPr>
-          <a:lstStyle/>
-          <a:p>
-            <a:pPr>
-              <a:defRPr sz="2600" b="1">
-                <a:solidFill>
-                  <a:srgbClr val="7B2D8E"/>
-                </a:solidFill>
-              </a:defRPr>
-            </a:pPr>
-            <a:r>
-              <a:t>EconCausal: -12.4pp</a:t>
-            </a:r>
-          </a:p>
-        </p:txBody>
-      </p:sp>
-      <p:sp>
-        <p:nvSpPr>
-          <p:cNvPr id="6" name="TextBox 5"/>
-          <p:cNvSpPr txBox="1"/>
-          <p:nvPr/>
-        </p:nvSpPr>
-        <p:spPr>
-          <a:xfrm>
-            <a:off x="6492240" y="1371600"/>
-            <a:ext cx="5303520" cy="4572000"/>
-          </a:xfrm>
-          <a:prstGeom prst="rect">
-            <a:avLst/>
-          </a:prstGeom>
-          <a:noFill/>
-        </p:spPr>
-        <p:txBody>
-          <a:bodyPr wrap="square">
-            <a:spAutoFit/>
-          </a:bodyPr>
-          <a:lstStyle/>
-          <a:p>
-            <a:pPr>
-              <a:spcAft>
-                <a:spcPts val="800"/>
-              </a:spcAft>
-              <a:defRPr sz="2400">
-                <a:solidFill>
-                  <a:srgbClr val="333333"/>
-                </a:solidFill>
-              </a:defRPr>
-              <a:buChar char="•"/>
-            </a:pPr>
-            <a:r>
-              <a:t>Applied causal identification</a:t>
-            </a:r>
-          </a:p>
-          <a:p>
-            <a:pPr>
-              <a:spcAft>
-                <a:spcPts val="800"/>
-              </a:spcAft>
-              <a:defRPr sz="2400">
-                <a:solidFill>
-                  <a:srgbClr val="333333"/>
-                </a:solidFill>
-              </a:defRPr>
-              <a:buChar char="•"/>
-            </a:pPr>
-            <a:r>
-              <a:t>Predicting directional effects from empirical context</a:t>
-            </a:r>
-          </a:p>
-          <a:p>
-            <a:pPr>
-              <a:spcAft>
-                <a:spcPts val="800"/>
-              </a:spcAft>
-              <a:defRPr sz="2400">
-                <a:solidFill>
-                  <a:srgbClr val="333333"/>
-                </a:solidFill>
-              </a:defRPr>
-              <a:buChar char="•"/>
-            </a:pPr>
-            <a:r>
-              <a:t>DM skepticism prior OVERRIDES empirical claims</a:t>
-            </a:r>
-          </a:p>
-          <a:p>
-            <a:pPr>
-              <a:spcAft>
-                <a:spcPts val="800"/>
-              </a:spcAft>
-              <a:defRPr sz="2400">
-                <a:solidFill>
-                  <a:srgbClr val="333333"/>
-                </a:solidFill>
-              </a:defRPr>
-              <a:buChar char="•"/>
-            </a:pPr>
-            <a:r>
-              <a:t>Model learns 'everything depends on structural conditions'</a:t>
-            </a:r>
-          </a:p>
-          <a:p>
-            <a:pPr>
-              <a:spcAft>
-                <a:spcPts val="800"/>
-              </a:spcAft>
-              <a:defRPr sz="2400">
-                <a:solidFill>
-                  <a:srgbClr val="333333"/>
-                </a:solidFill>
-              </a:defRPr>
-              <a:buChar char="•"/>
-            </a:pPr>
-            <a:r>
-              <a:t>Applies heuristic where correct answer is definitive + or -</a:t>
-            </a:r>
-          </a:p>
-        </p:txBody>
-      </p:sp>
-      <p:sp>
-        <p:nvSpPr>
-          <p:cNvPr id="7" name="Rectangle 6"/>
+              <a:t>The Hedging Artifact</a:t>
+            </a:r>
+          </a:p>
+        </p:txBody>
+      </p:sp>
+      <p:sp>
+        <p:nvSpPr>
+          <p:cNvPr id="3" name="Rectangle 2"/>
           <p:cNvSpPr/>
           <p:nvPr/>
         </p:nvSpPr>
         <p:spPr>
           <a:xfrm>
-            <a:off x="548640" y="4754880"/>
-            <a:ext cx="10515600" cy="1737360"/>
+            <a:off x="731520" y="1143000"/>
+            <a:ext cx="10698480" cy="36576"/>
           </a:xfrm>
           <a:prstGeom prst="rect">
             <a:avLst/>
           </a:prstGeom>
           <a:solidFill>
-            <a:srgbClr val="F8F4FC"/>
+            <a:srgbClr val="C62828"/>
           </a:solidFill>
           <a:ln>
             <a:noFill/>
@@ -6322,14 +6064,14 @@
       </p:sp>
       <p:sp>
         <p:nvSpPr>
-          <p:cNvPr id="8" name="TextBox 7"/>
+          <p:cNvPr id="4" name="TextBox 3"/>
           <p:cNvSpPr txBox="1"/>
           <p:nvPr/>
         </p:nvSpPr>
         <p:spPr>
           <a:xfrm>
-            <a:off x="731520" y="4846320"/>
-            <a:ext cx="10149840" cy="457200"/>
+            <a:off x="731520" y="1280160"/>
+            <a:ext cx="10698480" cy="365760"/>
           </a:xfrm>
           <a:prstGeom prst="rect">
             <a:avLst/>
@@ -6337,34 +6079,34 @@
           <a:noFill/>
         </p:spPr>
         <p:txBody>
-          <a:bodyPr wrap="none">
+          <a:bodyPr wrap="square" lIns="137160" rIns="137160">
             <a:spAutoFit/>
           </a:bodyPr>
           <a:lstStyle/>
           <a:p>
-            <a:pPr>
-              <a:defRPr sz="2600" b="1">
-                <a:solidFill>
-                  <a:srgbClr val="F0AD00"/>
-                </a:solidFill>
-              </a:defRPr>
-            </a:pPr>
-            <a:r>
-              <a:t>Confirmation</a:t>
-            </a:r>
-          </a:p>
-        </p:txBody>
-      </p:sp>
-      <p:sp>
-        <p:nvSpPr>
-          <p:cNvPr id="9" name="TextBox 8"/>
+            <a:pPr algn="l">
+              <a:defRPr sz="2400" b="1">
+                <a:solidFill>
+                  <a:srgbClr val="C62828"/>
+                </a:solidFill>
+              </a:defRPr>
+            </a:pPr>
+            <a:r>
+              <a:t>Dominant Failure Mode: Positive-to-Mixed Hedging</a:t>
+            </a:r>
+          </a:p>
+        </p:txBody>
+      </p:sp>
+      <p:sp>
+        <p:nvSpPr>
+          <p:cNvPr id="5" name="TextBox 4"/>
           <p:cNvSpPr txBox="1"/>
           <p:nvPr/>
         </p:nvSpPr>
         <p:spPr>
           <a:xfrm>
-            <a:off x="822960" y="5303520"/>
-            <a:ext cx="10058400" cy="914400"/>
+            <a:off x="731520" y="1783080"/>
+            <a:ext cx="10698480" cy="685800"/>
           </a:xfrm>
           <a:prstGeom prst="rect">
             <a:avLst/>
@@ -6372,38 +6114,238 @@
           <a:noFill/>
         </p:spPr>
         <p:txBody>
-          <a:bodyPr wrap="square">
+          <a:bodyPr wrap="square" lIns="320040" tIns="18288">
             <a:spAutoFit/>
           </a:bodyPr>
           <a:lstStyle/>
           <a:p>
             <a:pPr>
               <a:spcAft>
-                <a:spcPts val="400"/>
+                <a:spcPts val="200"/>
               </a:spcAft>
               <a:defRPr sz="2400">
                 <a:solidFill>
                   <a:srgbClr val="333333"/>
                 </a:solidFill>
               </a:defRPr>
-            </a:pPr>
-            <a:r>
-              <a:t>Mirrors Syrgkanis 2026: causal reasoning has TWO distinct bottlenecks</a:t>
+              <a:buChar char="•"/>
+            </a:pPr>
+            <a:r>
+              <a:t>Finetuned model converts correct positive predictions (+) to ambiguous "mixed"</a:t>
             </a:r>
           </a:p>
           <a:p>
             <a:pPr>
               <a:spcAft>
-                <a:spcPts val="400"/>
+                <a:spcPts val="200"/>
               </a:spcAft>
               <a:defRPr sz="2400">
                 <a:solidFill>
                   <a:srgbClr val="333333"/>
                 </a:solidFill>
               </a:defRPr>
-            </a:pPr>
-            <a:r>
-              <a:t>Formal logic (strengthened) vs. identification details (weakened)</a:t>
+              <a:buChar char="•"/>
+            </a:pPr>
+            <a:r>
+              <a:t>Task1 Econ: 96 of 182 regressions are + to mixed (52.7%)</a:t>
+            </a:r>
+          </a:p>
+          <a:p>
+            <a:pPr>
+              <a:spcAft>
+                <a:spcPts val="200"/>
+              </a:spcAft>
+              <a:defRPr sz="2400">
+                <a:solidFill>
+                  <a:srgbClr val="333333"/>
+                </a:solidFill>
+              </a:defRPr>
+              <a:buChar char="•"/>
+            </a:pPr>
+            <a:r>
+              <a:t>Task1 Finance: 95 of 174 (54.6%)</a:t>
+            </a:r>
+          </a:p>
+          <a:p>
+            <a:pPr>
+              <a:spcAft>
+                <a:spcPts val="200"/>
+              </a:spcAft>
+              <a:defRPr sz="2400">
+                <a:solidFill>
+                  <a:srgbClr val="333333"/>
+                </a:solidFill>
+              </a:defRPr>
+              <a:buChar char="•"/>
+            </a:pPr>
+            <a:r>
+              <a:t>Positive-effect conversion accounts for 77-85% of all Task1 regressions</a:t>
+            </a:r>
+          </a:p>
+        </p:txBody>
+      </p:sp>
+      <p:sp>
+        <p:nvSpPr>
+          <p:cNvPr id="6" name="Rectangle 5"/>
+          <p:cNvSpPr/>
+          <p:nvPr/>
+        </p:nvSpPr>
+        <p:spPr>
+          <a:xfrm>
+            <a:off x="731520" y="3429000"/>
+            <a:ext cx="10698480" cy="36576"/>
+          </a:xfrm>
+          <a:prstGeom prst="rect">
+            <a:avLst/>
+          </a:prstGeom>
+          <a:solidFill>
+            <a:srgbClr val="7B2D8E"/>
+          </a:solidFill>
+          <a:ln>
+            <a:noFill/>
+          </a:ln>
+          <a:effectLst/>
+        </p:spPr>
+        <p:style>
+          <a:lnRef idx="1">
+            <a:schemeClr val="accent1"/>
+          </a:lnRef>
+          <a:fillRef idx="3">
+            <a:schemeClr val="accent1"/>
+          </a:fillRef>
+          <a:effectRef idx="2">
+            <a:schemeClr val="accent1"/>
+          </a:effectRef>
+          <a:fontRef idx="minor">
+            <a:schemeClr val="lt1"/>
+          </a:fontRef>
+        </p:style>
+        <p:txBody>
+          <a:bodyPr rtlCol="0" anchor="ctr"/>
+          <a:lstStyle/>
+          <a:p>
+            <a:pPr algn="ctr"/>
+          </a:p>
+        </p:txBody>
+      </p:sp>
+      <p:sp>
+        <p:nvSpPr>
+          <p:cNvPr id="7" name="TextBox 6"/>
+          <p:cNvSpPr txBox="1"/>
+          <p:nvPr/>
+        </p:nvSpPr>
+        <p:spPr>
+          <a:xfrm>
+            <a:off x="731520" y="3566160"/>
+            <a:ext cx="10698480" cy="365760"/>
+          </a:xfrm>
+          <a:prstGeom prst="rect">
+            <a:avLst/>
+          </a:prstGeom>
+          <a:noFill/>
+        </p:spPr>
+        <p:txBody>
+          <a:bodyPr wrap="square" lIns="137160" rIns="137160">
+            <a:spAutoFit/>
+          </a:bodyPr>
+          <a:lstStyle/>
+          <a:p>
+            <a:pPr algn="l">
+              <a:defRPr sz="2400" b="1">
+                <a:solidFill>
+                  <a:srgbClr val="7B2D8E"/>
+                </a:solidFill>
+              </a:defRPr>
+            </a:pPr>
+            <a:r>
+              <a:t>Why? A Transferred Epistemic Prior</a:t>
+            </a:r>
+          </a:p>
+        </p:txBody>
+      </p:sp>
+      <p:sp>
+        <p:nvSpPr>
+          <p:cNvPr id="8" name="TextBox 7"/>
+          <p:cNvSpPr txBox="1"/>
+          <p:nvPr/>
+        </p:nvSpPr>
+        <p:spPr>
+          <a:xfrm>
+            <a:off x="731520" y="4069080"/>
+            <a:ext cx="10698480" cy="685800"/>
+          </a:xfrm>
+          <a:prstGeom prst="rect">
+            <a:avLst/>
+          </a:prstGeom>
+          <a:noFill/>
+        </p:spPr>
+        <p:txBody>
+          <a:bodyPr wrap="square" lIns="320040" tIns="18288">
+            <a:spAutoFit/>
+          </a:bodyPr>
+          <a:lstStyle/>
+          <a:p>
+            <a:pPr>
+              <a:spcAft>
+                <a:spcPts val="200"/>
+              </a:spcAft>
+              <a:defRPr sz="2400">
+                <a:solidFill>
+                  <a:srgbClr val="333333"/>
+                </a:solidFill>
+              </a:defRPr>
+              <a:buChar char="•"/>
+            </a:pPr>
+            <a:r>
+              <a:t>Hedging is ABSENT from training data -- teacher hedges only 4.0% of the time</a:t>
+            </a:r>
+          </a:p>
+          <a:p>
+            <a:pPr>
+              <a:spcAft>
+                <a:spcPts val="200"/>
+              </a:spcAft>
+              <a:defRPr sz="2400">
+                <a:solidFill>
+                  <a:srgbClr val="333333"/>
+                </a:solidFill>
+              </a:defRPr>
+              <a:buChar char="•"/>
+            </a:pPr>
+            <a:r>
+              <a:t>Model internalizes DM principles: "outcomes depend on material conditions"</a:t>
+            </a:r>
+          </a:p>
+          <a:p>
+            <a:pPr>
+              <a:spcAft>
+                <a:spcPts val="200"/>
+              </a:spcAft>
+              <a:defRPr sz="2400">
+                <a:solidFill>
+                  <a:srgbClr val="333333"/>
+                </a:solidFill>
+              </a:defRPr>
+              <a:buChar char="•"/>
+            </a:pPr>
+            <a:r>
+              <a:t>It then applies this skepticism indiscriminately -- even where definitive answers exist</a:t>
+            </a:r>
+          </a:p>
+          <a:p>
+            <a:pPr>
+              <a:spcAft>
+                <a:spcPts val="200"/>
+              </a:spcAft>
+              <a:defRPr sz="2400">
+                <a:solidFill>
+                  <a:srgbClr val="333333"/>
+                </a:solidFill>
+              </a:defRPr>
+              <a:buChar char="•"/>
+            </a:pPr>
+            <a:r>
+              <a:t>This is not a reasoning error. It is a transferred epistemic prior.</a:t>
             </a:r>
           </a:p>
         </p:txBody>
@@ -6442,8 +6384,8 @@
         </p:nvSpPr>
         <p:spPr>
           <a:xfrm>
-            <a:off x="0" y="274320"/>
-            <a:ext cx="12191695" cy="822960"/>
+            <a:off x="0" y="0"/>
+            <a:ext cx="12191695" cy="1051560"/>
           </a:xfrm>
           <a:prstGeom prst="rect">
             <a:avLst/>
@@ -6453,43 +6395,354 @@
           </a:solidFill>
         </p:spPr>
         <p:txBody>
-          <a:bodyPr wrap="square" lIns="548640" tIns="137160">
+          <a:bodyPr wrap="square" lIns="548640" tIns="91440">
             <a:spAutoFit/>
           </a:bodyPr>
           <a:lstStyle/>
           <a:p>
+            <a:pPr>
+              <a:defRPr sz="3200" b="1">
+                <a:solidFill>
+                  <a:srgbClr val="FFFFFF"/>
+                </a:solidFill>
+              </a:defRPr>
+            </a:pPr>
+            <a:r>
+              <a:t>Why Formal Causal Improves While Applied Causal Regresses</a:t>
+            </a:r>
+          </a:p>
+        </p:txBody>
+      </p:sp>
+      <p:sp>
+        <p:nvSpPr>
+          <p:cNvPr id="3" name="TextBox 2"/>
+          <p:cNvSpPr txBox="1"/>
+          <p:nvPr/>
+        </p:nvSpPr>
+        <p:spPr>
+          <a:xfrm>
+            <a:off x="731520" y="1143000"/>
+            <a:ext cx="5029200" cy="320040"/>
+          </a:xfrm>
+          <a:prstGeom prst="rect">
+            <a:avLst/>
+          </a:prstGeom>
+          <a:noFill/>
+        </p:spPr>
+        <p:txBody>
+          <a:bodyPr wrap="square" lIns="137160" rIns="137160">
+            <a:spAutoFit/>
+          </a:bodyPr>
+          <a:lstStyle/>
+          <a:p>
             <a:pPr algn="l">
+              <a:defRPr sz="2200" b="1">
+                <a:solidFill>
+                  <a:srgbClr val="1565C0"/>
+                </a:solidFill>
+              </a:defRPr>
+            </a:pPr>
+            <a:r>
+              <a:t>Corr2Cause: +38.3pp</a:t>
+            </a:r>
+          </a:p>
+        </p:txBody>
+      </p:sp>
+      <p:sp>
+        <p:nvSpPr>
+          <p:cNvPr id="4" name="TextBox 3"/>
+          <p:cNvSpPr txBox="1"/>
+          <p:nvPr/>
+        </p:nvSpPr>
+        <p:spPr>
+          <a:xfrm>
+            <a:off x="731520" y="1508760"/>
+            <a:ext cx="5029200" cy="274320"/>
+          </a:xfrm>
+          <a:prstGeom prst="rect">
+            <a:avLst/>
+          </a:prstGeom>
+          <a:noFill/>
+        </p:spPr>
+        <p:txBody>
+          <a:bodyPr wrap="square" lIns="137160" rIns="137160">
+            <a:spAutoFit/>
+          </a:bodyPr>
+          <a:lstStyle/>
+          <a:p>
+            <a:pPr algn="l">
+              <a:defRPr sz="1800" b="0">
+                <a:solidFill>
+                  <a:srgbClr val="666666"/>
+                </a:solidFill>
+              </a:defRPr>
+            </a:pPr>
+            <a:r>
+              <a:t>Formal structural analysis on causal graphs</a:t>
+            </a:r>
+          </a:p>
+        </p:txBody>
+      </p:sp>
+      <p:sp>
+        <p:nvSpPr>
+          <p:cNvPr id="5" name="TextBox 4"/>
+          <p:cNvSpPr txBox="1"/>
+          <p:nvPr/>
+        </p:nvSpPr>
+        <p:spPr>
+          <a:xfrm>
+            <a:off x="731520" y="1874519"/>
+            <a:ext cx="5029200" cy="640080"/>
+          </a:xfrm>
+          <a:prstGeom prst="rect">
+            <a:avLst/>
+          </a:prstGeom>
+          <a:noFill/>
+        </p:spPr>
+        <p:txBody>
+          <a:bodyPr wrap="square" lIns="320040" tIns="18288">
+            <a:spAutoFit/>
+          </a:bodyPr>
+          <a:lstStyle/>
+          <a:p>
+            <a:pPr>
               <a:spcAft>
-                <a:spcPts val="0"/>
+                <a:spcPts val="200"/>
               </a:spcAft>
-              <a:defRPr sz="3600" b="1">
-                <a:solidFill>
-                  <a:srgbClr val="FFFFFF"/>
-                </a:solidFill>
-              </a:defRPr>
-            </a:pPr>
-            <a:r>
-              <a:t>Implications for Alignment Research</a:t>
-            </a:r>
-          </a:p>
-        </p:txBody>
-      </p:sp>
-      <p:sp>
-        <p:nvSpPr>
-          <p:cNvPr id="3" name="Rectangle 2"/>
+              <a:defRPr sz="2200">
+                <a:solidFill>
+                  <a:srgbClr val="333333"/>
+                </a:solidFill>
+              </a:defRPr>
+              <a:buChar char="•"/>
+            </a:pPr>
+            <a:r>
+              <a:t>DM training strengthens structural reasoning: trace dependencies, find confounders</a:t>
+            </a:r>
+          </a:p>
+          <a:p>
+            <a:pPr>
+              <a:spcAft>
+                <a:spcPts val="200"/>
+              </a:spcAft>
+              <a:defRPr sz="2200">
+                <a:solidFill>
+                  <a:srgbClr val="333333"/>
+                </a:solidFill>
+              </a:defRPr>
+              <a:buChar char="•"/>
+            </a:pPr>
+            <a:r>
+              <a:t>Non-child descendant: 13.0% -&gt; 94.3% (+81.3pp)</a:t>
+            </a:r>
+          </a:p>
+          <a:p>
+            <a:pPr>
+              <a:spcAft>
+                <a:spcPts val="200"/>
+              </a:spcAft>
+              <a:defRPr sz="2200">
+                <a:solidFill>
+                  <a:srgbClr val="333333"/>
+                </a:solidFill>
+              </a:defRPr>
+              <a:buChar char="•"/>
+            </a:pPr>
+            <a:r>
+              <a:t>Non-parent ancestor: 14.4% -&gt; 87.2% (+72.8pp)</a:t>
+            </a:r>
+          </a:p>
+          <a:p>
+            <a:pPr>
+              <a:spcAft>
+                <a:spcPts val="200"/>
+              </a:spcAft>
+              <a:defRPr sz="2200">
+                <a:solidFill>
+                  <a:srgbClr val="333333"/>
+                </a:solidFill>
+              </a:defRPr>
+              <a:buChar char="•"/>
+            </a:pPr>
+            <a:r>
+              <a:t>Largest gains on the most structurally complex templates</a:t>
+            </a:r>
+          </a:p>
+        </p:txBody>
+      </p:sp>
+      <p:sp>
+        <p:nvSpPr>
+          <p:cNvPr id="6" name="TextBox 5"/>
+          <p:cNvSpPr txBox="1"/>
+          <p:nvPr/>
+        </p:nvSpPr>
+        <p:spPr>
+          <a:xfrm>
+            <a:off x="6400800" y="1188720"/>
+            <a:ext cx="5029200" cy="320040"/>
+          </a:xfrm>
+          <a:prstGeom prst="rect">
+            <a:avLst/>
+          </a:prstGeom>
+          <a:noFill/>
+        </p:spPr>
+        <p:txBody>
+          <a:bodyPr wrap="square" lIns="137160" rIns="137160">
+            <a:spAutoFit/>
+          </a:bodyPr>
+          <a:lstStyle/>
+          <a:p>
+            <a:pPr algn="l">
+              <a:defRPr sz="2200" b="1">
+                <a:solidFill>
+                  <a:srgbClr val="C62828"/>
+                </a:solidFill>
+              </a:defRPr>
+            </a:pPr>
+            <a:r>
+              <a:t>EconCausal: -12.4pp</a:t>
+            </a:r>
+          </a:p>
+        </p:txBody>
+      </p:sp>
+      <p:sp>
+        <p:nvSpPr>
+          <p:cNvPr id="7" name="TextBox 6"/>
+          <p:cNvSpPr txBox="1"/>
+          <p:nvPr/>
+        </p:nvSpPr>
+        <p:spPr>
+          <a:xfrm>
+            <a:off x="6400800" y="1554480"/>
+            <a:ext cx="5029200" cy="274320"/>
+          </a:xfrm>
+          <a:prstGeom prst="rect">
+            <a:avLst/>
+          </a:prstGeom>
+          <a:noFill/>
+        </p:spPr>
+        <p:txBody>
+          <a:bodyPr wrap="square" lIns="137160" rIns="137160">
+            <a:spAutoFit/>
+          </a:bodyPr>
+          <a:lstStyle/>
+          <a:p>
+            <a:pPr algn="l">
+              <a:defRPr sz="1800" b="0">
+                <a:solidFill>
+                  <a:srgbClr val="666666"/>
+                </a:solidFill>
+              </a:defRPr>
+            </a:pPr>
+            <a:r>
+              <a:t>Applied causal identification from empirical context</a:t>
+            </a:r>
+          </a:p>
+        </p:txBody>
+      </p:sp>
+      <p:sp>
+        <p:nvSpPr>
+          <p:cNvPr id="8" name="TextBox 7"/>
+          <p:cNvSpPr txBox="1"/>
+          <p:nvPr/>
+        </p:nvSpPr>
+        <p:spPr>
+          <a:xfrm>
+            <a:off x="6400800" y="1920240"/>
+            <a:ext cx="5029200" cy="640080"/>
+          </a:xfrm>
+          <a:prstGeom prst="rect">
+            <a:avLst/>
+          </a:prstGeom>
+          <a:noFill/>
+        </p:spPr>
+        <p:txBody>
+          <a:bodyPr wrap="square" lIns="320040" tIns="18288">
+            <a:spAutoFit/>
+          </a:bodyPr>
+          <a:lstStyle/>
+          <a:p>
+            <a:pPr>
+              <a:spcAft>
+                <a:spcPts val="200"/>
+              </a:spcAft>
+              <a:defRPr sz="2200">
+                <a:solidFill>
+                  <a:srgbClr val="333333"/>
+                </a:solidFill>
+              </a:defRPr>
+              <a:buChar char="•"/>
+            </a:pPr>
+            <a:r>
+              <a:t>DM skepticism prior overrides empirical directional claims</a:t>
+            </a:r>
+          </a:p>
+          <a:p>
+            <a:pPr>
+              <a:spcAft>
+                <a:spcPts val="200"/>
+              </a:spcAft>
+              <a:defRPr sz="2200">
+                <a:solidFill>
+                  <a:srgbClr val="333333"/>
+                </a:solidFill>
+              </a:defRPr>
+              <a:buChar char="•"/>
+            </a:pPr>
+            <a:r>
+              <a:t>Model learned "everything depends on structural conditions"</a:t>
+            </a:r>
+          </a:p>
+          <a:p>
+            <a:pPr>
+              <a:spcAft>
+                <a:spcPts val="200"/>
+              </a:spcAft>
+              <a:defRPr sz="2200">
+                <a:solidFill>
+                  <a:srgbClr val="333333"/>
+                </a:solidFill>
+              </a:defRPr>
+              <a:buChar char="•"/>
+            </a:pPr>
+            <a:r>
+              <a:t>Applies this heuristic where the correct answer is a definitive + or -</a:t>
+            </a:r>
+          </a:p>
+          <a:p>
+            <a:pPr>
+              <a:spcAft>
+                <a:spcPts val="200"/>
+              </a:spcAft>
+              <a:defRPr sz="2200">
+                <a:solidFill>
+                  <a:srgbClr val="333333"/>
+                </a:solidFill>
+              </a:defRPr>
+              <a:buChar char="•"/>
+            </a:pPr>
+            <a:r>
+              <a:t>Result: systematic under-prediction of positive effects</a:t>
+            </a:r>
+          </a:p>
+        </p:txBody>
+      </p:sp>
+      <p:sp>
+        <p:nvSpPr>
+          <p:cNvPr id="9" name="Rectangle 8"/>
           <p:cNvSpPr/>
           <p:nvPr/>
         </p:nvSpPr>
         <p:spPr>
           <a:xfrm>
-            <a:off x="548640" y="1371600"/>
-            <a:ext cx="10515600" cy="1737360"/>
+            <a:off x="731520" y="5029200"/>
+            <a:ext cx="10698480" cy="36576"/>
           </a:xfrm>
           <a:prstGeom prst="rect">
             <a:avLst/>
           </a:prstGeom>
           <a:solidFill>
-            <a:srgbClr val="F8F4FC"/>
+            <a:srgbClr val="F0AD00"/>
           </a:solidFill>
           <a:ln>
             <a:noFill/>
@@ -6520,14 +6773,14 @@
       </p:sp>
       <p:sp>
         <p:nvSpPr>
-          <p:cNvPr id="4" name="TextBox 3"/>
+          <p:cNvPr id="10" name="TextBox 9"/>
           <p:cNvSpPr txBox="1"/>
           <p:nvPr/>
         </p:nvSpPr>
         <p:spPr>
           <a:xfrm>
-            <a:off x="731520" y="1463040"/>
-            <a:ext cx="10149840" cy="457200"/>
+            <a:off x="731520" y="5166360"/>
+            <a:ext cx="10698480" cy="914400"/>
           </a:xfrm>
           <a:prstGeom prst="rect">
             <a:avLst/>
@@ -6535,352 +6788,20 @@
           <a:noFill/>
         </p:spPr>
         <p:txBody>
-          <a:bodyPr wrap="none">
+          <a:bodyPr wrap="square" lIns="137160" rIns="137160">
             <a:spAutoFit/>
           </a:bodyPr>
           <a:lstStyle/>
           <a:p>
-            <a:pPr>
-              <a:defRPr sz="2600" b="1">
-                <a:solidFill>
-                  <a:srgbClr val="7B2D8E"/>
-                </a:solidFill>
-              </a:defRPr>
-            </a:pPr>
-            <a:r>
-              <a:t>1. SFT transfers epistemic priors, not just behavior</a:t>
-            </a:r>
-          </a:p>
-        </p:txBody>
-      </p:sp>
-      <p:sp>
-        <p:nvSpPr>
-          <p:cNvPr id="5" name="TextBox 4"/>
-          <p:cNvSpPr txBox="1"/>
-          <p:nvPr/>
-        </p:nvSpPr>
-        <p:spPr>
-          <a:xfrm>
-            <a:off x="822960" y="1920240"/>
-            <a:ext cx="10058400" cy="914400"/>
-          </a:xfrm>
-          <a:prstGeom prst="rect">
-            <a:avLst/>
-          </a:prstGeom>
-          <a:noFill/>
-        </p:spPr>
-        <p:txBody>
-          <a:bodyPr wrap="square">
-            <a:spAutoFit/>
-          </a:bodyPr>
-          <a:lstStyle/>
-          <a:p>
-            <a:pPr>
-              <a:spcAft>
-                <a:spcPts val="400"/>
-              </a:spcAft>
-              <a:defRPr sz="2400">
+            <a:pPr algn="l">
+              <a:defRPr sz="2100" b="0">
                 <a:solidFill>
                   <a:srgbClr val="333333"/>
                 </a:solidFill>
               </a:defRPr>
             </a:pPr>
             <a:r>
-              <a:t>Hedging artifact absent from training data, emerges from internalized framework</a:t>
-            </a:r>
-          </a:p>
-          <a:p>
-            <a:pPr>
-              <a:spcAft>
-                <a:spcPts val="400"/>
-              </a:spcAft>
-              <a:defRPr sz="2400">
-                <a:solidFill>
-                  <a:srgbClr val="333333"/>
-                </a:solidFill>
-              </a:defRPr>
-            </a:pPr>
-            <a:r>
-              <a:t>Shift operates at level of reasoning heuristics, not response patterns</a:t>
-            </a:r>
-          </a:p>
-        </p:txBody>
-      </p:sp>
-      <p:sp>
-        <p:nvSpPr>
-          <p:cNvPr id="6" name="Rectangle 5"/>
-          <p:cNvSpPr/>
-          <p:nvPr/>
-        </p:nvSpPr>
-        <p:spPr>
-          <a:xfrm>
-            <a:off x="548640" y="2926080"/>
-            <a:ext cx="10515600" cy="1737360"/>
-          </a:xfrm>
-          <a:prstGeom prst="rect">
-            <a:avLst/>
-          </a:prstGeom>
-          <a:solidFill>
-            <a:srgbClr val="F8F4FC"/>
-          </a:solidFill>
-          <a:ln>
-            <a:noFill/>
-          </a:ln>
-          <a:effectLst/>
-        </p:spPr>
-        <p:style>
-          <a:lnRef idx="1">
-            <a:schemeClr val="accent1"/>
-          </a:lnRef>
-          <a:fillRef idx="3">
-            <a:schemeClr val="accent1"/>
-          </a:fillRef>
-          <a:effectRef idx="2">
-            <a:schemeClr val="accent1"/>
-          </a:effectRef>
-          <a:fontRef idx="minor">
-            <a:schemeClr val="lt1"/>
-          </a:fontRef>
-        </p:style>
-        <p:txBody>
-          <a:bodyPr rtlCol="0" anchor="ctr"/>
-          <a:lstStyle/>
-          <a:p>
-            <a:pPr algn="ctr"/>
-          </a:p>
-        </p:txBody>
-      </p:sp>
-      <p:sp>
-        <p:nvSpPr>
-          <p:cNvPr id="7" name="TextBox 6"/>
-          <p:cNvSpPr txBox="1"/>
-          <p:nvPr/>
-        </p:nvSpPr>
-        <p:spPr>
-          <a:xfrm>
-            <a:off x="731520" y="3017520"/>
-            <a:ext cx="10149840" cy="457200"/>
-          </a:xfrm>
-          <a:prstGeom prst="rect">
-            <a:avLst/>
-          </a:prstGeom>
-          <a:noFill/>
-        </p:spPr>
-        <p:txBody>
-          <a:bodyPr wrap="none">
-            <a:spAutoFit/>
-          </a:bodyPr>
-          <a:lstStyle/>
-          <a:p>
-            <a:pPr>
-              <a:defRPr sz="2600" b="1">
-                <a:solidFill>
-                  <a:srgbClr val="7B2D8E"/>
-                </a:solidFill>
-              </a:defRPr>
-            </a:pPr>
-            <a:r>
-              <a:t>2. Standard alignment may carry unaudited priors</a:t>
-            </a:r>
-          </a:p>
-        </p:txBody>
-      </p:sp>
-      <p:sp>
-        <p:nvSpPr>
-          <p:cNvPr id="8" name="TextBox 7"/>
-          <p:cNvSpPr txBox="1"/>
-          <p:nvPr/>
-        </p:nvSpPr>
-        <p:spPr>
-          <a:xfrm>
-            <a:off x="822960" y="3474720"/>
-            <a:ext cx="10058400" cy="914400"/>
-          </a:xfrm>
-          <a:prstGeom prst="rect">
-            <a:avLst/>
-          </a:prstGeom>
-          <a:noFill/>
-        </p:spPr>
-        <p:txBody>
-          <a:bodyPr wrap="square">
-            <a:spAutoFit/>
-          </a:bodyPr>
-          <a:lstStyle/>
-          <a:p>
-            <a:pPr>
-              <a:spcAft>
-                <a:spcPts val="400"/>
-              </a:spcAft>
-              <a:defRPr sz="2400">
-                <a:solidFill>
-                  <a:srgbClr val="333333"/>
-                </a:solidFill>
-              </a:defRPr>
-            </a:pPr>
-            <a:r>
-              <a:t>RLHF emphasizing helpfulness/harmlessness may transfer deference to authority</a:t>
-            </a:r>
-          </a:p>
-          <a:p>
-            <a:pPr>
-              <a:spcAft>
-                <a:spcPts val="400"/>
-              </a:spcAft>
-              <a:defRPr sz="2400">
-                <a:solidFill>
-                  <a:srgbClr val="333333"/>
-                </a:solidFill>
-              </a:defRPr>
-            </a:pPr>
-            <a:r>
-              <a:t>These go unaudited because they align with evaluator's own priors</a:t>
-            </a:r>
-          </a:p>
-        </p:txBody>
-      </p:sp>
-      <p:sp>
-        <p:nvSpPr>
-          <p:cNvPr id="9" name="Rectangle 8"/>
-          <p:cNvSpPr/>
-          <p:nvPr/>
-        </p:nvSpPr>
-        <p:spPr>
-          <a:xfrm>
-            <a:off x="548640" y="4480560"/>
-            <a:ext cx="10515600" cy="2240280"/>
-          </a:xfrm>
-          <a:prstGeom prst="rect">
-            <a:avLst/>
-          </a:prstGeom>
-          <a:solidFill>
-            <a:srgbClr val="F8F4FC"/>
-          </a:solidFill>
-          <a:ln>
-            <a:noFill/>
-          </a:ln>
-          <a:effectLst/>
-        </p:spPr>
-        <p:style>
-          <a:lnRef idx="1">
-            <a:schemeClr val="accent1"/>
-          </a:lnRef>
-          <a:fillRef idx="3">
-            <a:schemeClr val="accent1"/>
-          </a:fillRef>
-          <a:effectRef idx="2">
-            <a:schemeClr val="accent1"/>
-          </a:effectRef>
-          <a:fontRef idx="minor">
-            <a:schemeClr val="lt1"/>
-          </a:fontRef>
-        </p:style>
-        <p:txBody>
-          <a:bodyPr rtlCol="0" anchor="ctr"/>
-          <a:lstStyle/>
-          <a:p>
-            <a:pPr algn="ctr"/>
-          </a:p>
-        </p:txBody>
-      </p:sp>
-      <p:sp>
-        <p:nvSpPr>
-          <p:cNvPr id="10" name="TextBox 9"/>
-          <p:cNvSpPr txBox="1"/>
-          <p:nvPr/>
-        </p:nvSpPr>
-        <p:spPr>
-          <a:xfrm>
-            <a:off x="731520" y="4572000"/>
-            <a:ext cx="10149840" cy="457200"/>
-          </a:xfrm>
-          <a:prstGeom prst="rect">
-            <a:avLst/>
-          </a:prstGeom>
-          <a:noFill/>
-        </p:spPr>
-        <p:txBody>
-          <a:bodyPr wrap="none">
-            <a:spAutoFit/>
-          </a:bodyPr>
-          <a:lstStyle/>
-          <a:p>
-            <a:pPr>
-              <a:defRPr sz="2600" b="1">
-                <a:solidFill>
-                  <a:srgbClr val="7B2D8E"/>
-                </a:solidFill>
-              </a:defRPr>
-            </a:pPr>
-            <a:r>
-              <a:t>3. Identification-Logic Split as a diagnostic tool</a:t>
-            </a:r>
-          </a:p>
-        </p:txBody>
-      </p:sp>
-      <p:sp>
-        <p:nvSpPr>
-          <p:cNvPr id="11" name="TextBox 10"/>
-          <p:cNvSpPr txBox="1"/>
-          <p:nvPr/>
-        </p:nvSpPr>
-        <p:spPr>
-          <a:xfrm>
-            <a:off x="822960" y="5029200"/>
-            <a:ext cx="10058400" cy="1371600"/>
-          </a:xfrm>
-          <a:prstGeom prst="rect">
-            <a:avLst/>
-          </a:prstGeom>
-          <a:noFill/>
-        </p:spPr>
-        <p:txBody>
-          <a:bodyPr wrap="square">
-            <a:spAutoFit/>
-          </a:bodyPr>
-          <a:lstStyle/>
-          <a:p>
-            <a:pPr>
-              <a:spcAft>
-                <a:spcPts val="400"/>
-              </a:spcAft>
-              <a:defRPr sz="2400">
-                <a:solidFill>
-                  <a:srgbClr val="333333"/>
-                </a:solidFill>
-              </a:defRPr>
-            </a:pPr>
-            <a:r>
-              <a:t>Intervention improves formal logic but impairs applied identification?</a:t>
-            </a:r>
-          </a:p>
-          <a:p>
-            <a:pPr>
-              <a:spcAft>
-                <a:spcPts val="400"/>
-              </a:spcAft>
-              <a:defRPr sz="2400">
-                <a:solidFill>
-                  <a:srgbClr val="333333"/>
-                </a:solidFill>
-              </a:defRPr>
-            </a:pPr>
-            <a:r>
-              <a:t>Signal of over-generalized structural skepticism</a:t>
-            </a:r>
-          </a:p>
-          <a:p>
-            <a:pPr>
-              <a:spcAft>
-                <a:spcPts val="400"/>
-              </a:spcAft>
-              <a:defRPr sz="2400">
-                <a:solidFill>
-                  <a:srgbClr val="333333"/>
-                </a:solidFill>
-              </a:defRPr>
-            </a:pPr>
-            <a:r>
-              <a:t>Benchmarks need BOTH formal and applied causal tasks</a:t>
+              <a:t>Causal reasoning has two distinct bottlenecks: formal logic (strengthened by DM) and identification details (weakened by DM). Mirrors findings of Syrgkanis 2026.</a:t>
             </a:r>
           </a:p>
         </p:txBody>
@@ -6919,8 +6840,8 @@
         </p:nvSpPr>
         <p:spPr>
           <a:xfrm>
-            <a:off x="0" y="274320"/>
-            <a:ext cx="12191695" cy="822960"/>
+            <a:off x="0" y="0"/>
+            <a:ext cx="12191695" cy="1051560"/>
           </a:xfrm>
           <a:prstGeom prst="rect">
             <a:avLst/>
@@ -6930,23 +6851,20 @@
           </a:solidFill>
         </p:spPr>
         <p:txBody>
-          <a:bodyPr wrap="square" lIns="548640" tIns="137160">
+          <a:bodyPr wrap="square" lIns="548640" tIns="91440">
             <a:spAutoFit/>
           </a:bodyPr>
           <a:lstStyle/>
           <a:p>
-            <a:pPr algn="l">
-              <a:spcAft>
-                <a:spcPts val="0"/>
-              </a:spcAft>
-              <a:defRPr sz="3600" b="1">
+            <a:pPr>
+              <a:defRPr sz="3200" b="1">
                 <a:solidFill>
                   <a:srgbClr val="FFFFFF"/>
                 </a:solidFill>
               </a:defRPr>
             </a:pPr>
             <a:r>
-              <a:t>Summary</a:t>
+              <a:t>Implications for Alignment Research</a:t>
             </a:r>
           </a:p>
         </p:txBody>
@@ -6959,8 +6877,8 @@
         </p:nvSpPr>
         <p:spPr>
           <a:xfrm>
-            <a:off x="548640" y="1371600"/>
-            <a:ext cx="10972800" cy="4572000"/>
+            <a:off x="731520" y="1143000"/>
+            <a:ext cx="10698480" cy="365760"/>
           </a:xfrm>
           <a:prstGeom prst="rect">
             <a:avLst/>
@@ -6968,16 +6886,51 @@
           <a:noFill/>
         </p:spPr>
         <p:txBody>
-          <a:bodyPr wrap="square">
+          <a:bodyPr wrap="square" lIns="137160" rIns="137160">
             <a:spAutoFit/>
           </a:bodyPr>
           <a:lstStyle/>
           <a:p>
+            <a:pPr algn="l">
+              <a:defRPr sz="2400" b="1">
+                <a:solidFill>
+                  <a:srgbClr val="7B2D8E"/>
+                </a:solidFill>
+              </a:defRPr>
+            </a:pPr>
+            <a:r>
+              <a:t>SFT transfers epistemic priors, not just behavior</a:t>
+            </a:r>
+          </a:p>
+        </p:txBody>
+      </p:sp>
+      <p:sp>
+        <p:nvSpPr>
+          <p:cNvPr id="4" name="TextBox 3"/>
+          <p:cNvSpPr txBox="1"/>
+          <p:nvPr/>
+        </p:nvSpPr>
+        <p:spPr>
+          <a:xfrm>
+            <a:off x="731520" y="1600200"/>
+            <a:ext cx="10698480" cy="388620"/>
+          </a:xfrm>
+          <a:prstGeom prst="rect">
+            <a:avLst/>
+          </a:prstGeom>
+          <a:noFill/>
+        </p:spPr>
+        <p:txBody>
+          <a:bodyPr wrap="square" lIns="320040" tIns="18288">
+            <a:spAutoFit/>
+          </a:bodyPr>
+          <a:lstStyle/>
+          <a:p>
             <a:pPr>
               <a:spcAft>
-                <a:spcPts val="800"/>
+                <a:spcPts val="200"/>
               </a:spcAft>
-              <a:defRPr sz="2800">
+              <a:defRPr sz="2200">
                 <a:solidFill>
                   <a:srgbClr val="333333"/>
                 </a:solidFill>
@@ -6985,15 +6938,15 @@
               <a:buChar char="•"/>
             </a:pPr>
             <a:r>
-              <a:t>Problem: SFT's effects on reasoning beyond training domain are poorly understood</a:t>
+              <a:t>Hedging artifact absent from training data, emerges from internalized framework</a:t>
             </a:r>
           </a:p>
           <a:p>
             <a:pPr>
               <a:spcAft>
-                <a:spcPts val="800"/>
+                <a:spcPts val="200"/>
               </a:spcAft>
-              <a:defRPr sz="2800">
+              <a:defRPr sz="2200">
                 <a:solidFill>
                   <a:srgbClr val="333333"/>
                 </a:solidFill>
@@ -7001,15 +6954,73 @@
               <a:buChar char="•"/>
             </a:pPr>
             <a:r>
-              <a:t>Method: QLoRA SFT on 1,460 DM-aligned Q&amp;A pairs (Qwen3.5-9B)</a:t>
-            </a:r>
-          </a:p>
+              <a:t>Shift operates at level of reasoning heuristics, not response patterns</a:t>
+            </a:r>
+          </a:p>
+        </p:txBody>
+      </p:sp>
+      <p:sp>
+        <p:nvSpPr>
+          <p:cNvPr id="5" name="TextBox 4"/>
+          <p:cNvSpPr txBox="1"/>
+          <p:nvPr/>
+        </p:nvSpPr>
+        <p:spPr>
+          <a:xfrm>
+            <a:off x="731520" y="2308860"/>
+            <a:ext cx="10698480" cy="365760"/>
+          </a:xfrm>
+          <a:prstGeom prst="rect">
+            <a:avLst/>
+          </a:prstGeom>
+          <a:noFill/>
+        </p:spPr>
+        <p:txBody>
+          <a:bodyPr wrap="square" lIns="137160" rIns="137160">
+            <a:spAutoFit/>
+          </a:bodyPr>
+          <a:lstStyle/>
+          <a:p>
+            <a:pPr algn="l">
+              <a:defRPr sz="2400" b="1">
+                <a:solidFill>
+                  <a:srgbClr val="7B2D8E"/>
+                </a:solidFill>
+              </a:defRPr>
+            </a:pPr>
+            <a:r>
+              <a:t>Standard alignment may carry unaudited priors</a:t>
+            </a:r>
+          </a:p>
+        </p:txBody>
+      </p:sp>
+      <p:sp>
+        <p:nvSpPr>
+          <p:cNvPr id="6" name="TextBox 5"/>
+          <p:cNvSpPr txBox="1"/>
+          <p:nvPr/>
+        </p:nvSpPr>
+        <p:spPr>
+          <a:xfrm>
+            <a:off x="731520" y="2766060"/>
+            <a:ext cx="10698480" cy="388620"/>
+          </a:xfrm>
+          <a:prstGeom prst="rect">
+            <a:avLst/>
+          </a:prstGeom>
+          <a:noFill/>
+        </p:spPr>
+        <p:txBody>
+          <a:bodyPr wrap="square" lIns="320040" tIns="18288">
+            <a:spAutoFit/>
+          </a:bodyPr>
+          <a:lstStyle/>
           <a:p>
             <a:pPr>
               <a:spcAft>
-                <a:spcPts val="800"/>
+                <a:spcPts val="200"/>
               </a:spcAft>
-              <a:defRPr sz="2800">
+              <a:defRPr sz="2200">
                 <a:solidFill>
                   <a:srgbClr val="333333"/>
                 </a:solidFill>
@@ -7017,15 +7028,15 @@
               <a:buChar char="•"/>
             </a:pPr>
             <a:r>
-              <a:t>Finding 1: General capability preserved (MMLU -0.8pp, HumanEval 0.0pp)</a:t>
+              <a:t>If DM training produces detectable transfer, RLHF likely does too</a:t>
             </a:r>
           </a:p>
           <a:p>
             <a:pPr>
               <a:spcAft>
-                <a:spcPts val="800"/>
+                <a:spcPts val="200"/>
               </a:spcAft>
-              <a:defRPr sz="2800">
+              <a:defRPr sz="2200">
                 <a:solidFill>
                   <a:srgbClr val="333333"/>
                 </a:solidFill>
@@ -7033,15 +7044,73 @@
               <a:buChar char="•"/>
             </a:pPr>
             <a:r>
-              <a:t>Finding 2: Formal causal reasoning improves (Corr2Cause +38.3pp)</a:t>
-            </a:r>
-          </a:p>
+              <a:t>Helpfulness training may transfer deference to authority, controversy avoidance</a:t>
+            </a:r>
+          </a:p>
+        </p:txBody>
+      </p:sp>
+      <p:sp>
+        <p:nvSpPr>
+          <p:cNvPr id="7" name="TextBox 6"/>
+          <p:cNvSpPr txBox="1"/>
+          <p:nvPr/>
+        </p:nvSpPr>
+        <p:spPr>
+          <a:xfrm>
+            <a:off x="731520" y="3474720"/>
+            <a:ext cx="10698480" cy="365760"/>
+          </a:xfrm>
+          <a:prstGeom prst="rect">
+            <a:avLst/>
+          </a:prstGeom>
+          <a:noFill/>
+        </p:spPr>
+        <p:txBody>
+          <a:bodyPr wrap="square" lIns="137160" rIns="137160">
+            <a:spAutoFit/>
+          </a:bodyPr>
+          <a:lstStyle/>
+          <a:p>
+            <a:pPr algn="l">
+              <a:defRPr sz="2400" b="1">
+                <a:solidFill>
+                  <a:srgbClr val="7B2D8E"/>
+                </a:solidFill>
+              </a:defRPr>
+            </a:pPr>
+            <a:r>
+              <a:t>The Identification-Logic Split as a diagnostic</a:t>
+            </a:r>
+          </a:p>
+        </p:txBody>
+      </p:sp>
+      <p:sp>
+        <p:nvSpPr>
+          <p:cNvPr id="8" name="TextBox 7"/>
+          <p:cNvSpPr txBox="1"/>
+          <p:nvPr/>
+        </p:nvSpPr>
+        <p:spPr>
+          <a:xfrm>
+            <a:off x="731520" y="3931920"/>
+            <a:ext cx="10698480" cy="388620"/>
+          </a:xfrm>
+          <a:prstGeom prst="rect">
+            <a:avLst/>
+          </a:prstGeom>
+          <a:noFill/>
+        </p:spPr>
+        <p:txBody>
+          <a:bodyPr wrap="square" lIns="320040" tIns="18288">
+            <a:spAutoFit/>
+          </a:bodyPr>
+          <a:lstStyle/>
           <a:p>
             <a:pPr>
               <a:spcAft>
-                <a:spcPts val="800"/>
+                <a:spcPts val="200"/>
               </a:spcAft>
-              <a:defRPr sz="2800">
+              <a:defRPr sz="2200">
                 <a:solidFill>
                   <a:srgbClr val="333333"/>
                 </a:solidFill>
@@ -7049,15 +7118,15 @@
               <a:buChar char="•"/>
             </a:pPr>
             <a:r>
-              <a:t>Finding 3: Applied causal reasoning regresses (EconCausal -12.4pp)</a:t>
+              <a:t>Intervention improves formal logic but impairs applied identification?</a:t>
             </a:r>
           </a:p>
           <a:p>
             <a:pPr>
               <a:spcAft>
-                <a:spcPts val="800"/>
+                <a:spcPts val="200"/>
               </a:spcAft>
-              <a:defRPr sz="2800">
+              <a:defRPr sz="2200">
                 <a:solidFill>
                   <a:srgbClr val="333333"/>
                 </a:solidFill>
@@ -7065,23 +7134,7 @@
               <a:buChar char="•"/>
             </a:pPr>
             <a:r>
-              <a:t>Mechanism: Emergent hedging bias -- transferred epistemic prior, absent from data</a:t>
-            </a:r>
-          </a:p>
-          <a:p>
-            <a:pPr>
-              <a:spcAft>
-                <a:spcPts val="800"/>
-              </a:spcAft>
-              <a:defRPr sz="2800">
-                <a:solidFill>
-                  <a:srgbClr val="333333"/>
-                </a:solidFill>
-              </a:defRPr>
-              <a:buChar char="•"/>
-            </a:pPr>
-            <a:r>
-              <a:t>Implication: Alignment training transfers reasoning priors that should be audited</a:t>
+              <a:t>Signal of over-generalized structural skepticism</a:t>
             </a:r>
           </a:p>
         </p:txBody>
@@ -7120,8 +7173,8 @@
         </p:nvSpPr>
         <p:spPr>
           <a:xfrm>
-            <a:off x="0" y="274320"/>
-            <a:ext cx="12191695" cy="822960"/>
+            <a:off x="0" y="0"/>
+            <a:ext cx="12191695" cy="1051560"/>
           </a:xfrm>
           <a:prstGeom prst="rect">
             <a:avLst/>
@@ -7131,23 +7184,20 @@
           </a:solidFill>
         </p:spPr>
         <p:txBody>
-          <a:bodyPr wrap="square" lIns="548640" tIns="137160">
+          <a:bodyPr wrap="square" lIns="548640" tIns="91440">
             <a:spAutoFit/>
           </a:bodyPr>
           <a:lstStyle/>
           <a:p>
-            <a:pPr algn="l">
-              <a:spcAft>
-                <a:spcPts val="0"/>
-              </a:spcAft>
-              <a:defRPr sz="3600" b="1">
+            <a:pPr>
+              <a:defRPr sz="3200" b="1">
                 <a:solidFill>
                   <a:srgbClr val="FFFFFF"/>
                 </a:solidFill>
               </a:defRPr>
             </a:pPr>
             <a:r>
-              <a:t>Future Work: Breaking the Hedging Prior</a:t>
+              <a:t>Summary</a:t>
             </a:r>
           </a:p>
         </p:txBody>
@@ -7160,8 +7210,8 @@
         </p:nvSpPr>
         <p:spPr>
           <a:xfrm>
-            <a:off x="548640" y="1371600"/>
-            <a:ext cx="10972800" cy="4572000"/>
+            <a:off x="731520" y="1143000"/>
+            <a:ext cx="10698480" cy="1177289"/>
           </a:xfrm>
           <a:prstGeom prst="rect">
             <a:avLst/>
@@ -7169,16 +7219,16 @@
           <a:noFill/>
         </p:spPr>
         <p:txBody>
-          <a:bodyPr wrap="square">
+          <a:bodyPr wrap="square" lIns="320040" tIns="18288">
             <a:spAutoFit/>
           </a:bodyPr>
           <a:lstStyle/>
           <a:p>
             <a:pPr>
               <a:spcAft>
-                <a:spcPts val="800"/>
+                <a:spcPts val="200"/>
               </a:spcAft>
-              <a:defRPr sz="2800">
+              <a:defRPr sz="2600">
                 <a:solidFill>
                   <a:srgbClr val="333333"/>
                 </a:solidFill>
@@ -7186,15 +7236,15 @@
               <a:buChar char="•"/>
             </a:pPr>
             <a:r>
-              <a:t>GRPO with process rewards (RLVMR framework, Zhang 2025)</a:t>
+              <a:t>Fine-tuned Qwen3.5-9B on 1,460 DM-aligned Q&amp;A pairs via QLoRA</a:t>
             </a:r>
           </a:p>
           <a:p>
             <a:pPr>
               <a:spcAft>
-                <a:spcPts val="800"/>
+                <a:spcPts val="200"/>
               </a:spcAft>
-              <a:defRPr sz="2800">
+              <a:defRPr sz="2600">
                 <a:solidFill>
                   <a:srgbClr val="333333"/>
                 </a:solidFill>
@@ -7202,15 +7252,15 @@
               <a:buChar char="•"/>
             </a:pPr>
             <a:r>
-              <a:t>Dual advantage: trajectory-level outcome + meta-reasoning advantage</a:t>
+              <a:t>General capability preserved: MMLU -0.8pp, HumanEval unchanged at 70.7%</a:t>
             </a:r>
           </a:p>
           <a:p>
             <a:pPr>
               <a:spcAft>
-                <a:spcPts val="800"/>
+                <a:spcPts val="200"/>
               </a:spcAft>
-              <a:defRPr sz="2800">
+              <a:defRPr sz="2600">
                 <a:solidFill>
                   <a:srgbClr val="333333"/>
                 </a:solidFill>
@@ -7218,15 +7268,15 @@
               <a:buChar char="•"/>
             </a:pPr>
             <a:r>
-              <a:t>Reward definitive commitment when warranted</a:t>
+              <a:t>Formal causal reasoning improved dramatically: Corr2Cause +38.3pp</a:t>
             </a:r>
           </a:p>
           <a:p>
             <a:pPr>
               <a:spcAft>
-                <a:spcPts val="800"/>
+                <a:spcPts val="200"/>
               </a:spcAft>
-              <a:defRPr sz="2800">
+              <a:defRPr sz="2600">
                 <a:solidFill>
                   <a:srgbClr val="333333"/>
                 </a:solidFill>
@@ -7234,154 +7284,55 @@
               <a:buChar char="•"/>
             </a:pPr>
             <a:r>
-              <a:t>Goal: break hedging prior while maintaining structural reasoning quality</a:t>
-            </a:r>
-          </a:p>
-        </p:txBody>
-      </p:sp>
-      <p:sp>
-        <p:nvSpPr>
-          <p:cNvPr id="4" name="Rectangle 3"/>
-          <p:cNvSpPr/>
-          <p:nvPr/>
-        </p:nvSpPr>
-        <p:spPr>
-          <a:xfrm>
-            <a:off x="548640" y="3840480"/>
-            <a:ext cx="10515600" cy="2240280"/>
-          </a:xfrm>
-          <a:prstGeom prst="rect">
-            <a:avLst/>
-          </a:prstGeom>
-          <a:solidFill>
-            <a:srgbClr val="F8F4FC"/>
-          </a:solidFill>
-          <a:ln>
-            <a:noFill/>
-          </a:ln>
-          <a:effectLst/>
-        </p:spPr>
-        <p:style>
-          <a:lnRef idx="1">
-            <a:schemeClr val="accent1"/>
-          </a:lnRef>
-          <a:fillRef idx="3">
-            <a:schemeClr val="accent1"/>
-          </a:fillRef>
-          <a:effectRef idx="2">
-            <a:schemeClr val="accent1"/>
-          </a:effectRef>
-          <a:fontRef idx="minor">
-            <a:schemeClr val="lt1"/>
-          </a:fontRef>
-        </p:style>
-        <p:txBody>
-          <a:bodyPr rtlCol="0" anchor="ctr"/>
-          <a:lstStyle/>
-          <a:p>
-            <a:pPr algn="ctr"/>
-          </a:p>
-        </p:txBody>
-      </p:sp>
-      <p:sp>
-        <p:nvSpPr>
-          <p:cNvPr id="5" name="TextBox 4"/>
-          <p:cNvSpPr txBox="1"/>
-          <p:nvPr/>
-        </p:nvSpPr>
-        <p:spPr>
-          <a:xfrm>
-            <a:off x="731520" y="3931920"/>
-            <a:ext cx="10149840" cy="457200"/>
-          </a:xfrm>
-          <a:prstGeom prst="rect">
-            <a:avLst/>
-          </a:prstGeom>
-          <a:noFill/>
-        </p:spPr>
-        <p:txBody>
-          <a:bodyPr wrap="none">
-            <a:spAutoFit/>
-          </a:bodyPr>
-          <a:lstStyle/>
-          <a:p>
-            <a:pPr>
-              <a:defRPr sz="2600" b="1">
-                <a:solidFill>
-                  <a:srgbClr val="F0AD00"/>
-                </a:solidFill>
-              </a:defRPr>
-            </a:pPr>
-            <a:r>
-              <a:t>Current Status</a:t>
-            </a:r>
-          </a:p>
-        </p:txBody>
-      </p:sp>
-      <p:sp>
-        <p:nvSpPr>
-          <p:cNvPr id="6" name="TextBox 5"/>
-          <p:cNvSpPr txBox="1"/>
-          <p:nvPr/>
-        </p:nvSpPr>
-        <p:spPr>
-          <a:xfrm>
-            <a:off x="822960" y="4389120"/>
-            <a:ext cx="10058400" cy="1371600"/>
-          </a:xfrm>
-          <a:prstGeom prst="rect">
-            <a:avLst/>
-          </a:prstGeom>
-          <a:noFill/>
-        </p:spPr>
-        <p:txBody>
-          <a:bodyPr wrap="square">
-            <a:spAutoFit/>
-          </a:bodyPr>
-          <a:lstStyle/>
+              <a:t>Applied causal reasoning regressed: EconCausal -12.4pp to -13.5pp</a:t>
+            </a:r>
+          </a:p>
           <a:p>
             <a:pPr>
               <a:spcAft>
-                <a:spcPts val="400"/>
+                <a:spcPts val="200"/>
               </a:spcAft>
-              <a:defRPr sz="2400">
+              <a:defRPr sz="2600">
                 <a:solidFill>
                   <a:srgbClr val="333333"/>
                 </a:solidFill>
               </a:defRPr>
-            </a:pPr>
-            <a:r>
-              <a:t>GRPO v3 (outcome-only): stalled at 806/1500 steps, no reward improvement</a:t>
+              <a:buChar char="•"/>
+            </a:pPr>
+            <a:r>
+              <a:t>Regression from single emergent artifact: positive-to-mixed hedging bias</a:t>
             </a:r>
           </a:p>
           <a:p>
             <a:pPr>
               <a:spcAft>
-                <a:spcPts val="400"/>
+                <a:spcPts val="200"/>
               </a:spcAft>
-              <a:defRPr sz="2400">
+              <a:defRPr sz="2600">
                 <a:solidFill>
                   <a:srgbClr val="333333"/>
                 </a:solidFill>
               </a:defRPr>
-            </a:pPr>
-            <a:r>
-              <a:t>GRPO v4 (process rewards): tagged reasoning with rule-based rewards for</a:t>
+              <a:buChar char="•"/>
+            </a:pPr>
+            <a:r>
+              <a:t>Hedging absent from training data -- a transferred epistemic prior</a:t>
             </a:r>
           </a:p>
           <a:p>
             <a:pPr>
               <a:spcAft>
-                <a:spcPts val="400"/>
+                <a:spcPts val="200"/>
               </a:spcAft>
-              <a:defRPr sz="2400">
+              <a:defRPr sz="2600">
                 <a:solidFill>
                   <a:srgbClr val="333333"/>
                 </a:solidFill>
               </a:defRPr>
-            </a:pPr>
-            <a:r>
-              <a:t>  planning, commitment, reflection, and monitoring</a:t>
+              <a:buChar char="•"/>
+            </a:pPr>
+            <a:r>
+              <a:t>Conclusion: SFT transfers reasoning priors, not just behavioral patterns</a:t>
             </a:r>
           </a:p>
         </p:txBody>

</xml_diff>

<commit_message>
Fix text overlapping in slides: estimate line wrapping, adjust line height formula
</commit_message>
<xml_diff>
--- a/paper/iclr2026/iclr2026_spotlight.pptx
+++ b/paper/iclr2026/iclr2026_spotlight.pptx
@@ -4572,7 +4572,7 @@
         <p:spPr>
           <a:xfrm>
             <a:off x="731520" y="1143000"/>
-            <a:ext cx="10698480" cy="582930"/>
+            <a:ext cx="10698480" cy="1495806"/>
           </a:xfrm>
           <a:prstGeom prst="rect">
             <a:avLst/>
@@ -4642,7 +4642,7 @@
         </p:nvSpPr>
         <p:spPr>
           <a:xfrm>
-            <a:off x="731520" y="2331720"/>
+            <a:off x="731520" y="2913125"/>
             <a:ext cx="10698480" cy="36576"/>
           </a:xfrm>
           <a:prstGeom prst="rect">
@@ -4686,8 +4686,8 @@
         </p:nvSpPr>
         <p:spPr>
           <a:xfrm>
-            <a:off x="731520" y="2560320"/>
-            <a:ext cx="10698480" cy="434340"/>
+            <a:off x="731520" y="3141725"/>
+            <a:ext cx="10698480" cy="1042924"/>
           </a:xfrm>
           <a:prstGeom prst="rect">
             <a:avLst/>
@@ -4741,7 +4741,7 @@
         </p:nvSpPr>
         <p:spPr>
           <a:xfrm>
-            <a:off x="731520" y="3657600"/>
+            <a:off x="731520" y="4367530"/>
             <a:ext cx="10698480" cy="365760"/>
           </a:xfrm>
           <a:prstGeom prst="rect">
@@ -4840,7 +4840,7 @@
         <p:spPr>
           <a:xfrm>
             <a:off x="731520" y="1143000"/>
-            <a:ext cx="10698480" cy="434340"/>
+            <a:ext cx="10698480" cy="1042924"/>
           </a:xfrm>
           <a:prstGeom prst="rect">
             <a:avLst/>
@@ -4894,7 +4894,7 @@
         </p:nvSpPr>
         <p:spPr>
           <a:xfrm>
-            <a:off x="731520" y="2148840"/>
+            <a:off x="731520" y="2460244"/>
             <a:ext cx="10698480" cy="36576"/>
           </a:xfrm>
           <a:prstGeom prst="rect">
@@ -4938,8 +4938,8 @@
         </p:nvSpPr>
         <p:spPr>
           <a:xfrm>
-            <a:off x="731520" y="2377440"/>
-            <a:ext cx="10698480" cy="582930"/>
+            <a:off x="731520" y="2688844"/>
+            <a:ext cx="10698480" cy="1495806"/>
           </a:xfrm>
           <a:prstGeom prst="rect">
             <a:avLst/>
@@ -5009,7 +5009,7 @@
         </p:nvSpPr>
         <p:spPr>
           <a:xfrm>
-            <a:off x="731520" y="3931920"/>
+            <a:off x="731520" y="4367530"/>
             <a:ext cx="10698480" cy="365760"/>
           </a:xfrm>
           <a:prstGeom prst="rect">
@@ -5143,7 +5143,7 @@
         <p:spPr>
           <a:xfrm>
             <a:off x="731520" y="1508760"/>
-            <a:ext cx="5029200" cy="765810"/>
+            <a:ext cx="5029200" cy="2109470"/>
           </a:xfrm>
           <a:prstGeom prst="rect">
             <a:avLst/>
@@ -5281,7 +5281,7 @@
         <p:spPr>
           <a:xfrm>
             <a:off x="6400800" y="1508760"/>
-            <a:ext cx="5029200" cy="640080"/>
+            <a:ext cx="5029200" cy="1715008"/>
           </a:xfrm>
           <a:prstGeom prst="rect">
             <a:avLst/>
@@ -5545,7 +5545,7 @@
         <p:spPr>
           <a:xfrm>
             <a:off x="640080" y="1691640"/>
-            <a:ext cx="2926080" cy="594360"/>
+            <a:ext cx="2926080" cy="1598168"/>
           </a:xfrm>
           <a:prstGeom prst="rect">
             <a:avLst/>
@@ -5711,7 +5711,7 @@
         <p:spPr>
           <a:xfrm>
             <a:off x="4251959" y="1691640"/>
-            <a:ext cx="2926080" cy="594360"/>
+            <a:ext cx="2926080" cy="1598168"/>
           </a:xfrm>
           <a:prstGeom prst="rect">
             <a:avLst/>
@@ -5877,7 +5877,7 @@
         <p:spPr>
           <a:xfrm>
             <a:off x="7863840" y="1691640"/>
-            <a:ext cx="2926080" cy="594360"/>
+            <a:ext cx="2926080" cy="1598168"/>
           </a:xfrm>
           <a:prstGeom prst="rect">
             <a:avLst/>
@@ -6105,8 +6105,8 @@
         </p:nvSpPr>
         <p:spPr>
           <a:xfrm>
-            <a:off x="731520" y="1783080"/>
-            <a:ext cx="10698480" cy="685800"/>
+            <a:off x="731520" y="1737360"/>
+            <a:ext cx="10698480" cy="1831848"/>
           </a:xfrm>
           <a:prstGeom prst="rect">
             <a:avLst/>
@@ -6192,7 +6192,7 @@
         </p:nvSpPr>
         <p:spPr>
           <a:xfrm>
-            <a:off x="731520" y="3429000"/>
+            <a:off x="731520" y="3843528"/>
             <a:ext cx="10698480" cy="36576"/>
           </a:xfrm>
           <a:prstGeom prst="rect">
@@ -6236,7 +6236,7 @@
         </p:nvSpPr>
         <p:spPr>
           <a:xfrm>
-            <a:off x="731520" y="3566160"/>
+            <a:off x="731520" y="3980688"/>
             <a:ext cx="10698480" cy="365760"/>
           </a:xfrm>
           <a:prstGeom prst="rect">
@@ -6271,8 +6271,8 @@
         </p:nvSpPr>
         <p:spPr>
           <a:xfrm>
-            <a:off x="731520" y="4069080"/>
-            <a:ext cx="10698480" cy="685800"/>
+            <a:off x="731520" y="4437888"/>
+            <a:ext cx="10698480" cy="1831848"/>
           </a:xfrm>
           <a:prstGeom prst="rect">
             <a:avLst/>
@@ -6492,7 +6492,7 @@
         <p:spPr>
           <a:xfrm>
             <a:off x="731520" y="1874519"/>
-            <a:ext cx="5029200" cy="640080"/>
+            <a:ext cx="5029200" cy="2109470"/>
           </a:xfrm>
           <a:prstGeom prst="rect">
             <a:avLst/>
@@ -6649,7 +6649,7 @@
         <p:spPr>
           <a:xfrm>
             <a:off x="6400800" y="1920240"/>
-            <a:ext cx="5029200" cy="640080"/>
+            <a:ext cx="5029200" cy="1715008"/>
           </a:xfrm>
           <a:prstGeom prst="rect">
             <a:avLst/>
@@ -6913,7 +6913,7 @@
         <p:spPr>
           <a:xfrm>
             <a:off x="731520" y="1600200"/>
-            <a:ext cx="10698480" cy="388620"/>
+            <a:ext cx="10698480" cy="926084"/>
           </a:xfrm>
           <a:prstGeom prst="rect">
             <a:avLst/>
@@ -6967,7 +6967,7 @@
         </p:nvSpPr>
         <p:spPr>
           <a:xfrm>
-            <a:off x="731520" y="2308860"/>
+            <a:off x="731520" y="2846324"/>
             <a:ext cx="10698480" cy="365760"/>
           </a:xfrm>
           <a:prstGeom prst="rect">
@@ -7002,8 +7002,8 @@
         </p:nvSpPr>
         <p:spPr>
           <a:xfrm>
-            <a:off x="731520" y="2766060"/>
-            <a:ext cx="10698480" cy="388620"/>
+            <a:off x="731520" y="3303524"/>
+            <a:ext cx="10698480" cy="926084"/>
           </a:xfrm>
           <a:prstGeom prst="rect">
             <a:avLst/>
@@ -7057,7 +7057,7 @@
         </p:nvSpPr>
         <p:spPr>
           <a:xfrm>
-            <a:off x="731520" y="3474720"/>
+            <a:off x="731520" y="4549648"/>
             <a:ext cx="10698480" cy="365760"/>
           </a:xfrm>
           <a:prstGeom prst="rect">
@@ -7092,8 +7092,8 @@
         </p:nvSpPr>
         <p:spPr>
           <a:xfrm>
-            <a:off x="731520" y="3931920"/>
-            <a:ext cx="10698480" cy="388620"/>
+            <a:off x="731520" y="5006848"/>
+            <a:ext cx="10698480" cy="926084"/>
           </a:xfrm>
           <a:prstGeom prst="rect">
             <a:avLst/>
@@ -7211,7 +7211,7 @@
         <p:spPr>
           <a:xfrm>
             <a:off x="731520" y="1143000"/>
-            <a:ext cx="10698480" cy="1177289"/>
+            <a:ext cx="10698480" cy="3307333"/>
           </a:xfrm>
           <a:prstGeom prst="rect">
             <a:avLst/>

</xml_diff>

<commit_message>
Fix bullets: use unicode bullet char in text, add spacing between items
</commit_message>
<xml_diff>
--- a/paper/iclr2026/iclr2026_spotlight.pptx
+++ b/paper/iclr2026/iclr2026_spotlight.pptx
@@ -4580,56 +4580,56 @@
           <a:noFill/>
         </p:spPr>
         <p:txBody>
-          <a:bodyPr wrap="square" lIns="320040" tIns="18288">
+          <a:bodyPr wrap="square" lIns="457200">
             <a:spAutoFit/>
           </a:bodyPr>
           <a:lstStyle/>
           <a:p>
             <a:pPr>
               <a:spcAft>
-                <a:spcPts val="200"/>
+                <a:spcPts val="600"/>
               </a:spcAft>
               <a:defRPr sz="2600">
                 <a:solidFill>
                   <a:srgbClr val="333333"/>
                 </a:solidFill>
               </a:defRPr>
-              <a:buChar char="•"/>
-            </a:pPr>
-            <a:r>
-              <a:t>LLMs are aligned in two stages: SFT, then preference optimization (DPO, RLHF)</a:t>
+              <a:buNone/>
+            </a:pPr>
+            <a:r>
+              <a:t>•  LLMs are aligned in two stages: SFT, then preference optimization (DPO, RLHF)</a:t>
             </a:r>
           </a:p>
           <a:p>
             <a:pPr>
               <a:spcAft>
-                <a:spcPts val="200"/>
+                <a:spcPts val="600"/>
               </a:spcAft>
               <a:defRPr sz="2600">
                 <a:solidFill>
                   <a:srgbClr val="333333"/>
                 </a:solidFill>
               </a:defRPr>
-              <a:buChar char="•"/>
-            </a:pPr>
-            <a:r>
-              <a:t>SFT (supervised fine-tuning) trains on curated instruction-answer pairs</a:t>
+              <a:buNone/>
+            </a:pPr>
+            <a:r>
+              <a:t>•  SFT (supervised fine-tuning) trains on curated instruction-answer pairs</a:t>
             </a:r>
           </a:p>
           <a:p>
             <a:pPr>
               <a:spcAft>
-                <a:spcPts val="200"/>
+                <a:spcPts val="600"/>
               </a:spcAft>
               <a:defRPr sz="2600">
                 <a:solidFill>
                   <a:srgbClr val="333333"/>
                 </a:solidFill>
               </a:defRPr>
-              <a:buChar char="•"/>
-            </a:pPr>
-            <a:r>
-              <a:t>Preference optimization further shapes responses from paired comparisons</a:t>
+              <a:buNone/>
+            </a:pPr>
+            <a:r>
+              <a:t>•  Preference optimization further shapes responses from paired comparisons</a:t>
             </a:r>
           </a:p>
         </p:txBody>
@@ -4695,40 +4695,40 @@
           <a:noFill/>
         </p:spPr>
         <p:txBody>
-          <a:bodyPr wrap="square" lIns="320040" tIns="18288">
+          <a:bodyPr wrap="square" lIns="457200">
             <a:spAutoFit/>
           </a:bodyPr>
           <a:lstStyle/>
           <a:p>
             <a:pPr>
               <a:spcAft>
-                <a:spcPts val="200"/>
+                <a:spcPts val="600"/>
               </a:spcAft>
               <a:defRPr sz="2600">
                 <a:solidFill>
                   <a:srgbClr val="333333"/>
                 </a:solidFill>
               </a:defRPr>
-              <a:buChar char="•"/>
-            </a:pPr>
-            <a:r>
-              <a:t>SFT is the most impactful alignment step -- it sets the model's reasoning baseline</a:t>
+              <a:buNone/>
+            </a:pPr>
+            <a:r>
+              <a:t>•  SFT is the most impactful alignment step -- it sets the model's reasoning baseline</a:t>
             </a:r>
           </a:p>
           <a:p>
             <a:pPr>
               <a:spcAft>
-                <a:spcPts val="200"/>
+                <a:spcPts val="600"/>
               </a:spcAft>
               <a:defRPr sz="2600">
                 <a:solidFill>
                   <a:srgbClr val="333333"/>
                 </a:solidFill>
               </a:defRPr>
-              <a:buChar char="•"/>
-            </a:pPr>
-            <a:r>
-              <a:t>But we do not understand what SFT transfers beyond its training domain</a:t>
+              <a:buNone/>
+            </a:pPr>
+            <a:r>
+              <a:t>•  But we do not understand what SFT transfers beyond its training domain</a:t>
             </a:r>
           </a:p>
         </p:txBody>
@@ -4848,40 +4848,40 @@
           <a:noFill/>
         </p:spPr>
         <p:txBody>
-          <a:bodyPr wrap="square" lIns="320040" tIns="18288">
+          <a:bodyPr wrap="square" lIns="457200">
             <a:spAutoFit/>
           </a:bodyPr>
           <a:lstStyle/>
           <a:p>
             <a:pPr>
               <a:spcAft>
-                <a:spcPts val="200"/>
+                <a:spcPts val="600"/>
               </a:spcAft>
               <a:defRPr sz="2600">
                 <a:solidFill>
                   <a:srgbClr val="333333"/>
                 </a:solidFill>
               </a:defRPr>
-              <a:buChar char="•"/>
-            </a:pPr>
-            <a:r>
-              <a:t>Prior work: LLMs carry ideological priors from pretraining (Kronlund 2024, Lee 2026)</a:t>
+              <a:buNone/>
+            </a:pPr>
+            <a:r>
+              <a:t>•  Prior work: LLMs carry ideological priors from pretraining (Kronlund 2024, Lee 2026)</a:t>
             </a:r>
           </a:p>
           <a:p>
             <a:pPr>
               <a:spcAft>
-                <a:spcPts val="200"/>
+                <a:spcPts val="600"/>
               </a:spcAft>
               <a:defRPr sz="2600">
                 <a:solidFill>
                   <a:srgbClr val="333333"/>
                 </a:solidFill>
               </a:defRPr>
-              <a:buChar char="•"/>
-            </a:pPr>
-            <a:r>
-              <a:t>These studies treat ideology as a static property -- what the model already knows</a:t>
+              <a:buNone/>
+            </a:pPr>
+            <a:r>
+              <a:t>•  These studies treat ideology as a static property -- what the model already knows</a:t>
             </a:r>
           </a:p>
         </p:txBody>
@@ -4947,56 +4947,56 @@
           <a:noFill/>
         </p:spPr>
         <p:txBody>
-          <a:bodyPr wrap="square" lIns="320040" tIns="18288">
+          <a:bodyPr wrap="square" lIns="457200">
             <a:spAutoFit/>
           </a:bodyPr>
           <a:lstStyle/>
           <a:p>
             <a:pPr>
               <a:spcAft>
-                <a:spcPts val="200"/>
+                <a:spcPts val="600"/>
               </a:spcAft>
               <a:defRPr sz="2600">
                 <a:solidFill>
                   <a:srgbClr val="333333"/>
                 </a:solidFill>
               </a:defRPr>
-              <a:buChar char="•"/>
-            </a:pPr>
-            <a:r>
-              <a:t>We ask a dynamic question: can targeted SFT shift a model's reasoning?</a:t>
+              <a:buNone/>
+            </a:pPr>
+            <a:r>
+              <a:t>•  We ask a dynamic question: can targeted SFT shift a model's reasoning?</a:t>
             </a:r>
           </a:p>
           <a:p>
             <a:pPr>
               <a:spcAft>
-                <a:spcPts val="200"/>
+                <a:spcPts val="600"/>
               </a:spcAft>
               <a:defRPr sz="2600">
                 <a:solidFill>
                   <a:srgbClr val="333333"/>
                 </a:solidFill>
               </a:defRPr>
-              <a:buChar char="•"/>
-            </a:pPr>
-            <a:r>
-              <a:t>We train on a non-dominant framework: Dialectical Materialism (DM)</a:t>
+              <a:buNone/>
+            </a:pPr>
+            <a:r>
+              <a:t>•  We train on a non-dominant framework: Dialectical Materialism (DM)</a:t>
             </a:r>
           </a:p>
           <a:p>
             <a:pPr>
               <a:spcAft>
-                <a:spcPts val="200"/>
+                <a:spcPts val="600"/>
               </a:spcAft>
               <a:defRPr sz="2600">
                 <a:solidFill>
                   <a:srgbClr val="333333"/>
                 </a:solidFill>
               </a:defRPr>
-              <a:buChar char="•"/>
-            </a:pPr>
-            <a:r>
-              <a:t>DM emphasizes structural conditions, systemic contradictions, skepticism of simple causality</a:t>
+              <a:buNone/>
+            </a:pPr>
+            <a:r>
+              <a:t>•  DM emphasizes structural conditions, systemic contradictions, skepticism of simple causality</a:t>
             </a:r>
           </a:p>
         </p:txBody>
@@ -5151,88 +5151,88 @@
           <a:noFill/>
         </p:spPr>
         <p:txBody>
-          <a:bodyPr wrap="square" lIns="320040" tIns="18288">
+          <a:bodyPr wrap="square" lIns="457200">
             <a:spAutoFit/>
           </a:bodyPr>
           <a:lstStyle/>
           <a:p>
             <a:pPr>
               <a:spcAft>
-                <a:spcPts val="200"/>
+                <a:spcPts val="600"/>
               </a:spcAft>
               <a:defRPr sz="2200">
                 <a:solidFill>
                   <a:srgbClr val="333333"/>
                 </a:solidFill>
               </a:defRPr>
-              <a:buChar char="•"/>
-            </a:pPr>
-            <a:r>
-              <a:t>Student: Qwen3.5-9B (Instruct variant)</a:t>
+              <a:buNone/>
+            </a:pPr>
+            <a:r>
+              <a:t>•  Student: Qwen3.5-9B (Instruct variant)</a:t>
             </a:r>
           </a:p>
           <a:p>
             <a:pPr>
               <a:spcAft>
-                <a:spcPts val="200"/>
+                <a:spcPts val="600"/>
               </a:spcAft>
               <a:defRPr sz="2200">
                 <a:solidFill>
                   <a:srgbClr val="333333"/>
                 </a:solidFill>
               </a:defRPr>
-              <a:buChar char="•"/>
-            </a:pPr>
-            <a:r>
-              <a:t>Teacher: Qwen3.5-27B (generates DM answers only)</a:t>
+              <a:buNone/>
+            </a:pPr>
+            <a:r>
+              <a:t>•  Teacher: Qwen3.5-27B (generates DM answers only)</a:t>
             </a:r>
           </a:p>
           <a:p>
             <a:pPr>
               <a:spcAft>
-                <a:spcPts val="200"/>
+                <a:spcPts val="600"/>
               </a:spcAft>
               <a:defRPr sz="2200">
                 <a:solidFill>
                   <a:srgbClr val="333333"/>
                 </a:solidFill>
               </a:defRPr>
-              <a:buChar char="•"/>
-            </a:pPr>
-            <a:r>
-              <a:t>QLoRA with NF4 quantization, rank 32, 7 target modules</a:t>
+              <a:buNone/>
+            </a:pPr>
+            <a:r>
+              <a:t>•  QLoRA with NF4 quantization, rank 32, 7 target modules</a:t>
             </a:r>
           </a:p>
           <a:p>
             <a:pPr>
               <a:spcAft>
-                <a:spcPts val="200"/>
+                <a:spcPts val="600"/>
               </a:spcAft>
               <a:defRPr sz="2200">
                 <a:solidFill>
                   <a:srgbClr val="333333"/>
                 </a:solidFill>
               </a:defRPr>
-              <a:buChar char="•"/>
-            </a:pPr>
-            <a:r>
-              <a:t>1,460 DM question-answer pairs, trained 3 epochs</a:t>
+              <a:buNone/>
+            </a:pPr>
+            <a:r>
+              <a:t>•  1,460 DM question-answer pairs, trained 3 epochs</a:t>
             </a:r>
           </a:p>
           <a:p>
             <a:pPr>
               <a:spcAft>
-                <a:spcPts val="200"/>
+                <a:spcPts val="600"/>
               </a:spcAft>
               <a:defRPr sz="2200">
                 <a:solidFill>
                   <a:srgbClr val="333333"/>
                 </a:solidFill>
               </a:defRPr>
-              <a:buChar char="•"/>
-            </a:pPr>
-            <a:r>
-              <a:t>Single NVIDIA RTX 5090 (32 GB VRAM)</a:t>
+              <a:buNone/>
+            </a:pPr>
+            <a:r>
+              <a:t>•  Single NVIDIA RTX 5090 (32 GB VRAM)</a:t>
             </a:r>
           </a:p>
         </p:txBody>
@@ -5289,72 +5289,72 @@
           <a:noFill/>
         </p:spPr>
         <p:txBody>
-          <a:bodyPr wrap="square" lIns="320040" tIns="18288">
+          <a:bodyPr wrap="square" lIns="457200">
             <a:spAutoFit/>
           </a:bodyPr>
           <a:lstStyle/>
           <a:p>
             <a:pPr>
               <a:spcAft>
-                <a:spcPts val="200"/>
+                <a:spcPts val="600"/>
               </a:spcAft>
               <a:defRPr sz="2200">
                 <a:solidFill>
                   <a:srgbClr val="333333"/>
                 </a:solidFill>
               </a:defRPr>
-              <a:buChar char="•"/>
-            </a:pPr>
-            <a:r>
-              <a:t>All benchmarks: bf16 precision, 0-shot greedy decoding</a:t>
+              <a:buNone/>
+            </a:pPr>
+            <a:r>
+              <a:t>•  All benchmarks: bf16 precision, 0-shot greedy decoding</a:t>
             </a:r>
           </a:p>
           <a:p>
             <a:pPr>
               <a:spcAft>
-                <a:spcPts val="200"/>
+                <a:spcPts val="600"/>
               </a:spcAft>
               <a:defRPr sz="2200">
                 <a:solidFill>
                   <a:srgbClr val="333333"/>
                 </a:solidFill>
               </a:defRPr>
-              <a:buChar char="•"/>
-            </a:pPr>
-            <a:r>
-              <a:t>General capability: MMLU, HumanEval, GPQA Diamond</a:t>
+              <a:buNone/>
+            </a:pPr>
+            <a:r>
+              <a:t>•  General capability: MMLU, HumanEval, GPQA Diamond</a:t>
             </a:r>
           </a:p>
           <a:p>
             <a:pPr>
               <a:spcAft>
-                <a:spcPts val="200"/>
+                <a:spcPts val="600"/>
               </a:spcAft>
               <a:defRPr sz="2200">
                 <a:solidFill>
                   <a:srgbClr val="333333"/>
                 </a:solidFill>
               </a:defRPr>
-              <a:buChar char="•"/>
-            </a:pPr>
-            <a:r>
-              <a:t>Formal causal logic: Corr2Cause (1,162 samples)</a:t>
+              <a:buNone/>
+            </a:pPr>
+            <a:r>
+              <a:t>•  Formal causal logic: Corr2Cause (1,162 samples)</a:t>
             </a:r>
           </a:p>
           <a:p>
             <a:pPr>
               <a:spcAft>
-                <a:spcPts val="200"/>
+                <a:spcPts val="600"/>
               </a:spcAft>
               <a:defRPr sz="2200">
                 <a:solidFill>
                   <a:srgbClr val="333333"/>
                 </a:solidFill>
               </a:defRPr>
-              <a:buChar char="•"/>
-            </a:pPr>
-            <a:r>
-              <a:t>Applied causal reasoning: EconCausal (3,943 samples)</a:t>
+              <a:buNone/>
+            </a:pPr>
+            <a:r>
+              <a:t>•  Applied causal reasoning: EconCausal (3,943 samples)</a:t>
             </a:r>
           </a:p>
         </p:txBody>
@@ -5553,72 +5553,72 @@
           <a:noFill/>
         </p:spPr>
         <p:txBody>
-          <a:bodyPr wrap="square" lIns="320040" tIns="18288">
+          <a:bodyPr wrap="square" lIns="457200">
             <a:spAutoFit/>
           </a:bodyPr>
           <a:lstStyle/>
           <a:p>
             <a:pPr>
               <a:spcAft>
-                <a:spcPts val="200"/>
+                <a:spcPts val="600"/>
               </a:spcAft>
               <a:defRPr sz="2000">
                 <a:solidFill>
                   <a:srgbClr val="333333"/>
                 </a:solidFill>
               </a:defRPr>
-              <a:buChar char="•"/>
-            </a:pPr>
-            <a:r>
-              <a:t>MMLU: -0.8pp (within noise)</a:t>
+              <a:buNone/>
+            </a:pPr>
+            <a:r>
+              <a:t>•  MMLU: -0.8pp (within noise)</a:t>
             </a:r>
           </a:p>
           <a:p>
             <a:pPr>
               <a:spcAft>
-                <a:spcPts val="200"/>
+                <a:spcPts val="600"/>
               </a:spcAft>
               <a:defRPr sz="2000">
                 <a:solidFill>
                   <a:srgbClr val="333333"/>
                 </a:solidFill>
               </a:defRPr>
-              <a:buChar char="•"/>
-            </a:pPr>
-            <a:r>
-              <a:t>HumanEval: 0.0pp (identical)</a:t>
+              <a:buNone/>
+            </a:pPr>
+            <a:r>
+              <a:t>•  HumanEval: 0.0pp (identical)</a:t>
             </a:r>
           </a:p>
           <a:p>
             <a:pPr>
               <a:spcAft>
-                <a:spcPts val="200"/>
+                <a:spcPts val="600"/>
               </a:spcAft>
               <a:defRPr sz="2000">
                 <a:solidFill>
                   <a:srgbClr val="333333"/>
                 </a:solidFill>
               </a:defRPr>
-              <a:buChar char="•"/>
-            </a:pPr>
-            <a:r>
-              <a:t>GPQA: -1.5pp (within noise)</a:t>
+              <a:buNone/>
+            </a:pPr>
+            <a:r>
+              <a:t>•  GPQA: -1.5pp (within noise)</a:t>
             </a:r>
           </a:p>
           <a:p>
             <a:pPr>
               <a:spcAft>
-                <a:spcPts val="200"/>
+                <a:spcPts val="600"/>
               </a:spcAft>
               <a:defRPr sz="2000">
                 <a:solidFill>
                   <a:srgbClr val="333333"/>
                 </a:solidFill>
               </a:defRPr>
-              <a:buChar char="•"/>
-            </a:pPr>
-            <a:r>
-              <a:t>No catastrophic forgetting</a:t>
+              <a:buNone/>
+            </a:pPr>
+            <a:r>
+              <a:t>•  No catastrophic forgetting</a:t>
             </a:r>
           </a:p>
         </p:txBody>
@@ -5719,72 +5719,72 @@
           <a:noFill/>
         </p:spPr>
         <p:txBody>
-          <a:bodyPr wrap="square" lIns="320040" tIns="18288">
+          <a:bodyPr wrap="square" lIns="457200">
             <a:spAutoFit/>
           </a:bodyPr>
           <a:lstStyle/>
           <a:p>
             <a:pPr>
               <a:spcAft>
-                <a:spcPts val="200"/>
+                <a:spcPts val="600"/>
               </a:spcAft>
               <a:defRPr sz="2000">
                 <a:solidFill>
                   <a:srgbClr val="333333"/>
                 </a:solidFill>
               </a:defRPr>
-              <a:buChar char="•"/>
-            </a:pPr>
-            <a:r>
-              <a:t>Corr2Cause: 36.3% -&gt; 74.6%</a:t>
+              <a:buNone/>
+            </a:pPr>
+            <a:r>
+              <a:t>•  Corr2Cause: 36.3% -&gt; 74.6%</a:t>
             </a:r>
           </a:p>
           <a:p>
             <a:pPr>
               <a:spcAft>
-                <a:spcPts val="200"/>
+                <a:spcPts val="600"/>
               </a:spcAft>
               <a:defRPr sz="2000">
                 <a:solidFill>
                   <a:srgbClr val="333333"/>
                 </a:solidFill>
               </a:defRPr>
-              <a:buChar char="•"/>
-            </a:pPr>
-            <a:r>
-              <a:t>Corrects 520 baseline errors</a:t>
+              <a:buNone/>
+            </a:pPr>
+            <a:r>
+              <a:t>•  Corrects 520 baseline errors</a:t>
             </a:r>
           </a:p>
           <a:p>
             <a:pPr>
               <a:spcAft>
-                <a:spcPts val="200"/>
+                <a:spcPts val="600"/>
               </a:spcAft>
               <a:defRPr sz="2000">
                 <a:solidFill>
                   <a:srgbClr val="333333"/>
                 </a:solidFill>
               </a:defRPr>
-              <a:buChar char="•"/>
-            </a:pPr>
-            <a:r>
-              <a:t>Only 75 new errors introduced</a:t>
+              <a:buNone/>
+            </a:pPr>
+            <a:r>
+              <a:t>•  Only 75 new errors introduced</a:t>
             </a:r>
           </a:p>
           <a:p>
             <a:pPr>
               <a:spcAft>
-                <a:spcPts val="200"/>
+                <a:spcPts val="600"/>
               </a:spcAft>
               <a:defRPr sz="2000">
                 <a:solidFill>
                   <a:srgbClr val="333333"/>
                 </a:solidFill>
               </a:defRPr>
-              <a:buChar char="•"/>
-            </a:pPr>
-            <a:r>
-              <a:t>Net gain: +445 correct answers</a:t>
+              <a:buNone/>
+            </a:pPr>
+            <a:r>
+              <a:t>•  Net gain: +445 correct answers</a:t>
             </a:r>
           </a:p>
         </p:txBody>
@@ -5885,72 +5885,72 @@
           <a:noFill/>
         </p:spPr>
         <p:txBody>
-          <a:bodyPr wrap="square" lIns="320040" tIns="18288">
+          <a:bodyPr wrap="square" lIns="457200">
             <a:spAutoFit/>
           </a:bodyPr>
           <a:lstStyle/>
           <a:p>
             <a:pPr>
               <a:spcAft>
-                <a:spcPts val="200"/>
+                <a:spcPts val="600"/>
               </a:spcAft>
               <a:defRPr sz="2000">
                 <a:solidFill>
                   <a:srgbClr val="333333"/>
                 </a:solidFill>
               </a:defRPr>
-              <a:buChar char="•"/>
-            </a:pPr>
-            <a:r>
-              <a:t>Task1 Econ: 60.3% -&gt; 47.9%</a:t>
+              <a:buNone/>
+            </a:pPr>
+            <a:r>
+              <a:t>•  Task1 Econ: 60.3% -&gt; 47.9%</a:t>
             </a:r>
           </a:p>
           <a:p>
             <a:pPr>
               <a:spcAft>
-                <a:spcPts val="200"/>
+                <a:spcPts val="600"/>
               </a:spcAft>
               <a:defRPr sz="2000">
                 <a:solidFill>
                   <a:srgbClr val="333333"/>
                 </a:solidFill>
               </a:defRPr>
-              <a:buChar char="•"/>
-            </a:pPr>
-            <a:r>
-              <a:t>Task1 Finance: 56.5% -&gt; 43.0%</a:t>
+              <a:buNone/>
+            </a:pPr>
+            <a:r>
+              <a:t>•  Task1 Finance: 56.5% -&gt; 43.0%</a:t>
             </a:r>
           </a:p>
           <a:p>
             <a:pPr>
               <a:spcAft>
-                <a:spcPts val="200"/>
+                <a:spcPts val="600"/>
               </a:spcAft>
               <a:defRPr sz="2000">
                 <a:solidFill>
                   <a:srgbClr val="333333"/>
                 </a:solidFill>
               </a:defRPr>
-              <a:buChar char="•"/>
-            </a:pPr>
-            <a:r>
-              <a:t>Task3: 22.2% -&gt; 11.4%</a:t>
+              <a:buNone/>
+            </a:pPr>
+            <a:r>
+              <a:t>•  Task3: 22.2% -&gt; 11.4%</a:t>
             </a:r>
           </a:p>
           <a:p>
             <a:pPr>
               <a:spcAft>
-                <a:spcPts val="200"/>
+                <a:spcPts val="600"/>
               </a:spcAft>
               <a:defRPr sz="2000">
                 <a:solidFill>
                   <a:srgbClr val="333333"/>
                 </a:solidFill>
               </a:defRPr>
-              <a:buChar char="•"/>
-            </a:pPr>
-            <a:r>
-              <a:t>All regressions highly significant</a:t>
+              <a:buNone/>
+            </a:pPr>
+            <a:r>
+              <a:t>•  All regressions highly significant</a:t>
             </a:r>
           </a:p>
         </p:txBody>
@@ -6114,72 +6114,72 @@
           <a:noFill/>
         </p:spPr>
         <p:txBody>
-          <a:bodyPr wrap="square" lIns="320040" tIns="18288">
+          <a:bodyPr wrap="square" lIns="457200">
             <a:spAutoFit/>
           </a:bodyPr>
           <a:lstStyle/>
           <a:p>
             <a:pPr>
               <a:spcAft>
-                <a:spcPts val="200"/>
+                <a:spcPts val="600"/>
               </a:spcAft>
               <a:defRPr sz="2400">
                 <a:solidFill>
                   <a:srgbClr val="333333"/>
                 </a:solidFill>
               </a:defRPr>
-              <a:buChar char="•"/>
-            </a:pPr>
-            <a:r>
-              <a:t>Finetuned model converts correct positive predictions (+) to ambiguous "mixed"</a:t>
+              <a:buNone/>
+            </a:pPr>
+            <a:r>
+              <a:t>•  Finetuned model converts correct positive predictions (+) to ambiguous "mixed"</a:t>
             </a:r>
           </a:p>
           <a:p>
             <a:pPr>
               <a:spcAft>
-                <a:spcPts val="200"/>
+                <a:spcPts val="600"/>
               </a:spcAft>
               <a:defRPr sz="2400">
                 <a:solidFill>
                   <a:srgbClr val="333333"/>
                 </a:solidFill>
               </a:defRPr>
-              <a:buChar char="•"/>
-            </a:pPr>
-            <a:r>
-              <a:t>Task1 Econ: 96 of 182 regressions are + to mixed (52.7%)</a:t>
+              <a:buNone/>
+            </a:pPr>
+            <a:r>
+              <a:t>•  Task1 Econ: 96 of 182 regressions are + to mixed (52.7%)</a:t>
             </a:r>
           </a:p>
           <a:p>
             <a:pPr>
               <a:spcAft>
-                <a:spcPts val="200"/>
+                <a:spcPts val="600"/>
               </a:spcAft>
               <a:defRPr sz="2400">
                 <a:solidFill>
                   <a:srgbClr val="333333"/>
                 </a:solidFill>
               </a:defRPr>
-              <a:buChar char="•"/>
-            </a:pPr>
-            <a:r>
-              <a:t>Task1 Finance: 95 of 174 (54.6%)</a:t>
+              <a:buNone/>
+            </a:pPr>
+            <a:r>
+              <a:t>•  Task1 Finance: 95 of 174 (54.6%)</a:t>
             </a:r>
           </a:p>
           <a:p>
             <a:pPr>
               <a:spcAft>
-                <a:spcPts val="200"/>
+                <a:spcPts val="600"/>
               </a:spcAft>
               <a:defRPr sz="2400">
                 <a:solidFill>
                   <a:srgbClr val="333333"/>
                 </a:solidFill>
               </a:defRPr>
-              <a:buChar char="•"/>
-            </a:pPr>
-            <a:r>
-              <a:t>Positive-effect conversion accounts for 77-85% of all Task1 regressions</a:t>
+              <a:buNone/>
+            </a:pPr>
+            <a:r>
+              <a:t>•  Positive-effect conversion accounts for 77-85% of all Task1 regressions</a:t>
             </a:r>
           </a:p>
         </p:txBody>
@@ -6280,72 +6280,72 @@
           <a:noFill/>
         </p:spPr>
         <p:txBody>
-          <a:bodyPr wrap="square" lIns="320040" tIns="18288">
+          <a:bodyPr wrap="square" lIns="457200">
             <a:spAutoFit/>
           </a:bodyPr>
           <a:lstStyle/>
           <a:p>
             <a:pPr>
               <a:spcAft>
-                <a:spcPts val="200"/>
+                <a:spcPts val="600"/>
               </a:spcAft>
               <a:defRPr sz="2400">
                 <a:solidFill>
                   <a:srgbClr val="333333"/>
                 </a:solidFill>
               </a:defRPr>
-              <a:buChar char="•"/>
-            </a:pPr>
-            <a:r>
-              <a:t>Hedging is ABSENT from training data -- teacher hedges only 4.0% of the time</a:t>
+              <a:buNone/>
+            </a:pPr>
+            <a:r>
+              <a:t>•  Hedging is ABSENT from training data -- teacher hedges only 4.0% of the time</a:t>
             </a:r>
           </a:p>
           <a:p>
             <a:pPr>
               <a:spcAft>
-                <a:spcPts val="200"/>
+                <a:spcPts val="600"/>
               </a:spcAft>
               <a:defRPr sz="2400">
                 <a:solidFill>
                   <a:srgbClr val="333333"/>
                 </a:solidFill>
               </a:defRPr>
-              <a:buChar char="•"/>
-            </a:pPr>
-            <a:r>
-              <a:t>Model internalizes DM principles: "outcomes depend on material conditions"</a:t>
+              <a:buNone/>
+            </a:pPr>
+            <a:r>
+              <a:t>•  Model internalizes DM principles: "outcomes depend on material conditions"</a:t>
             </a:r>
           </a:p>
           <a:p>
             <a:pPr>
               <a:spcAft>
-                <a:spcPts val="200"/>
+                <a:spcPts val="600"/>
               </a:spcAft>
               <a:defRPr sz="2400">
                 <a:solidFill>
                   <a:srgbClr val="333333"/>
                 </a:solidFill>
               </a:defRPr>
-              <a:buChar char="•"/>
-            </a:pPr>
-            <a:r>
-              <a:t>It then applies this skepticism indiscriminately -- even where definitive answers exist</a:t>
+              <a:buNone/>
+            </a:pPr>
+            <a:r>
+              <a:t>•  It then applies this skepticism indiscriminately -- even where definitive answers exist</a:t>
             </a:r>
           </a:p>
           <a:p>
             <a:pPr>
               <a:spcAft>
-                <a:spcPts val="200"/>
+                <a:spcPts val="600"/>
               </a:spcAft>
               <a:defRPr sz="2400">
                 <a:solidFill>
                   <a:srgbClr val="333333"/>
                 </a:solidFill>
               </a:defRPr>
-              <a:buChar char="•"/>
-            </a:pPr>
-            <a:r>
-              <a:t>This is not a reasoning error. It is a transferred epistemic prior.</a:t>
+              <a:buNone/>
+            </a:pPr>
+            <a:r>
+              <a:t>•  This is not a reasoning error. It is a transferred epistemic prior.</a:t>
             </a:r>
           </a:p>
         </p:txBody>
@@ -6500,72 +6500,72 @@
           <a:noFill/>
         </p:spPr>
         <p:txBody>
-          <a:bodyPr wrap="square" lIns="320040" tIns="18288">
+          <a:bodyPr wrap="square" lIns="457200">
             <a:spAutoFit/>
           </a:bodyPr>
           <a:lstStyle/>
           <a:p>
             <a:pPr>
               <a:spcAft>
-                <a:spcPts val="200"/>
+                <a:spcPts val="600"/>
               </a:spcAft>
               <a:defRPr sz="2200">
                 <a:solidFill>
                   <a:srgbClr val="333333"/>
                 </a:solidFill>
               </a:defRPr>
-              <a:buChar char="•"/>
-            </a:pPr>
-            <a:r>
-              <a:t>DM training strengthens structural reasoning: trace dependencies, find confounders</a:t>
+              <a:buNone/>
+            </a:pPr>
+            <a:r>
+              <a:t>•  DM training strengthens structural reasoning: trace dependencies, find confounders</a:t>
             </a:r>
           </a:p>
           <a:p>
             <a:pPr>
               <a:spcAft>
-                <a:spcPts val="200"/>
+                <a:spcPts val="600"/>
               </a:spcAft>
               <a:defRPr sz="2200">
                 <a:solidFill>
                   <a:srgbClr val="333333"/>
                 </a:solidFill>
               </a:defRPr>
-              <a:buChar char="•"/>
-            </a:pPr>
-            <a:r>
-              <a:t>Non-child descendant: 13.0% -&gt; 94.3% (+81.3pp)</a:t>
+              <a:buNone/>
+            </a:pPr>
+            <a:r>
+              <a:t>•  Non-child descendant: 13.0% -&gt; 94.3% (+81.3pp)</a:t>
             </a:r>
           </a:p>
           <a:p>
             <a:pPr>
               <a:spcAft>
-                <a:spcPts val="200"/>
+                <a:spcPts val="600"/>
               </a:spcAft>
               <a:defRPr sz="2200">
                 <a:solidFill>
                   <a:srgbClr val="333333"/>
                 </a:solidFill>
               </a:defRPr>
-              <a:buChar char="•"/>
-            </a:pPr>
-            <a:r>
-              <a:t>Non-parent ancestor: 14.4% -&gt; 87.2% (+72.8pp)</a:t>
+              <a:buNone/>
+            </a:pPr>
+            <a:r>
+              <a:t>•  Non-parent ancestor: 14.4% -&gt; 87.2% (+72.8pp)</a:t>
             </a:r>
           </a:p>
           <a:p>
             <a:pPr>
               <a:spcAft>
-                <a:spcPts val="200"/>
+                <a:spcPts val="600"/>
               </a:spcAft>
               <a:defRPr sz="2200">
                 <a:solidFill>
                   <a:srgbClr val="333333"/>
                 </a:solidFill>
               </a:defRPr>
-              <a:buChar char="•"/>
-            </a:pPr>
-            <a:r>
-              <a:t>Largest gains on the most structurally complex templates</a:t>
+              <a:buNone/>
+            </a:pPr>
+            <a:r>
+              <a:t>•  Largest gains on the most structurally complex templates</a:t>
             </a:r>
           </a:p>
         </p:txBody>
@@ -6657,72 +6657,72 @@
           <a:noFill/>
         </p:spPr>
         <p:txBody>
-          <a:bodyPr wrap="square" lIns="320040" tIns="18288">
+          <a:bodyPr wrap="square" lIns="457200">
             <a:spAutoFit/>
           </a:bodyPr>
           <a:lstStyle/>
           <a:p>
             <a:pPr>
               <a:spcAft>
-                <a:spcPts val="200"/>
+                <a:spcPts val="600"/>
               </a:spcAft>
               <a:defRPr sz="2200">
                 <a:solidFill>
                   <a:srgbClr val="333333"/>
                 </a:solidFill>
               </a:defRPr>
-              <a:buChar char="•"/>
-            </a:pPr>
-            <a:r>
-              <a:t>DM skepticism prior overrides empirical directional claims</a:t>
+              <a:buNone/>
+            </a:pPr>
+            <a:r>
+              <a:t>•  DM skepticism prior overrides empirical directional claims</a:t>
             </a:r>
           </a:p>
           <a:p>
             <a:pPr>
               <a:spcAft>
-                <a:spcPts val="200"/>
+                <a:spcPts val="600"/>
               </a:spcAft>
               <a:defRPr sz="2200">
                 <a:solidFill>
                   <a:srgbClr val="333333"/>
                 </a:solidFill>
               </a:defRPr>
-              <a:buChar char="•"/>
-            </a:pPr>
-            <a:r>
-              <a:t>Model learned "everything depends on structural conditions"</a:t>
+              <a:buNone/>
+            </a:pPr>
+            <a:r>
+              <a:t>•  Model learned "everything depends on structural conditions"</a:t>
             </a:r>
           </a:p>
           <a:p>
             <a:pPr>
               <a:spcAft>
-                <a:spcPts val="200"/>
+                <a:spcPts val="600"/>
               </a:spcAft>
               <a:defRPr sz="2200">
                 <a:solidFill>
                   <a:srgbClr val="333333"/>
                 </a:solidFill>
               </a:defRPr>
-              <a:buChar char="•"/>
-            </a:pPr>
-            <a:r>
-              <a:t>Applies this heuristic where the correct answer is a definitive + or -</a:t>
+              <a:buNone/>
+            </a:pPr>
+            <a:r>
+              <a:t>•  Applies this heuristic where the correct answer is a definitive + or -</a:t>
             </a:r>
           </a:p>
           <a:p>
             <a:pPr>
               <a:spcAft>
-                <a:spcPts val="200"/>
+                <a:spcPts val="600"/>
               </a:spcAft>
               <a:defRPr sz="2200">
                 <a:solidFill>
                   <a:srgbClr val="333333"/>
                 </a:solidFill>
               </a:defRPr>
-              <a:buChar char="•"/>
-            </a:pPr>
-            <a:r>
-              <a:t>Result: systematic under-prediction of positive effects</a:t>
+              <a:buNone/>
+            </a:pPr>
+            <a:r>
+              <a:t>•  Result: systematic under-prediction of positive effects</a:t>
             </a:r>
           </a:p>
         </p:txBody>
@@ -6921,40 +6921,40 @@
           <a:noFill/>
         </p:spPr>
         <p:txBody>
-          <a:bodyPr wrap="square" lIns="320040" tIns="18288">
+          <a:bodyPr wrap="square" lIns="457200">
             <a:spAutoFit/>
           </a:bodyPr>
           <a:lstStyle/>
           <a:p>
             <a:pPr>
               <a:spcAft>
-                <a:spcPts val="200"/>
+                <a:spcPts val="600"/>
               </a:spcAft>
               <a:defRPr sz="2200">
                 <a:solidFill>
                   <a:srgbClr val="333333"/>
                 </a:solidFill>
               </a:defRPr>
-              <a:buChar char="•"/>
-            </a:pPr>
-            <a:r>
-              <a:t>Hedging artifact absent from training data, emerges from internalized framework</a:t>
+              <a:buNone/>
+            </a:pPr>
+            <a:r>
+              <a:t>•  Hedging artifact absent from training data, emerges from internalized framework</a:t>
             </a:r>
           </a:p>
           <a:p>
             <a:pPr>
               <a:spcAft>
-                <a:spcPts val="200"/>
+                <a:spcPts val="600"/>
               </a:spcAft>
               <a:defRPr sz="2200">
                 <a:solidFill>
                   <a:srgbClr val="333333"/>
                 </a:solidFill>
               </a:defRPr>
-              <a:buChar char="•"/>
-            </a:pPr>
-            <a:r>
-              <a:t>Shift operates at level of reasoning heuristics, not response patterns</a:t>
+              <a:buNone/>
+            </a:pPr>
+            <a:r>
+              <a:t>•  Shift operates at level of reasoning heuristics, not response patterns</a:t>
             </a:r>
           </a:p>
         </p:txBody>
@@ -7011,40 +7011,40 @@
           <a:noFill/>
         </p:spPr>
         <p:txBody>
-          <a:bodyPr wrap="square" lIns="320040" tIns="18288">
+          <a:bodyPr wrap="square" lIns="457200">
             <a:spAutoFit/>
           </a:bodyPr>
           <a:lstStyle/>
           <a:p>
             <a:pPr>
               <a:spcAft>
-                <a:spcPts val="200"/>
+                <a:spcPts val="600"/>
               </a:spcAft>
               <a:defRPr sz="2200">
                 <a:solidFill>
                   <a:srgbClr val="333333"/>
                 </a:solidFill>
               </a:defRPr>
-              <a:buChar char="•"/>
-            </a:pPr>
-            <a:r>
-              <a:t>If DM training produces detectable transfer, RLHF likely does too</a:t>
+              <a:buNone/>
+            </a:pPr>
+            <a:r>
+              <a:t>•  If DM training produces detectable transfer, RLHF likely does too</a:t>
             </a:r>
           </a:p>
           <a:p>
             <a:pPr>
               <a:spcAft>
-                <a:spcPts val="200"/>
+                <a:spcPts val="600"/>
               </a:spcAft>
               <a:defRPr sz="2200">
                 <a:solidFill>
                   <a:srgbClr val="333333"/>
                 </a:solidFill>
               </a:defRPr>
-              <a:buChar char="•"/>
-            </a:pPr>
-            <a:r>
-              <a:t>Helpfulness training may transfer deference to authority, controversy avoidance</a:t>
+              <a:buNone/>
+            </a:pPr>
+            <a:r>
+              <a:t>•  Helpfulness training may transfer deference to authority, controversy avoidance</a:t>
             </a:r>
           </a:p>
         </p:txBody>
@@ -7101,40 +7101,40 @@
           <a:noFill/>
         </p:spPr>
         <p:txBody>
-          <a:bodyPr wrap="square" lIns="320040" tIns="18288">
+          <a:bodyPr wrap="square" lIns="457200">
             <a:spAutoFit/>
           </a:bodyPr>
           <a:lstStyle/>
           <a:p>
             <a:pPr>
               <a:spcAft>
-                <a:spcPts val="200"/>
+                <a:spcPts val="600"/>
               </a:spcAft>
               <a:defRPr sz="2200">
                 <a:solidFill>
                   <a:srgbClr val="333333"/>
                 </a:solidFill>
               </a:defRPr>
-              <a:buChar char="•"/>
-            </a:pPr>
-            <a:r>
-              <a:t>Intervention improves formal logic but impairs applied identification?</a:t>
+              <a:buNone/>
+            </a:pPr>
+            <a:r>
+              <a:t>•  Intervention improves formal logic but impairs applied identification?</a:t>
             </a:r>
           </a:p>
           <a:p>
             <a:pPr>
               <a:spcAft>
-                <a:spcPts val="200"/>
+                <a:spcPts val="600"/>
               </a:spcAft>
               <a:defRPr sz="2200">
                 <a:solidFill>
                   <a:srgbClr val="333333"/>
                 </a:solidFill>
               </a:defRPr>
-              <a:buChar char="•"/>
-            </a:pPr>
-            <a:r>
-              <a:t>Signal of over-generalized structural skepticism</a:t>
+              <a:buNone/>
+            </a:pPr>
+            <a:r>
+              <a:t>•  Signal of over-generalized structural skepticism</a:t>
             </a:r>
           </a:p>
         </p:txBody>
@@ -7219,120 +7219,120 @@
           <a:noFill/>
         </p:spPr>
         <p:txBody>
-          <a:bodyPr wrap="square" lIns="320040" tIns="18288">
+          <a:bodyPr wrap="square" lIns="457200">
             <a:spAutoFit/>
           </a:bodyPr>
           <a:lstStyle/>
           <a:p>
             <a:pPr>
               <a:spcAft>
-                <a:spcPts val="200"/>
+                <a:spcPts val="600"/>
               </a:spcAft>
               <a:defRPr sz="2600">
                 <a:solidFill>
                   <a:srgbClr val="333333"/>
                 </a:solidFill>
               </a:defRPr>
-              <a:buChar char="•"/>
-            </a:pPr>
-            <a:r>
-              <a:t>Fine-tuned Qwen3.5-9B on 1,460 DM-aligned Q&amp;A pairs via QLoRA</a:t>
+              <a:buNone/>
+            </a:pPr>
+            <a:r>
+              <a:t>•  Fine-tuned Qwen3.5-9B on 1,460 DM-aligned Q&amp;A pairs via QLoRA</a:t>
             </a:r>
           </a:p>
           <a:p>
             <a:pPr>
               <a:spcAft>
-                <a:spcPts val="200"/>
+                <a:spcPts val="600"/>
               </a:spcAft>
               <a:defRPr sz="2600">
                 <a:solidFill>
                   <a:srgbClr val="333333"/>
                 </a:solidFill>
               </a:defRPr>
-              <a:buChar char="•"/>
-            </a:pPr>
-            <a:r>
-              <a:t>General capability preserved: MMLU -0.8pp, HumanEval unchanged at 70.7%</a:t>
+              <a:buNone/>
+            </a:pPr>
+            <a:r>
+              <a:t>•  General capability preserved: MMLU -0.8pp, HumanEval unchanged at 70.7%</a:t>
             </a:r>
           </a:p>
           <a:p>
             <a:pPr>
               <a:spcAft>
-                <a:spcPts val="200"/>
+                <a:spcPts val="600"/>
               </a:spcAft>
               <a:defRPr sz="2600">
                 <a:solidFill>
                   <a:srgbClr val="333333"/>
                 </a:solidFill>
               </a:defRPr>
-              <a:buChar char="•"/>
-            </a:pPr>
-            <a:r>
-              <a:t>Formal causal reasoning improved dramatically: Corr2Cause +38.3pp</a:t>
+              <a:buNone/>
+            </a:pPr>
+            <a:r>
+              <a:t>•  Formal causal reasoning improved dramatically: Corr2Cause +38.3pp</a:t>
             </a:r>
           </a:p>
           <a:p>
             <a:pPr>
               <a:spcAft>
-                <a:spcPts val="200"/>
+                <a:spcPts val="600"/>
               </a:spcAft>
               <a:defRPr sz="2600">
                 <a:solidFill>
                   <a:srgbClr val="333333"/>
                 </a:solidFill>
               </a:defRPr>
-              <a:buChar char="•"/>
-            </a:pPr>
-            <a:r>
-              <a:t>Applied causal reasoning regressed: EconCausal -12.4pp to -13.5pp</a:t>
+              <a:buNone/>
+            </a:pPr>
+            <a:r>
+              <a:t>•  Applied causal reasoning regressed: EconCausal -12.4pp to -13.5pp</a:t>
             </a:r>
           </a:p>
           <a:p>
             <a:pPr>
               <a:spcAft>
-                <a:spcPts val="200"/>
+                <a:spcPts val="600"/>
               </a:spcAft>
               <a:defRPr sz="2600">
                 <a:solidFill>
                   <a:srgbClr val="333333"/>
                 </a:solidFill>
               </a:defRPr>
-              <a:buChar char="•"/>
-            </a:pPr>
-            <a:r>
-              <a:t>Regression from single emergent artifact: positive-to-mixed hedging bias</a:t>
+              <a:buNone/>
+            </a:pPr>
+            <a:r>
+              <a:t>•  Regression from single emergent artifact: positive-to-mixed hedging bias</a:t>
             </a:r>
           </a:p>
           <a:p>
             <a:pPr>
               <a:spcAft>
-                <a:spcPts val="200"/>
+                <a:spcPts val="600"/>
               </a:spcAft>
               <a:defRPr sz="2600">
                 <a:solidFill>
                   <a:srgbClr val="333333"/>
                 </a:solidFill>
               </a:defRPr>
-              <a:buChar char="•"/>
-            </a:pPr>
-            <a:r>
-              <a:t>Hedging absent from training data -- a transferred epistemic prior</a:t>
+              <a:buNone/>
+            </a:pPr>
+            <a:r>
+              <a:t>•  Hedging absent from training data -- a transferred epistemic prior</a:t>
             </a:r>
           </a:p>
           <a:p>
             <a:pPr>
               <a:spcAft>
-                <a:spcPts val="200"/>
+                <a:spcPts val="600"/>
               </a:spcAft>
               <a:defRPr sz="2600">
                 <a:solidFill>
                   <a:srgbClr val="333333"/>
                 </a:solidFill>
               </a:defRPr>
-              <a:buChar char="•"/>
-            </a:pPr>
-            <a:r>
-              <a:t>Conclusion: SFT transfers reasoning priors, not just behavioral patterns</a:t>
+              <a:buNone/>
+            </a:pPr>
+            <a:r>
+              <a:t>•  Conclusion: SFT transfers reasoning priors, not just behavioral patterns</a:t>
             </a:r>
           </a:p>
         </p:txBody>

</xml_diff>

<commit_message>
Fix accent line cutting through text, move glossary to footer
</commit_message>
<xml_diff>
--- a/paper/iclr2026/iclr2026_spotlight.pptx
+++ b/paper/iclr2026/iclr2026_spotlight.pptx
@@ -4642,7 +4642,7 @@
         </p:nvSpPr>
         <p:spPr>
           <a:xfrm>
-            <a:off x="731520" y="2913125"/>
+            <a:off x="731520" y="3004566"/>
             <a:ext cx="10698480" cy="36576"/>
           </a:xfrm>
           <a:prstGeom prst="rect">
@@ -4686,7 +4686,7 @@
         </p:nvSpPr>
         <p:spPr>
           <a:xfrm>
-            <a:off x="731520" y="3141725"/>
+            <a:off x="731520" y="3278885"/>
             <a:ext cx="10698480" cy="1042924"/>
           </a:xfrm>
           <a:prstGeom prst="rect">
@@ -4741,7 +4741,7 @@
         </p:nvSpPr>
         <p:spPr>
           <a:xfrm>
-            <a:off x="731520" y="4367530"/>
+            <a:off x="731520" y="6217920"/>
             <a:ext cx="10698480" cy="365760"/>
           </a:xfrm>
           <a:prstGeom prst="rect">
@@ -4894,7 +4894,7 @@
         </p:nvSpPr>
         <p:spPr>
           <a:xfrm>
-            <a:off x="731520" y="2460244"/>
+            <a:off x="731520" y="2551684"/>
             <a:ext cx="10698480" cy="36576"/>
           </a:xfrm>
           <a:prstGeom prst="rect">
@@ -4938,7 +4938,7 @@
         </p:nvSpPr>
         <p:spPr>
           <a:xfrm>
-            <a:off x="731520" y="2688844"/>
+            <a:off x="731520" y="2826004"/>
             <a:ext cx="10698480" cy="1495806"/>
           </a:xfrm>
           <a:prstGeom prst="rect">
@@ -5009,7 +5009,7 @@
         </p:nvSpPr>
         <p:spPr>
           <a:xfrm>
-            <a:off x="731520" y="4367530"/>
+            <a:off x="731520" y="6217920"/>
             <a:ext cx="10698480" cy="365760"/>
           </a:xfrm>
           <a:prstGeom prst="rect">
@@ -5367,7 +5367,7 @@
         </p:nvSpPr>
         <p:spPr>
           <a:xfrm>
-            <a:off x="731520" y="5486400"/>
+            <a:off x="731520" y="6217920"/>
             <a:ext cx="10698480" cy="365760"/>
           </a:xfrm>
           <a:prstGeom prst="rect">

</xml_diff>

<commit_message>
Fix accent lines cutting through text: add space_after to height calc, increase buffers
</commit_message>
<xml_diff>
--- a/paper/iclr2026/iclr2026_spotlight.pptx
+++ b/paper/iclr2026/iclr2026_spotlight.pptx
@@ -4572,7 +4572,7 @@
         <p:spPr>
           <a:xfrm>
             <a:off x="731520" y="1143000"/>
-            <a:ext cx="10698480" cy="1495806"/>
+            <a:ext cx="10698480" cy="1723491"/>
           </a:xfrm>
           <a:prstGeom prst="rect">
             <a:avLst/>
@@ -4642,7 +4642,7 @@
         </p:nvSpPr>
         <p:spPr>
           <a:xfrm>
-            <a:off x="731520" y="3004566"/>
+            <a:off x="731520" y="3323691"/>
             <a:ext cx="10698480" cy="36576"/>
           </a:xfrm>
           <a:prstGeom prst="rect">
@@ -4686,8 +4686,8 @@
         </p:nvSpPr>
         <p:spPr>
           <a:xfrm>
-            <a:off x="731520" y="3278885"/>
-            <a:ext cx="10698480" cy="1042924"/>
+            <a:off x="731520" y="3643731"/>
+            <a:ext cx="10698480" cy="1194714"/>
           </a:xfrm>
           <a:prstGeom prst="rect">
             <a:avLst/>
@@ -4840,7 +4840,7 @@
         <p:spPr>
           <a:xfrm>
             <a:off x="731520" y="1143000"/>
-            <a:ext cx="10698480" cy="1042924"/>
+            <a:ext cx="10698480" cy="1194714"/>
           </a:xfrm>
           <a:prstGeom prst="rect">
             <a:avLst/>
@@ -4894,7 +4894,7 @@
         </p:nvSpPr>
         <p:spPr>
           <a:xfrm>
-            <a:off x="731520" y="2551684"/>
+            <a:off x="731520" y="2794914"/>
             <a:ext cx="10698480" cy="36576"/>
           </a:xfrm>
           <a:prstGeom prst="rect">
@@ -4938,8 +4938,8 @@
         </p:nvSpPr>
         <p:spPr>
           <a:xfrm>
-            <a:off x="731520" y="2826004"/>
-            <a:ext cx="10698480" cy="1495806"/>
+            <a:off x="731520" y="3114954"/>
+            <a:ext cx="10698480" cy="1723491"/>
           </a:xfrm>
           <a:prstGeom prst="rect">
             <a:avLst/>
@@ -5143,7 +5143,7 @@
         <p:spPr>
           <a:xfrm>
             <a:off x="731520" y="1508760"/>
-            <a:ext cx="5029200" cy="2109470"/>
+            <a:ext cx="5029200" cy="2488946"/>
           </a:xfrm>
           <a:prstGeom prst="rect">
             <a:avLst/>
@@ -5281,7 +5281,7 @@
         <p:spPr>
           <a:xfrm>
             <a:off x="6400800" y="1508760"/>
-            <a:ext cx="5029200" cy="1715008"/>
+            <a:ext cx="5029200" cy="2018588"/>
           </a:xfrm>
           <a:prstGeom prst="rect">
             <a:avLst/>
@@ -5545,7 +5545,7 @@
         <p:spPr>
           <a:xfrm>
             <a:off x="640080" y="1691640"/>
-            <a:ext cx="2926080" cy="1598168"/>
+            <a:ext cx="2926080" cy="1901748"/>
           </a:xfrm>
           <a:prstGeom prst="rect">
             <a:avLst/>
@@ -5711,7 +5711,7 @@
         <p:spPr>
           <a:xfrm>
             <a:off x="4251959" y="1691640"/>
-            <a:ext cx="2926080" cy="1598168"/>
+            <a:ext cx="2926080" cy="1901748"/>
           </a:xfrm>
           <a:prstGeom prst="rect">
             <a:avLst/>
@@ -5877,7 +5877,7 @@
         <p:spPr>
           <a:xfrm>
             <a:off x="7863840" y="1691640"/>
-            <a:ext cx="2926080" cy="1598168"/>
+            <a:ext cx="2926080" cy="1901748"/>
           </a:xfrm>
           <a:prstGeom prst="rect">
             <a:avLst/>
@@ -6106,7 +6106,7 @@
         <p:spPr>
           <a:xfrm>
             <a:off x="731520" y="1737360"/>
-            <a:ext cx="10698480" cy="1831848"/>
+            <a:ext cx="10698480" cy="2135428"/>
           </a:xfrm>
           <a:prstGeom prst="rect">
             <a:avLst/>
@@ -6192,7 +6192,7 @@
         </p:nvSpPr>
         <p:spPr>
           <a:xfrm>
-            <a:off x="731520" y="3843528"/>
+            <a:off x="731520" y="4147108"/>
             <a:ext cx="10698480" cy="36576"/>
           </a:xfrm>
           <a:prstGeom prst="rect">
@@ -6236,7 +6236,7 @@
         </p:nvSpPr>
         <p:spPr>
           <a:xfrm>
-            <a:off x="731520" y="3980688"/>
+            <a:off x="731520" y="4284268"/>
             <a:ext cx="10698480" cy="365760"/>
           </a:xfrm>
           <a:prstGeom prst="rect">
@@ -6271,8 +6271,8 @@
         </p:nvSpPr>
         <p:spPr>
           <a:xfrm>
-            <a:off x="731520" y="4437888"/>
-            <a:ext cx="10698480" cy="1831848"/>
+            <a:off x="731520" y="4741468"/>
+            <a:ext cx="10698480" cy="2135428"/>
           </a:xfrm>
           <a:prstGeom prst="rect">
             <a:avLst/>
@@ -6492,7 +6492,7 @@
         <p:spPr>
           <a:xfrm>
             <a:off x="731520" y="1874519"/>
-            <a:ext cx="5029200" cy="2109470"/>
+            <a:ext cx="5029200" cy="2413050"/>
           </a:xfrm>
           <a:prstGeom prst="rect">
             <a:avLst/>
@@ -6649,7 +6649,7 @@
         <p:spPr>
           <a:xfrm>
             <a:off x="6400800" y="1920240"/>
-            <a:ext cx="5029200" cy="1715008"/>
+            <a:ext cx="5029200" cy="2018588"/>
           </a:xfrm>
           <a:prstGeom prst="rect">
             <a:avLst/>
@@ -6735,7 +6735,7 @@
         </p:nvSpPr>
         <p:spPr>
           <a:xfrm>
-            <a:off x="731520" y="5029200"/>
+            <a:off x="731520" y="5212080"/>
             <a:ext cx="10698480" cy="36576"/>
           </a:xfrm>
           <a:prstGeom prst="rect">
@@ -6779,7 +6779,7 @@
         </p:nvSpPr>
         <p:spPr>
           <a:xfrm>
-            <a:off x="731520" y="5166360"/>
+            <a:off x="731520" y="5349240"/>
             <a:ext cx="10698480" cy="914400"/>
           </a:xfrm>
           <a:prstGeom prst="rect">
@@ -6913,7 +6913,7 @@
         <p:spPr>
           <a:xfrm>
             <a:off x="731520" y="1600200"/>
-            <a:ext cx="10698480" cy="926084"/>
+            <a:ext cx="10698480" cy="1077874"/>
           </a:xfrm>
           <a:prstGeom prst="rect">
             <a:avLst/>
@@ -6967,7 +6967,7 @@
         </p:nvSpPr>
         <p:spPr>
           <a:xfrm>
-            <a:off x="731520" y="2846324"/>
+            <a:off x="731520" y="2998114"/>
             <a:ext cx="10698480" cy="365760"/>
           </a:xfrm>
           <a:prstGeom prst="rect">
@@ -7002,8 +7002,8 @@
         </p:nvSpPr>
         <p:spPr>
           <a:xfrm>
-            <a:off x="731520" y="3303524"/>
-            <a:ext cx="10698480" cy="926084"/>
+            <a:off x="731520" y="3455314"/>
+            <a:ext cx="10698480" cy="1077874"/>
           </a:xfrm>
           <a:prstGeom prst="rect">
             <a:avLst/>
@@ -7057,7 +7057,7 @@
         </p:nvSpPr>
         <p:spPr>
           <a:xfrm>
-            <a:off x="731520" y="4549648"/>
+            <a:off x="731520" y="4853228"/>
             <a:ext cx="10698480" cy="365760"/>
           </a:xfrm>
           <a:prstGeom prst="rect">
@@ -7092,8 +7092,8 @@
         </p:nvSpPr>
         <p:spPr>
           <a:xfrm>
-            <a:off x="731520" y="5006848"/>
-            <a:ext cx="10698480" cy="926084"/>
+            <a:off x="731520" y="5310428"/>
+            <a:ext cx="10698480" cy="1077874"/>
           </a:xfrm>
           <a:prstGeom prst="rect">
             <a:avLst/>
@@ -7211,7 +7211,7 @@
         <p:spPr>
           <a:xfrm>
             <a:off x="731520" y="1143000"/>
-            <a:ext cx="10698480" cy="3307333"/>
+            <a:ext cx="10698480" cy="3838600"/>
           </a:xfrm>
           <a:prstGeom prst="rect">
             <a:avLst/>

</xml_diff>

<commit_message>
Shift accent lines down 10px globally
</commit_message>
<xml_diff>
--- a/paper/iclr2026/iclr2026_spotlight.pptx
+++ b/paper/iclr2026/iclr2026_spotlight.pptx
@@ -4642,7 +4642,7 @@
         </p:nvSpPr>
         <p:spPr>
           <a:xfrm>
-            <a:off x="731520" y="3323691"/>
+            <a:off x="731520" y="3451707"/>
             <a:ext cx="10698480" cy="36576"/>
           </a:xfrm>
           <a:prstGeom prst="rect">
@@ -4894,7 +4894,7 @@
         </p:nvSpPr>
         <p:spPr>
           <a:xfrm>
-            <a:off x="731520" y="2794914"/>
+            <a:off x="731520" y="2922930"/>
             <a:ext cx="10698480" cy="36576"/>
           </a:xfrm>
           <a:prstGeom prst="rect">
@@ -6026,7 +6026,7 @@
         </p:nvSpPr>
         <p:spPr>
           <a:xfrm>
-            <a:off x="731520" y="1143000"/>
+            <a:off x="731520" y="1271016"/>
             <a:ext cx="10698480" cy="36576"/>
           </a:xfrm>
           <a:prstGeom prst="rect">
@@ -6192,7 +6192,7 @@
         </p:nvSpPr>
         <p:spPr>
           <a:xfrm>
-            <a:off x="731520" y="4147108"/>
+            <a:off x="731520" y="4275124"/>
             <a:ext cx="10698480" cy="36576"/>
           </a:xfrm>
           <a:prstGeom prst="rect">
@@ -6735,7 +6735,7 @@
         </p:nvSpPr>
         <p:spPr>
           <a:xfrm>
-            <a:off x="731520" y="5212080"/>
+            <a:off x="731520" y="5340096"/>
             <a:ext cx="10698480" cy="36576"/>
           </a:xfrm>
           <a:prstGeom prst="rect">

</xml_diff>